<commit_message>
Completing all but 2 slides of the presentation
</commit_message>
<xml_diff>
--- a/presentation.pptx
+++ b/presentation.pptx
@@ -21,9 +21,9 @@
     <p:sldId id="796" r:id="rId9"/>
     <p:sldId id="795" r:id="rId10"/>
     <p:sldId id="798" r:id="rId11"/>
-    <p:sldId id="799" r:id="rId12"/>
-    <p:sldId id="800" r:id="rId13"/>
-    <p:sldId id="801" r:id="rId14"/>
+    <p:sldId id="807" r:id="rId12"/>
+    <p:sldId id="799" r:id="rId13"/>
+    <p:sldId id="800" r:id="rId14"/>
     <p:sldId id="804" r:id="rId15"/>
     <p:sldId id="727" r:id="rId16"/>
     <p:sldId id="805" r:id="rId17"/>
@@ -278,7 +278,7 @@
           <a:p>
             <a:fld id="{4E9DBEC1-03D6-8C41-96E3-520E1D7FD629}" type="datetimeFigureOut">
               <a:rPr lang="en-US" smtClean="0"/>
-              <a:t>7/13/21</a:t>
+              <a:t>7/14/21</a:t>
             </a:fld>
             <a:endParaRPr lang="en-US"/>
           </a:p>
@@ -439,7 +439,7 @@
               </a14:hiddenEffects>
             </a:ext>
             <a:ext uri="{FAA26D3D-D897-4be2-8F04-BA451C77F1D7}">
-              <ma14:placeholderFlag xmlns:ma14="http://schemas.microsoft.com/office/mac/drawingml/2011/main" xmlns="" val="1"/>
+              <ma14:placeholderFlag xmlns="" xmlns:ma14="http://schemas.microsoft.com/office/mac/drawingml/2011/main" val="1"/>
             </a:ext>
           </a:extLst>
         </p:spPr>
@@ -518,7 +518,7 @@
               </a14:hiddenEffects>
             </a:ext>
             <a:ext uri="{FAA26D3D-D897-4be2-8F04-BA451C77F1D7}">
-              <ma14:placeholderFlag xmlns:ma14="http://schemas.microsoft.com/office/mac/drawingml/2011/main" xmlns="" val="1"/>
+              <ma14:placeholderFlag xmlns="" xmlns:ma14="http://schemas.microsoft.com/office/mac/drawingml/2011/main" val="1"/>
             </a:ext>
           </a:extLst>
         </p:spPr>
@@ -643,7 +643,7 @@
               </a14:hiddenEffects>
             </a:ext>
             <a:ext uri="{FAA26D3D-D897-4be2-8F04-BA451C77F1D7}">
-              <ma14:placeholderFlag xmlns:ma14="http://schemas.microsoft.com/office/mac/drawingml/2011/main" xmlns="" val="1"/>
+              <ma14:placeholderFlag xmlns="" xmlns:ma14="http://schemas.microsoft.com/office/mac/drawingml/2011/main" val="1"/>
             </a:ext>
           </a:extLst>
         </p:spPr>
@@ -744,7 +744,7 @@
               </a14:hiddenEffects>
             </a:ext>
             <a:ext uri="{FAA26D3D-D897-4be2-8F04-BA451C77F1D7}">
-              <ma14:placeholderFlag xmlns:ma14="http://schemas.microsoft.com/office/mac/drawingml/2011/main" xmlns="" val="1"/>
+              <ma14:placeholderFlag xmlns="" xmlns:ma14="http://schemas.microsoft.com/office/mac/drawingml/2011/main" val="1"/>
             </a:ext>
           </a:extLst>
         </p:spPr>
@@ -823,7 +823,7 @@
               </a14:hiddenEffects>
             </a:ext>
             <a:ext uri="{FAA26D3D-D897-4be2-8F04-BA451C77F1D7}">
-              <ma14:placeholderFlag xmlns:ma14="http://schemas.microsoft.com/office/mac/drawingml/2011/main" xmlns="" val="1"/>
+              <ma14:placeholderFlag xmlns="" xmlns:ma14="http://schemas.microsoft.com/office/mac/drawingml/2011/main" val="1"/>
             </a:ext>
           </a:extLst>
         </p:spPr>
@@ -1065,12 +1065,24 @@
           </a:p>
           <a:p>
             <a:r>
+              <a:rPr lang="de-DE" dirty="0"/>
+              <a:t>The title </a:t>
+            </a:r>
+            <a:r>
               <a:rPr lang="de-DE" dirty="0" err="1"/>
-              <a:t>Mouthful</a:t>
+              <a:t>is</a:t>
             </a:r>
             <a:r>
               <a:rPr lang="de-DE" dirty="0"/>
-              <a:t> title, </a:t>
+              <a:t> a </a:t>
+            </a:r>
+            <a:r>
+              <a:rPr lang="de-DE" dirty="0" err="1"/>
+              <a:t>mouthful</a:t>
+            </a:r>
+            <a:r>
+              <a:rPr lang="de-DE" dirty="0"/>
+              <a:t>, </a:t>
             </a:r>
             <a:r>
               <a:rPr lang="de-DE" dirty="0" err="1"/>
@@ -1205,31 +1217,17 @@
             </a:r>
           </a:p>
           <a:p>
+            <a:pPr lvl="0"/>
             <a:r>
               <a:rPr lang="en-US" b="0" baseline="0" dirty="0"/>
-              <a:t>Find out any goal or compound templates</a:t>
+              <a:t>Calculate the the atom equivalence.</a:t>
             </a:r>
           </a:p>
           <a:p>
             <a:pPr lvl="1"/>
             <a:r>
               <a:rPr lang="en-US" b="0" baseline="0" dirty="0"/>
-              <a:t>All goal templates are having edit distance &gt; 2. They cannot be reached by simple substitution.</a:t>
-            </a:r>
-          </a:p>
-          <a:p>
-            <a:pPr lvl="0"/>
-            <a:r>
-              <a:rPr lang="en-US" b="0" baseline="0" dirty="0"/>
-              <a:t>Calculate the the atom </a:t>
-            </a:r>
-            <a:r>
-              <a:rPr lang="en-US" b="0" baseline="0" dirty="0" err="1"/>
-              <a:t>equivalance</a:t>
-            </a:r>
-            <a:r>
-              <a:rPr lang="en-US" b="0" baseline="0" dirty="0"/>
-              <a:t>.</a:t>
+              <a:t>If 2 compounds have an edit distance = 1, then their differing atoms are equivalent.</a:t>
             </a:r>
           </a:p>
           <a:p>
@@ -1343,18 +1341,48 @@
           <a:p>
             <a:r>
               <a:rPr lang="en-US" b="0" baseline="0" dirty="0"/>
-              <a:t>Let us come back to our architecture so see how much we have understood.</a:t>
+              <a:t>Lets look at the other components briefly before we get into the details of the architecture.</a:t>
             </a:r>
           </a:p>
           <a:p>
             <a:r>
               <a:rPr lang="en-US" b="0" baseline="0" dirty="0"/>
-              <a:t>For this we have to see the complete algorithm of Imagine architecture.</a:t>
+              <a:t>&lt;Mention the components&gt;</a:t>
+            </a:r>
+          </a:p>
+          <a:p>
+            <a:r>
+              <a:rPr lang="en-US" b="0" baseline="0" dirty="0"/>
+              <a:t>How are they trained.</a:t>
             </a:r>
           </a:p>
           <a:p>
             <a:pPr lvl="1"/>
-            <a:endParaRPr lang="en-US" b="0" baseline="0" dirty="0"/>
+            <a:r>
+              <a:rPr lang="en-US" b="0" baseline="0" dirty="0"/>
+              <a:t>Basic principle is that anything that is of interest is saved.</a:t>
+            </a:r>
+          </a:p>
+          <a:p>
+            <a:pPr lvl="1"/>
+            <a:r>
+              <a:rPr lang="en-US" b="0" baseline="0" dirty="0"/>
+              <a:t>Use the saved data to train the components.</a:t>
+            </a:r>
+          </a:p>
+          <a:p>
+            <a:pPr lvl="0"/>
+            <a:r>
+              <a:rPr lang="en-US" b="0" baseline="0" dirty="0"/>
+              <a:t>One important thing – The function approximators are goal conditioned.</a:t>
+            </a:r>
+          </a:p>
+          <a:p>
+            <a:pPr lvl="0"/>
+            <a:r>
+              <a:rPr lang="en-US" b="0" baseline="0" dirty="0"/>
+              <a:t>It will become more clear if we go to through the architecture one by one.</a:t>
+            </a:r>
           </a:p>
         </p:txBody>
       </p:sp>
@@ -1390,7 +1418,7 @@
     </p:spTree>
     <p:extLst>
       <p:ext uri="{BB962C8B-B14F-4D97-AF65-F5344CB8AC3E}">
-        <p14:creationId xmlns:p14="http://schemas.microsoft.com/office/powerpoint/2010/main" val="2500109937"/>
+        <p14:creationId xmlns:p14="http://schemas.microsoft.com/office/powerpoint/2010/main" val="2340811763"/>
       </p:ext>
     </p:extLst>
   </p:cSld>
@@ -1446,28 +1474,34 @@
           <a:p>
             <a:r>
               <a:rPr lang="en-US" b="0" baseline="0" dirty="0"/>
-              <a:t>Going through the algorithm step by step to help understand the algorithm.</a:t>
-            </a:r>
-          </a:p>
-          <a:p>
+              <a:t>Let us come back to our architecture so see how much we have understood.</a:t>
+            </a:r>
+          </a:p>
+          <a:p>
+            <a:pPr lvl="1"/>
             <a:r>
               <a:rPr lang="en-US" b="0" baseline="0" dirty="0"/>
-              <a:t>There is addition of </a:t>
-            </a:r>
-            <a:r>
-              <a:rPr lang="en-US" b="0" baseline="0" dirty="0" err="1"/>
-              <a:t>r,s</a:t>
-            </a:r>
+              <a:t>Here we can see some of the basic principles of what we discussed previous slides.</a:t>
+            </a:r>
+          </a:p>
+          <a:p>
+            <a:pPr lvl="1"/>
             <a:r>
               <a:rPr lang="en-US" b="0" baseline="0" dirty="0"/>
-              <a:t> so that we learn the reward function</a:t>
+              <a:t>We see the playground environment on the right had corner</a:t>
             </a:r>
           </a:p>
           <a:p>
             <a:pPr lvl="1"/>
             <a:r>
               <a:rPr lang="en-US" b="0" baseline="0" dirty="0"/>
-              <a:t>Very important for the behavior adaption.</a:t>
+              <a:t>We have understood the Goal Generation mechanism.</a:t>
+            </a:r>
+          </a:p>
+          <a:p>
+            <a:r>
+              <a:rPr lang="en-US" b="0" baseline="0" dirty="0"/>
+              <a:t>Now lets put all the things together and understand everything in sequence with the algorithm.</a:t>
             </a:r>
           </a:p>
           <a:p>
@@ -1508,7 +1542,7 @@
     </p:spTree>
     <p:extLst>
       <p:ext uri="{BB962C8B-B14F-4D97-AF65-F5344CB8AC3E}">
-        <p14:creationId xmlns:p14="http://schemas.microsoft.com/office/powerpoint/2010/main" val="2862936666"/>
+        <p14:creationId xmlns:p14="http://schemas.microsoft.com/office/powerpoint/2010/main" val="2500109937"/>
       </p:ext>
     </p:extLst>
   </p:cSld>
@@ -1562,6 +1596,209 @@
           <a:bodyPr/>
           <a:lstStyle/>
           <a:p>
+            <a:r>
+              <a:rPr lang="en-US" b="0" baseline="0" dirty="0"/>
+              <a:t>Going through the algorithm step by step to help understand the algorithm.</a:t>
+            </a:r>
+          </a:p>
+          <a:p>
+            <a:r>
+              <a:rPr lang="en-US" b="0" baseline="0" dirty="0"/>
+              <a:t>We do </a:t>
+            </a:r>
+          </a:p>
+          <a:p>
+            <a:pPr lvl="1"/>
+            <a:r>
+              <a:rPr lang="en-US" b="0" baseline="0" dirty="0"/>
+              <a:t>Random initialization for our function approximators.</a:t>
+            </a:r>
+          </a:p>
+          <a:p>
+            <a:pPr lvl="1"/>
+            <a:r>
+              <a:rPr lang="en-US" b="0" baseline="0" dirty="0"/>
+              <a:t>Initialize empty sets for our memories (both known goals and imaginary goals)</a:t>
+            </a:r>
+          </a:p>
+          <a:p>
+            <a:pPr lvl="0"/>
+            <a:r>
+              <a:rPr lang="en-US" b="0" baseline="0" dirty="0"/>
+              <a:t>Sample weights from the set of known or imaginary goals.</a:t>
+            </a:r>
+          </a:p>
+          <a:p>
+            <a:pPr lvl="1"/>
+            <a:r>
+              <a:rPr lang="en-US" b="0" baseline="0" dirty="0"/>
+              <a:t>Convert the goal to the real valued vector using LSTM.</a:t>
+            </a:r>
+          </a:p>
+          <a:p>
+            <a:pPr lvl="1"/>
+            <a:r>
+              <a:rPr lang="en-US" b="0" baseline="0" dirty="0"/>
+              <a:t>If sets are empty we take a random vector out of a gaussian distribution.</a:t>
+            </a:r>
+          </a:p>
+          <a:p>
+            <a:pPr lvl="0"/>
+            <a:r>
+              <a:rPr lang="en-US" b="0" baseline="0" dirty="0"/>
+              <a:t>Run our policy and add save the whole trajectory to the memory.</a:t>
+            </a:r>
+          </a:p>
+          <a:p>
+            <a:pPr lvl="0"/>
+            <a:r>
+              <a:rPr lang="en-US" b="0" baseline="0" dirty="0"/>
+              <a:t>The last step of our trajectory is explained by the social partner.</a:t>
+            </a:r>
+          </a:p>
+          <a:p>
+            <a:pPr lvl="0"/>
+            <a:r>
+              <a:rPr lang="en-US" b="0" baseline="0" dirty="0"/>
+              <a:t>This is stored in our reward memory with the corresponding state.</a:t>
+            </a:r>
+          </a:p>
+          <a:p>
+            <a:pPr lvl="0"/>
+            <a:r>
+              <a:rPr lang="en-US" b="0" baseline="0" dirty="0"/>
+              <a:t>If Goal generation (here referred to as imagination) is enabled </a:t>
+            </a:r>
+            <a:r>
+              <a:rPr lang="en-US" b="0" baseline="0" dirty="0">
+                <a:sym typeface="Wingdings" pitchFamily="2" charset="2"/>
+              </a:rPr>
+              <a:t> We run the imagine algorithm.</a:t>
+            </a:r>
+          </a:p>
+          <a:p>
+            <a:pPr lvl="0"/>
+            <a:r>
+              <a:rPr lang="en-US" b="0" baseline="0" dirty="0">
+                <a:sym typeface="Wingdings" pitchFamily="2" charset="2"/>
+              </a:rPr>
+              <a:t>Using batch of trajectories stored in the memory, essentially hindsight experience replay, our </a:t>
+            </a:r>
+            <a:r>
+              <a:rPr lang="en-US" b="0" baseline="0" dirty="0" err="1">
+                <a:sym typeface="Wingdings" pitchFamily="2" charset="2"/>
+              </a:rPr>
+              <a:t>policity</a:t>
+            </a:r>
+            <a:r>
+              <a:rPr lang="en-US" b="0" baseline="0" dirty="0">
+                <a:sym typeface="Wingdings" pitchFamily="2" charset="2"/>
+              </a:rPr>
+              <a:t> is updated.</a:t>
+            </a:r>
+          </a:p>
+          <a:p>
+            <a:pPr lvl="1"/>
+            <a:r>
+              <a:rPr lang="en-US" b="0" baseline="0" dirty="0" err="1">
+                <a:sym typeface="Wingdings" pitchFamily="2" charset="2"/>
+              </a:rPr>
+              <a:t>Modularbatch</a:t>
+            </a:r>
+            <a:r>
+              <a:rPr lang="en-US" b="0" baseline="0" dirty="0">
+                <a:sym typeface="Wingdings" pitchFamily="2" charset="2"/>
+              </a:rPr>
+              <a:t> is due to modular trajectories – see appendix.</a:t>
+            </a:r>
+          </a:p>
+          <a:p>
+            <a:pPr lvl="0"/>
+            <a:r>
+              <a:rPr lang="en-US" b="0" baseline="0" dirty="0">
+                <a:sym typeface="Wingdings" pitchFamily="2" charset="2"/>
+              </a:rPr>
+              <a:t>Lastly from the stored rewards the La </a:t>
+            </a:r>
+            <a:r>
+              <a:rPr lang="en-US" b="0" baseline="0" dirty="0" err="1">
+                <a:sym typeface="Wingdings" pitchFamily="2" charset="2"/>
+              </a:rPr>
+              <a:t>guage</a:t>
+            </a:r>
+            <a:r>
+              <a:rPr lang="en-US" b="0" baseline="0" dirty="0">
+                <a:sym typeface="Wingdings" pitchFamily="2" charset="2"/>
+              </a:rPr>
+              <a:t> encoder and the reward function are trained</a:t>
+            </a:r>
+          </a:p>
+          <a:p>
+            <a:pPr lvl="1"/>
+            <a:r>
+              <a:rPr lang="en-US" b="0" baseline="0" dirty="0">
+                <a:sym typeface="Wingdings" pitchFamily="2" charset="2"/>
+              </a:rPr>
+              <a:t>Language encoder training is clear. A supervised function </a:t>
+            </a:r>
+            <a:r>
+              <a:rPr lang="en-US" b="0" baseline="0" dirty="0" err="1">
+                <a:sym typeface="Wingdings" pitchFamily="2" charset="2"/>
+              </a:rPr>
+              <a:t>approximater</a:t>
+            </a:r>
+            <a:r>
+              <a:rPr lang="en-US" b="0" baseline="0" dirty="0">
+                <a:sym typeface="Wingdings" pitchFamily="2" charset="2"/>
+              </a:rPr>
+              <a:t> that maps words to real valued vector.</a:t>
+            </a:r>
+          </a:p>
+          <a:p>
+            <a:pPr lvl="1"/>
+            <a:r>
+              <a:rPr lang="en-US" b="0" baseline="0" dirty="0">
+                <a:sym typeface="Wingdings" pitchFamily="2" charset="2"/>
+              </a:rPr>
+              <a:t>For training the memory reward, (g, </a:t>
+            </a:r>
+            <a:r>
+              <a:rPr lang="en-US" b="0" baseline="0" dirty="0" err="1">
+                <a:sym typeface="Wingdings" pitchFamily="2" charset="2"/>
+              </a:rPr>
+              <a:t>s_t</a:t>
+            </a:r>
+            <a:r>
+              <a:rPr lang="en-US" b="0" baseline="0" dirty="0">
+                <a:sym typeface="Wingdings" pitchFamily="2" charset="2"/>
+              </a:rPr>
+              <a:t>)  1 and all other known goals with St are mapped to zero.</a:t>
+            </a:r>
+            <a:endParaRPr lang="en-US" b="0" baseline="0" dirty="0"/>
+          </a:p>
+          <a:p>
+            <a:r>
+              <a:rPr lang="en-US" b="0" baseline="0" dirty="0"/>
+              <a:t>There is addition of </a:t>
+            </a:r>
+            <a:r>
+              <a:rPr lang="en-US" b="0" baseline="0" dirty="0" err="1"/>
+              <a:t>r,s</a:t>
+            </a:r>
+            <a:r>
+              <a:rPr lang="en-US" b="0" baseline="0" dirty="0"/>
+              <a:t> so that we learn the reward function</a:t>
+            </a:r>
+          </a:p>
+          <a:p>
+            <a:pPr lvl="1"/>
+            <a:r>
+              <a:rPr lang="en-US" b="0" baseline="0" dirty="0"/>
+              <a:t>Very important for the behavior adaption.</a:t>
+            </a:r>
+          </a:p>
+          <a:p>
+            <a:pPr lvl="1"/>
             <a:endParaRPr lang="en-US" b="0" baseline="0" dirty="0"/>
           </a:p>
         </p:txBody>
@@ -1598,7 +1835,7 @@
     </p:spTree>
     <p:extLst>
       <p:ext uri="{BB962C8B-B14F-4D97-AF65-F5344CB8AC3E}">
-        <p14:creationId xmlns:p14="http://schemas.microsoft.com/office/powerpoint/2010/main" val="3519689356"/>
+        <p14:creationId xmlns:p14="http://schemas.microsoft.com/office/powerpoint/2010/main" val="2862936666"/>
       </p:ext>
     </p:extLst>
   </p:cSld>
@@ -1658,6 +1895,489 @@
           <a:lstStyle/>
           <a:p>
             <a:pPr marL="285750" marR="0" indent="-285750" algn="l" defTabSz="914400" rtl="0" eaLnBrk="0" fontAlgn="base" latinLnBrk="0" hangingPunct="0">
+              <a:lnSpc>
+                <a:spcPct val="100000"/>
+              </a:lnSpc>
+              <a:spcBef>
+                <a:spcPct val="30000"/>
+              </a:spcBef>
+              <a:spcAft>
+                <a:spcPct val="0"/>
+              </a:spcAft>
+              <a:buClr>
+                <a:srgbClr val="800000"/>
+              </a:buClr>
+              <a:buSzTx/>
+              <a:buFont typeface="Wingdings" charset="2"/>
+              <a:buChar char="§"/>
+              <a:tabLst/>
+              <a:defRPr/>
+            </a:pPr>
+            <a:r>
+              <a:rPr lang="en-US" baseline="0" dirty="0"/>
+              <a:t>The state space generalization is almost perfect.</a:t>
+            </a:r>
+          </a:p>
+          <a:p>
+            <a:pPr marL="285750" marR="0" indent="-285750" algn="l" defTabSz="914400" rtl="0" eaLnBrk="0" fontAlgn="base" latinLnBrk="0" hangingPunct="0">
+              <a:lnSpc>
+                <a:spcPct val="100000"/>
+              </a:lnSpc>
+              <a:spcBef>
+                <a:spcPct val="30000"/>
+              </a:spcBef>
+              <a:spcAft>
+                <a:spcPct val="0"/>
+              </a:spcAft>
+              <a:buClr>
+                <a:srgbClr val="800000"/>
+              </a:buClr>
+              <a:buSzTx/>
+              <a:buFont typeface="Wingdings" charset="2"/>
+              <a:buChar char="§"/>
+              <a:tabLst/>
+              <a:defRPr/>
+            </a:pPr>
+            <a:r>
+              <a:rPr lang="en-US" baseline="0" dirty="0"/>
+              <a:t>So the focus is on goal generalization.</a:t>
+            </a:r>
+          </a:p>
+          <a:p>
+            <a:pPr marL="285750" marR="0" indent="-285750" algn="l" defTabSz="914400" rtl="0" eaLnBrk="0" fontAlgn="base" latinLnBrk="0" hangingPunct="0">
+              <a:lnSpc>
+                <a:spcPct val="100000"/>
+              </a:lnSpc>
+              <a:spcBef>
+                <a:spcPct val="30000"/>
+              </a:spcBef>
+              <a:spcAft>
+                <a:spcPct val="0"/>
+              </a:spcAft>
+              <a:buClr>
+                <a:srgbClr val="800000"/>
+              </a:buClr>
+              <a:buSzTx/>
+              <a:buFont typeface="Wingdings" charset="2"/>
+              <a:buChar char="§"/>
+              <a:tabLst/>
+              <a:defRPr/>
+            </a:pPr>
+            <a:r>
+              <a:rPr lang="en-US" baseline="0" dirty="0"/>
+              <a:t>There were 2 types of interesting behaviors observed</a:t>
+            </a:r>
+          </a:p>
+          <a:p>
+            <a:pPr marL="615950" marR="0" lvl="1" indent="-285750" algn="l" defTabSz="914400" rtl="0" eaLnBrk="0" fontAlgn="base" latinLnBrk="0" hangingPunct="0">
+              <a:lnSpc>
+                <a:spcPct val="100000"/>
+              </a:lnSpc>
+              <a:spcBef>
+                <a:spcPct val="30000"/>
+              </a:spcBef>
+              <a:spcAft>
+                <a:spcPct val="0"/>
+              </a:spcAft>
+              <a:buClr>
+                <a:srgbClr val="800000"/>
+              </a:buClr>
+              <a:buSzTx/>
+              <a:buFont typeface="Wingdings" charset="2"/>
+              <a:buChar char="§"/>
+              <a:tabLst/>
+              <a:defRPr/>
+            </a:pPr>
+            <a:r>
+              <a:rPr lang="en-US" baseline="0" dirty="0"/>
+              <a:t>Grow imagination to non living things. This is clearly because of the power of language compositionality.</a:t>
+            </a:r>
+          </a:p>
+          <a:p>
+            <a:pPr marL="615950" marR="0" lvl="1" indent="-285750" algn="l" defTabSz="914400" rtl="0" eaLnBrk="0" fontAlgn="base" latinLnBrk="0" hangingPunct="0">
+              <a:lnSpc>
+                <a:spcPct val="100000"/>
+              </a:lnSpc>
+              <a:spcBef>
+                <a:spcPct val="30000"/>
+              </a:spcBef>
+              <a:spcAft>
+                <a:spcPct val="0"/>
+              </a:spcAft>
+              <a:buClr>
+                <a:srgbClr val="800000"/>
+              </a:buClr>
+              <a:buSzTx/>
+              <a:buFont typeface="Wingdings" charset="2"/>
+              <a:buChar char="§"/>
+              <a:tabLst/>
+              <a:defRPr/>
+            </a:pPr>
+            <a:r>
+              <a:rPr lang="en-US" baseline="0" dirty="0"/>
+              <a:t>Hence the imagination of out of distribution goals is shown in this case.</a:t>
+            </a:r>
+          </a:p>
+          <a:p>
+            <a:pPr marL="615950" marR="0" lvl="1" indent="-285750" algn="l" defTabSz="914400" rtl="0" eaLnBrk="0" fontAlgn="base" latinLnBrk="0" hangingPunct="0">
+              <a:lnSpc>
+                <a:spcPct val="100000"/>
+              </a:lnSpc>
+              <a:spcBef>
+                <a:spcPct val="30000"/>
+              </a:spcBef>
+              <a:spcAft>
+                <a:spcPct val="0"/>
+              </a:spcAft>
+              <a:buClr>
+                <a:srgbClr val="800000"/>
+              </a:buClr>
+              <a:buSzTx/>
+              <a:buFont typeface="Wingdings" charset="2"/>
+              <a:buChar char="§"/>
+              <a:tabLst/>
+              <a:defRPr/>
+            </a:pPr>
+            <a:r>
+              <a:rPr lang="en-US" baseline="0" dirty="0"/>
+              <a:t>Second is a behavior adaption which is more subtle</a:t>
+            </a:r>
+          </a:p>
+          <a:p>
+            <a:pPr marL="903288" marR="0" lvl="2" indent="-285750" algn="l" defTabSz="914400" rtl="0" eaLnBrk="0" fontAlgn="base" latinLnBrk="0" hangingPunct="0">
+              <a:lnSpc>
+                <a:spcPct val="100000"/>
+              </a:lnSpc>
+              <a:spcBef>
+                <a:spcPct val="30000"/>
+              </a:spcBef>
+              <a:spcAft>
+                <a:spcPct val="0"/>
+              </a:spcAft>
+              <a:buClr>
+                <a:srgbClr val="800000"/>
+              </a:buClr>
+              <a:buSzTx/>
+              <a:buFont typeface="Wingdings" charset="2"/>
+              <a:buChar char="§"/>
+              <a:tabLst/>
+              <a:defRPr/>
+            </a:pPr>
+            <a:r>
+              <a:rPr lang="en-US" baseline="0" dirty="0"/>
+              <a:t>First the social partner in its description of goals, never describes that plants can grow. But this is got through goal imagination trivially</a:t>
+            </a:r>
+          </a:p>
+          <a:p>
+            <a:pPr marL="903288" marR="0" lvl="2" indent="-285750" algn="l" defTabSz="914400" rtl="0" eaLnBrk="0" fontAlgn="base" latinLnBrk="0" hangingPunct="0">
+              <a:lnSpc>
+                <a:spcPct val="100000"/>
+              </a:lnSpc>
+              <a:spcBef>
+                <a:spcPct val="30000"/>
+              </a:spcBef>
+              <a:spcAft>
+                <a:spcPct val="0"/>
+              </a:spcAft>
+              <a:buClr>
+                <a:srgbClr val="800000"/>
+              </a:buClr>
+              <a:buSzTx/>
+              <a:buFont typeface="Wingdings" charset="2"/>
+              <a:buChar char="§"/>
+              <a:tabLst/>
+              <a:defRPr/>
+            </a:pPr>
+            <a:r>
+              <a:rPr lang="en-US" baseline="0" dirty="0"/>
+              <a:t>It also does not state that plants only grow through water.</a:t>
+            </a:r>
+          </a:p>
+          <a:p>
+            <a:pPr marL="285750" marR="0" lvl="0" indent="-285750" algn="l" defTabSz="914400" rtl="0" eaLnBrk="0" fontAlgn="base" latinLnBrk="0" hangingPunct="0">
+              <a:lnSpc>
+                <a:spcPct val="100000"/>
+              </a:lnSpc>
+              <a:spcBef>
+                <a:spcPct val="30000"/>
+              </a:spcBef>
+              <a:spcAft>
+                <a:spcPct val="0"/>
+              </a:spcAft>
+              <a:buClr>
+                <a:srgbClr val="800000"/>
+              </a:buClr>
+              <a:buSzTx/>
+              <a:buFont typeface="Wingdings" charset="2"/>
+              <a:buChar char="§"/>
+              <a:tabLst/>
+              <a:defRPr/>
+            </a:pPr>
+            <a:r>
+              <a:rPr lang="en-US" baseline="0" dirty="0"/>
+              <a:t>How is behavior adaption accomplished</a:t>
+            </a:r>
+          </a:p>
+          <a:p>
+            <a:pPr marL="615950" marR="0" lvl="1" indent="-285750" algn="l" defTabSz="914400" rtl="0" eaLnBrk="0" fontAlgn="base" latinLnBrk="0" hangingPunct="0">
+              <a:lnSpc>
+                <a:spcPct val="100000"/>
+              </a:lnSpc>
+              <a:spcBef>
+                <a:spcPct val="30000"/>
+              </a:spcBef>
+              <a:spcAft>
+                <a:spcPct val="0"/>
+              </a:spcAft>
+              <a:buClr>
+                <a:srgbClr val="800000"/>
+              </a:buClr>
+              <a:buSzTx/>
+              <a:buFont typeface="Wingdings" charset="2"/>
+              <a:buChar char="§"/>
+              <a:tabLst/>
+              <a:defRPr/>
+            </a:pPr>
+            <a:r>
+              <a:rPr lang="en-US" baseline="0" dirty="0"/>
+              <a:t>First we have to remember that ”Grow” goal is only accomplished when the object is grown.</a:t>
+            </a:r>
+          </a:p>
+          <a:p>
+            <a:pPr marL="615950" marR="0" lvl="1" indent="-285750" algn="l" defTabSz="914400" rtl="0" eaLnBrk="0" fontAlgn="base" latinLnBrk="0" hangingPunct="0">
+              <a:lnSpc>
+                <a:spcPct val="100000"/>
+              </a:lnSpc>
+              <a:spcBef>
+                <a:spcPct val="30000"/>
+              </a:spcBef>
+              <a:spcAft>
+                <a:spcPct val="0"/>
+              </a:spcAft>
+              <a:buClr>
+                <a:srgbClr val="800000"/>
+              </a:buClr>
+              <a:buSzTx/>
+              <a:buFont typeface="Wingdings" charset="2"/>
+              <a:buChar char="§"/>
+              <a:tabLst/>
+              <a:defRPr/>
+            </a:pPr>
+            <a:r>
+              <a:rPr lang="en-US" baseline="0" dirty="0"/>
+              <a:t>How does the agent get to know that it has accomplished a goal without the help of the social partner? </a:t>
+            </a:r>
+            <a:r>
+              <a:rPr lang="en-US" baseline="0" dirty="0">
+                <a:sym typeface="Wingdings" pitchFamily="2" charset="2"/>
+              </a:rPr>
+              <a:t> Reward function.</a:t>
+            </a:r>
+          </a:p>
+          <a:p>
+            <a:pPr marL="615950" marR="0" lvl="1" indent="-285750" algn="l" defTabSz="914400" rtl="0" eaLnBrk="0" fontAlgn="base" latinLnBrk="0" hangingPunct="0">
+              <a:lnSpc>
+                <a:spcPct val="100000"/>
+              </a:lnSpc>
+              <a:spcBef>
+                <a:spcPct val="30000"/>
+              </a:spcBef>
+              <a:spcAft>
+                <a:spcPct val="0"/>
+              </a:spcAft>
+              <a:buClr>
+                <a:srgbClr val="800000"/>
+              </a:buClr>
+              <a:buSzTx/>
+              <a:buFont typeface="Wingdings" charset="2"/>
+              <a:buChar char="§"/>
+              <a:tabLst/>
+              <a:defRPr/>
+            </a:pPr>
+            <a:r>
+              <a:rPr lang="en-US" baseline="0" dirty="0">
+                <a:sym typeface="Wingdings" pitchFamily="2" charset="2"/>
+              </a:rPr>
+              <a:t>So the steps are</a:t>
+            </a:r>
+          </a:p>
+          <a:p>
+            <a:pPr marL="903288" marR="0" lvl="2" indent="-285750" algn="l" defTabSz="914400" rtl="0" eaLnBrk="0" fontAlgn="base" latinLnBrk="0" hangingPunct="0">
+              <a:lnSpc>
+                <a:spcPct val="100000"/>
+              </a:lnSpc>
+              <a:spcBef>
+                <a:spcPct val="30000"/>
+              </a:spcBef>
+              <a:spcAft>
+                <a:spcPct val="0"/>
+              </a:spcAft>
+              <a:buClr>
+                <a:srgbClr val="800000"/>
+              </a:buClr>
+              <a:buSzTx/>
+              <a:buFont typeface="Wingdings" charset="2"/>
+              <a:buChar char="§"/>
+              <a:tabLst/>
+              <a:defRPr/>
+            </a:pPr>
+            <a:r>
+              <a:rPr lang="en-US" baseline="0" dirty="0">
+                <a:sym typeface="Wingdings" pitchFamily="2" charset="2"/>
+              </a:rPr>
+              <a:t>First image to grow a plant.</a:t>
+            </a:r>
+          </a:p>
+          <a:p>
+            <a:pPr marL="903288" marR="0" lvl="2" indent="-285750" algn="l" defTabSz="914400" rtl="0" eaLnBrk="0" fontAlgn="base" latinLnBrk="0" hangingPunct="0">
+              <a:lnSpc>
+                <a:spcPct val="100000"/>
+              </a:lnSpc>
+              <a:spcBef>
+                <a:spcPct val="30000"/>
+              </a:spcBef>
+              <a:spcAft>
+                <a:spcPct val="0"/>
+              </a:spcAft>
+              <a:buClr>
+                <a:srgbClr val="800000"/>
+              </a:buClr>
+              <a:buSzTx/>
+              <a:buFont typeface="Wingdings" charset="2"/>
+              <a:buChar char="§"/>
+              <a:tabLst/>
+              <a:defRPr/>
+            </a:pPr>
+            <a:r>
+              <a:rPr lang="en-US" baseline="0" dirty="0">
+                <a:sym typeface="Wingdings" pitchFamily="2" charset="2"/>
+              </a:rPr>
+              <a:t>Explore the </a:t>
+            </a:r>
+            <a:r>
+              <a:rPr lang="en-US" baseline="0" dirty="0" err="1">
+                <a:sym typeface="Wingdings" pitchFamily="2" charset="2"/>
+              </a:rPr>
+              <a:t>statespace</a:t>
+            </a:r>
+            <a:r>
+              <a:rPr lang="en-US" baseline="0" dirty="0">
+                <a:sym typeface="Wingdings" pitchFamily="2" charset="2"/>
+              </a:rPr>
+              <a:t> by following the policy</a:t>
+            </a:r>
+          </a:p>
+          <a:p>
+            <a:pPr marL="903288" marR="0" lvl="2" indent="-285750" algn="l" defTabSz="914400" rtl="0" eaLnBrk="0" fontAlgn="base" latinLnBrk="0" hangingPunct="0">
+              <a:lnSpc>
+                <a:spcPct val="100000"/>
+              </a:lnSpc>
+              <a:spcBef>
+                <a:spcPct val="30000"/>
+              </a:spcBef>
+              <a:spcAft>
+                <a:spcPct val="0"/>
+              </a:spcAft>
+              <a:buClr>
+                <a:srgbClr val="800000"/>
+              </a:buClr>
+              <a:buSzTx/>
+              <a:buFont typeface="Wingdings" charset="2"/>
+              <a:buChar char="§"/>
+              <a:tabLst/>
+              <a:defRPr/>
+            </a:pPr>
+            <a:r>
+              <a:rPr lang="en-US" baseline="0" dirty="0">
+                <a:sym typeface="Wingdings" pitchFamily="2" charset="2"/>
+              </a:rPr>
+              <a:t>When the object (tree) is grown, the reward signals the goal is accomplished</a:t>
+            </a:r>
+          </a:p>
+          <a:p>
+            <a:pPr marL="903288" marR="0" lvl="2" indent="-285750" algn="l" defTabSz="914400" rtl="0" eaLnBrk="0" fontAlgn="base" latinLnBrk="0" hangingPunct="0">
+              <a:lnSpc>
+                <a:spcPct val="100000"/>
+              </a:lnSpc>
+              <a:spcBef>
+                <a:spcPct val="30000"/>
+              </a:spcBef>
+              <a:spcAft>
+                <a:spcPct val="0"/>
+              </a:spcAft>
+              <a:buClr>
+                <a:srgbClr val="800000"/>
+              </a:buClr>
+              <a:buSzTx/>
+              <a:buFont typeface="Wingdings" charset="2"/>
+              <a:buChar char="§"/>
+              <a:tabLst/>
+              <a:defRPr/>
+            </a:pPr>
+            <a:r>
+              <a:rPr lang="en-US" baseline="0" dirty="0">
+                <a:sym typeface="Wingdings" pitchFamily="2" charset="2"/>
+              </a:rPr>
+              <a:t>This trajectory is stored in the trajectories memory of policies.</a:t>
+            </a:r>
+          </a:p>
+          <a:p>
+            <a:pPr marL="903288" marR="0" lvl="2" indent="-285750" algn="l" defTabSz="914400" rtl="0" eaLnBrk="0" fontAlgn="base" latinLnBrk="0" hangingPunct="0">
+              <a:lnSpc>
+                <a:spcPct val="100000"/>
+              </a:lnSpc>
+              <a:spcBef>
+                <a:spcPct val="30000"/>
+              </a:spcBef>
+              <a:spcAft>
+                <a:spcPct val="0"/>
+              </a:spcAft>
+              <a:buClr>
+                <a:srgbClr val="800000"/>
+              </a:buClr>
+              <a:buSzTx/>
+              <a:buFont typeface="Wingdings" charset="2"/>
+              <a:buChar char="§"/>
+              <a:tabLst/>
+              <a:defRPr/>
+            </a:pPr>
+            <a:r>
+              <a:rPr lang="en-US" baseline="0" dirty="0">
+                <a:sym typeface="Wingdings" pitchFamily="2" charset="2"/>
+              </a:rPr>
+              <a:t>From now on the policy on the goal of growing the tree is trained on this trajectory</a:t>
+            </a:r>
+          </a:p>
+          <a:p>
+            <a:pPr marL="903288" marR="0" lvl="2" indent="-285750" algn="l" defTabSz="914400" rtl="0" eaLnBrk="0" fontAlgn="base" latinLnBrk="0" hangingPunct="0">
+              <a:lnSpc>
+                <a:spcPct val="100000"/>
+              </a:lnSpc>
+              <a:spcBef>
+                <a:spcPct val="30000"/>
+              </a:spcBef>
+              <a:spcAft>
+                <a:spcPct val="0"/>
+              </a:spcAft>
+              <a:buClr>
+                <a:srgbClr val="800000"/>
+              </a:buClr>
+              <a:buSzTx/>
+              <a:buFont typeface="Wingdings" charset="2"/>
+              <a:buChar char="§"/>
+              <a:tabLst/>
+              <a:defRPr/>
+            </a:pPr>
+            <a:r>
+              <a:rPr lang="en-US" baseline="0" dirty="0">
+                <a:sym typeface="Wingdings" pitchFamily="2" charset="2"/>
+              </a:rPr>
+              <a:t>Hence the behavior adaption.</a:t>
+            </a:r>
+            <a:endParaRPr lang="en-US" baseline="0" dirty="0"/>
+          </a:p>
+          <a:p>
+            <a:pPr marL="615950" marR="0" lvl="1" indent="-285750" algn="l" defTabSz="914400" rtl="0" eaLnBrk="0" fontAlgn="base" latinLnBrk="0" hangingPunct="0">
               <a:lnSpc>
                 <a:spcPct val="100000"/>
               </a:lnSpc>
@@ -2018,6 +2738,1024 @@
               <a:tabLst/>
               <a:defRPr/>
             </a:pPr>
+            <a:r>
+              <a:rPr lang="de-DE" dirty="0" err="1"/>
+              <a:t>There</a:t>
+            </a:r>
+            <a:r>
+              <a:rPr lang="de-DE" dirty="0"/>
+              <a:t> </a:t>
+            </a:r>
+            <a:r>
+              <a:rPr lang="de-DE" dirty="0" err="1"/>
+              <a:t>are</a:t>
+            </a:r>
+            <a:r>
+              <a:rPr lang="de-DE" dirty="0"/>
+              <a:t> </a:t>
+            </a:r>
+            <a:r>
+              <a:rPr lang="de-DE" dirty="0" err="1"/>
+              <a:t>some</a:t>
+            </a:r>
+            <a:r>
+              <a:rPr lang="de-DE" dirty="0"/>
+              <a:t> </a:t>
+            </a:r>
+            <a:r>
+              <a:rPr lang="de-DE" dirty="0" err="1"/>
+              <a:t>limitations</a:t>
+            </a:r>
+            <a:r>
+              <a:rPr lang="de-DE" dirty="0"/>
+              <a:t> </a:t>
+            </a:r>
+            <a:r>
+              <a:rPr lang="de-DE" dirty="0" err="1"/>
+              <a:t>as</a:t>
+            </a:r>
+            <a:r>
+              <a:rPr lang="de-DE" dirty="0"/>
+              <a:t> per </a:t>
+            </a:r>
+            <a:r>
+              <a:rPr lang="de-DE" dirty="0" err="1"/>
+              <a:t>my</a:t>
+            </a:r>
+            <a:r>
+              <a:rPr lang="de-DE" dirty="0"/>
+              <a:t> </a:t>
+            </a:r>
+            <a:r>
+              <a:rPr lang="de-DE" dirty="0" err="1"/>
+              <a:t>understanding</a:t>
+            </a:r>
+            <a:r>
+              <a:rPr lang="de-DE" dirty="0"/>
+              <a:t> </a:t>
+            </a:r>
+            <a:r>
+              <a:rPr lang="de-DE" dirty="0" err="1"/>
+              <a:t>of</a:t>
+            </a:r>
+            <a:r>
+              <a:rPr lang="de-DE" dirty="0"/>
+              <a:t> </a:t>
+            </a:r>
+            <a:r>
+              <a:rPr lang="de-DE" dirty="0" err="1"/>
+              <a:t>the</a:t>
+            </a:r>
+            <a:r>
+              <a:rPr lang="de-DE" dirty="0"/>
+              <a:t> </a:t>
+            </a:r>
+            <a:r>
+              <a:rPr lang="de-DE" dirty="0" err="1"/>
+              <a:t>paper</a:t>
+            </a:r>
+            <a:endParaRPr lang="de-DE" dirty="0"/>
+          </a:p>
+          <a:p>
+            <a:pPr marL="615950" marR="0" lvl="1" indent="-285750" algn="l" defTabSz="914400" rtl="0" eaLnBrk="0" fontAlgn="base" latinLnBrk="0" hangingPunct="0">
+              <a:lnSpc>
+                <a:spcPct val="100000"/>
+              </a:lnSpc>
+              <a:spcBef>
+                <a:spcPct val="30000"/>
+              </a:spcBef>
+              <a:spcAft>
+                <a:spcPct val="0"/>
+              </a:spcAft>
+              <a:buClr>
+                <a:srgbClr val="800000"/>
+              </a:buClr>
+              <a:buSzTx/>
+              <a:buFont typeface="Wingdings" charset="2"/>
+              <a:buChar char="§"/>
+              <a:tabLst/>
+              <a:defRPr/>
+            </a:pPr>
+            <a:r>
+              <a:rPr lang="de-DE" dirty="0"/>
+              <a:t>The </a:t>
+            </a:r>
+            <a:r>
+              <a:rPr lang="de-DE" dirty="0" err="1"/>
+              <a:t>environment</a:t>
+            </a:r>
+            <a:r>
+              <a:rPr lang="de-DE" dirty="0"/>
+              <a:t> </a:t>
+            </a:r>
+            <a:r>
+              <a:rPr lang="de-DE" dirty="0" err="1"/>
+              <a:t>they</a:t>
+            </a:r>
+            <a:r>
+              <a:rPr lang="de-DE" dirty="0"/>
+              <a:t> </a:t>
+            </a:r>
+            <a:r>
+              <a:rPr lang="de-DE" dirty="0" err="1"/>
+              <a:t>used</a:t>
+            </a:r>
+            <a:r>
+              <a:rPr lang="de-DE" dirty="0"/>
+              <a:t> </a:t>
+            </a:r>
+            <a:r>
+              <a:rPr lang="de-DE" dirty="0" err="1"/>
+              <a:t>to</a:t>
+            </a:r>
+            <a:r>
+              <a:rPr lang="de-DE" dirty="0"/>
+              <a:t> </a:t>
+            </a:r>
+            <a:r>
+              <a:rPr lang="de-DE" dirty="0" err="1"/>
+              <a:t>test</a:t>
+            </a:r>
+            <a:r>
+              <a:rPr lang="de-DE" dirty="0"/>
+              <a:t>/</a:t>
+            </a:r>
+            <a:r>
+              <a:rPr lang="de-DE" dirty="0" err="1"/>
+              <a:t>train</a:t>
+            </a:r>
+            <a:r>
+              <a:rPr lang="de-DE" dirty="0"/>
+              <a:t> </a:t>
+            </a:r>
+            <a:r>
+              <a:rPr lang="de-DE" dirty="0" err="1"/>
+              <a:t>their</a:t>
+            </a:r>
+            <a:r>
+              <a:rPr lang="de-DE" dirty="0"/>
+              <a:t> </a:t>
+            </a:r>
+            <a:r>
+              <a:rPr lang="de-DE" dirty="0" err="1"/>
+              <a:t>architecture</a:t>
+            </a:r>
+            <a:r>
+              <a:rPr lang="de-DE" dirty="0"/>
+              <a:t> </a:t>
+            </a:r>
+            <a:r>
+              <a:rPr lang="de-DE" dirty="0" err="1"/>
+              <a:t>is</a:t>
+            </a:r>
+            <a:r>
+              <a:rPr lang="de-DE" dirty="0"/>
+              <a:t> </a:t>
+            </a:r>
+            <a:r>
+              <a:rPr lang="de-DE" dirty="0" err="1"/>
+              <a:t>synthetic</a:t>
+            </a:r>
+            <a:r>
+              <a:rPr lang="de-DE" dirty="0"/>
+              <a:t> </a:t>
+            </a:r>
+            <a:r>
+              <a:rPr lang="de-DE" dirty="0" err="1"/>
+              <a:t>and</a:t>
+            </a:r>
+            <a:r>
+              <a:rPr lang="de-DE" dirty="0"/>
+              <a:t> </a:t>
+            </a:r>
+            <a:r>
+              <a:rPr lang="de-DE" dirty="0" err="1"/>
+              <a:t>very</a:t>
+            </a:r>
+            <a:r>
+              <a:rPr lang="de-DE" dirty="0"/>
+              <a:t> simple.</a:t>
+            </a:r>
+          </a:p>
+          <a:p>
+            <a:pPr marL="615950" marR="0" lvl="1" indent="-285750" algn="l" defTabSz="914400" rtl="0" eaLnBrk="0" fontAlgn="base" latinLnBrk="0" hangingPunct="0">
+              <a:lnSpc>
+                <a:spcPct val="100000"/>
+              </a:lnSpc>
+              <a:spcBef>
+                <a:spcPct val="30000"/>
+              </a:spcBef>
+              <a:spcAft>
+                <a:spcPct val="0"/>
+              </a:spcAft>
+              <a:buClr>
+                <a:srgbClr val="800000"/>
+              </a:buClr>
+              <a:buSzTx/>
+              <a:buFont typeface="Wingdings" charset="2"/>
+              <a:buChar char="§"/>
+              <a:tabLst/>
+              <a:defRPr/>
+            </a:pPr>
+            <a:r>
+              <a:rPr lang="de-DE" dirty="0"/>
+              <a:t>The </a:t>
+            </a:r>
+            <a:r>
+              <a:rPr lang="de-DE" dirty="0" err="1"/>
+              <a:t>language</a:t>
+            </a:r>
+            <a:r>
+              <a:rPr lang="de-DE" dirty="0"/>
+              <a:t> </a:t>
+            </a:r>
+            <a:r>
+              <a:rPr lang="de-DE" dirty="0" err="1"/>
+              <a:t>grammar</a:t>
+            </a:r>
+            <a:r>
+              <a:rPr lang="de-DE" dirty="0"/>
+              <a:t> </a:t>
+            </a:r>
+            <a:r>
+              <a:rPr lang="de-DE" dirty="0" err="1"/>
+              <a:t>they</a:t>
+            </a:r>
+            <a:r>
+              <a:rPr lang="de-DE" dirty="0"/>
+              <a:t> </a:t>
+            </a:r>
+            <a:r>
+              <a:rPr lang="de-DE" dirty="0" err="1"/>
+              <a:t>used</a:t>
+            </a:r>
+            <a:r>
+              <a:rPr lang="de-DE" dirty="0"/>
+              <a:t> </a:t>
+            </a:r>
+            <a:r>
+              <a:rPr lang="de-DE" dirty="0" err="1"/>
+              <a:t>is</a:t>
+            </a:r>
+            <a:r>
+              <a:rPr lang="de-DE" dirty="0"/>
+              <a:t> </a:t>
+            </a:r>
+            <a:r>
+              <a:rPr lang="de-DE" dirty="0" err="1"/>
+              <a:t>very</a:t>
+            </a:r>
+            <a:r>
+              <a:rPr lang="de-DE" dirty="0"/>
+              <a:t> primitive.</a:t>
+            </a:r>
+          </a:p>
+          <a:p>
+            <a:pPr marL="615950" marR="0" lvl="1" indent="-285750" algn="l" defTabSz="914400" rtl="0" eaLnBrk="0" fontAlgn="base" latinLnBrk="0" hangingPunct="0">
+              <a:lnSpc>
+                <a:spcPct val="100000"/>
+              </a:lnSpc>
+              <a:spcBef>
+                <a:spcPct val="30000"/>
+              </a:spcBef>
+              <a:spcAft>
+                <a:spcPct val="0"/>
+              </a:spcAft>
+              <a:buClr>
+                <a:srgbClr val="800000"/>
+              </a:buClr>
+              <a:buSzTx/>
+              <a:buFont typeface="Wingdings" charset="2"/>
+              <a:buChar char="§"/>
+              <a:tabLst/>
+              <a:defRPr/>
+            </a:pPr>
+            <a:r>
+              <a:rPr lang="de-DE" dirty="0" err="1"/>
+              <a:t>Very</a:t>
+            </a:r>
+            <a:r>
+              <a:rPr lang="de-DE" dirty="0"/>
+              <a:t> high </a:t>
+            </a:r>
+            <a:r>
+              <a:rPr lang="de-DE" dirty="0" err="1"/>
+              <a:t>computational</a:t>
+            </a:r>
+            <a:r>
+              <a:rPr lang="de-DE" dirty="0"/>
+              <a:t> </a:t>
+            </a:r>
+            <a:r>
+              <a:rPr lang="de-DE" dirty="0" err="1"/>
+              <a:t>costs</a:t>
+            </a:r>
+            <a:r>
+              <a:rPr lang="de-DE" dirty="0"/>
+              <a:t>. </a:t>
+            </a:r>
+            <a:r>
+              <a:rPr lang="de-DE" dirty="0" err="1"/>
+              <a:t>They</a:t>
+            </a:r>
+            <a:r>
+              <a:rPr lang="de-DE" dirty="0"/>
+              <a:t> </a:t>
+            </a:r>
+            <a:r>
+              <a:rPr lang="de-DE" dirty="0" err="1"/>
+              <a:t>had</a:t>
+            </a:r>
+            <a:r>
+              <a:rPr lang="de-DE" dirty="0"/>
+              <a:t> </a:t>
+            </a:r>
+            <a:r>
+              <a:rPr lang="de-DE" dirty="0" err="1"/>
+              <a:t>to</a:t>
+            </a:r>
+            <a:r>
+              <a:rPr lang="de-DE" dirty="0"/>
+              <a:t> </a:t>
+            </a:r>
+            <a:r>
+              <a:rPr lang="de-DE" dirty="0" err="1"/>
+              <a:t>use</a:t>
+            </a:r>
+            <a:r>
+              <a:rPr lang="de-DE" dirty="0"/>
+              <a:t> ~2.5 CPU </a:t>
+            </a:r>
+            <a:r>
+              <a:rPr lang="de-DE" dirty="0" err="1"/>
+              <a:t>years</a:t>
+            </a:r>
+            <a:r>
+              <a:rPr lang="de-DE" dirty="0"/>
+              <a:t> </a:t>
+            </a:r>
+            <a:r>
+              <a:rPr lang="de-DE" dirty="0" err="1"/>
+              <a:t>for</a:t>
+            </a:r>
+            <a:r>
+              <a:rPr lang="de-DE" dirty="0"/>
+              <a:t> a </a:t>
+            </a:r>
+            <a:r>
+              <a:rPr lang="de-DE" dirty="0" err="1"/>
+              <a:t>single</a:t>
+            </a:r>
+            <a:r>
+              <a:rPr lang="de-DE" dirty="0"/>
+              <a:t> </a:t>
+            </a:r>
+            <a:r>
+              <a:rPr lang="de-DE" dirty="0" err="1"/>
+              <a:t>train</a:t>
+            </a:r>
+            <a:r>
+              <a:rPr lang="de-DE" dirty="0"/>
+              <a:t> </a:t>
+            </a:r>
+            <a:r>
+              <a:rPr lang="de-DE" dirty="0" err="1"/>
+              <a:t>of</a:t>
+            </a:r>
+            <a:r>
+              <a:rPr lang="de-DE" dirty="0"/>
+              <a:t> </a:t>
+            </a:r>
+            <a:r>
+              <a:rPr lang="de-DE" dirty="0" err="1"/>
+              <a:t>their</a:t>
+            </a:r>
+            <a:r>
+              <a:rPr lang="de-DE" dirty="0"/>
+              <a:t> </a:t>
+            </a:r>
+            <a:r>
+              <a:rPr lang="de-DE" dirty="0" err="1"/>
+              <a:t>architecture</a:t>
+            </a:r>
+            <a:r>
+              <a:rPr lang="de-DE" dirty="0"/>
+              <a:t>.</a:t>
+            </a:r>
+          </a:p>
+          <a:p>
+            <a:pPr marL="615950" marR="0" lvl="1" indent="-285750" algn="l" defTabSz="914400" rtl="0" eaLnBrk="0" fontAlgn="base" latinLnBrk="0" hangingPunct="0">
+              <a:lnSpc>
+                <a:spcPct val="100000"/>
+              </a:lnSpc>
+              <a:spcBef>
+                <a:spcPct val="30000"/>
+              </a:spcBef>
+              <a:spcAft>
+                <a:spcPct val="0"/>
+              </a:spcAft>
+              <a:buClr>
+                <a:srgbClr val="800000"/>
+              </a:buClr>
+              <a:buSzTx/>
+              <a:buFont typeface="Wingdings" charset="2"/>
+              <a:buChar char="§"/>
+              <a:tabLst/>
+              <a:defRPr/>
+            </a:pPr>
+            <a:r>
+              <a:rPr lang="de-DE" dirty="0" err="1"/>
+              <a:t>They</a:t>
+            </a:r>
+            <a:r>
+              <a:rPr lang="de-DE" dirty="0"/>
+              <a:t> </a:t>
+            </a:r>
+            <a:r>
+              <a:rPr lang="de-DE" dirty="0" err="1"/>
+              <a:t>had</a:t>
+            </a:r>
+            <a:r>
+              <a:rPr lang="de-DE" dirty="0"/>
+              <a:t> </a:t>
+            </a:r>
+            <a:r>
+              <a:rPr lang="de-DE" dirty="0" err="1"/>
+              <a:t>to</a:t>
+            </a:r>
+            <a:r>
+              <a:rPr lang="de-DE" dirty="0"/>
+              <a:t> </a:t>
+            </a:r>
+            <a:r>
+              <a:rPr lang="de-DE" dirty="0" err="1"/>
+              <a:t>train</a:t>
+            </a:r>
+            <a:r>
+              <a:rPr lang="de-DE" dirty="0"/>
+              <a:t> </a:t>
+            </a:r>
+            <a:r>
+              <a:rPr lang="de-DE" dirty="0" err="1"/>
+              <a:t>with</a:t>
+            </a:r>
+            <a:r>
+              <a:rPr lang="de-DE" dirty="0"/>
+              <a:t> multiple </a:t>
+            </a:r>
+            <a:r>
+              <a:rPr lang="de-DE" dirty="0" err="1"/>
+              <a:t>seeds</a:t>
+            </a:r>
+            <a:r>
+              <a:rPr lang="de-DE" dirty="0"/>
+              <a:t> </a:t>
+            </a:r>
+            <a:r>
+              <a:rPr lang="de-DE" dirty="0" err="1"/>
+              <a:t>to</a:t>
+            </a:r>
+            <a:r>
+              <a:rPr lang="de-DE" dirty="0"/>
+              <a:t> </a:t>
+            </a:r>
+            <a:r>
+              <a:rPr lang="de-DE" dirty="0" err="1"/>
+              <a:t>account</a:t>
+            </a:r>
+            <a:r>
+              <a:rPr lang="de-DE" dirty="0"/>
+              <a:t> </a:t>
+            </a:r>
+            <a:r>
+              <a:rPr lang="de-DE" dirty="0" err="1"/>
+              <a:t>for</a:t>
+            </a:r>
+            <a:r>
+              <a:rPr lang="de-DE" dirty="0"/>
+              <a:t> </a:t>
+            </a:r>
+            <a:r>
+              <a:rPr lang="de-DE" dirty="0" err="1"/>
+              <a:t>the</a:t>
+            </a:r>
+            <a:r>
+              <a:rPr lang="de-DE" dirty="0"/>
+              <a:t> high </a:t>
+            </a:r>
+            <a:r>
+              <a:rPr lang="de-DE" dirty="0" err="1"/>
+              <a:t>variations</a:t>
+            </a:r>
+            <a:r>
+              <a:rPr lang="de-DE" dirty="0"/>
+              <a:t> in </a:t>
+            </a:r>
+            <a:r>
+              <a:rPr lang="de-DE" dirty="0" err="1"/>
+              <a:t>their</a:t>
+            </a:r>
+            <a:r>
+              <a:rPr lang="de-DE" dirty="0"/>
+              <a:t> </a:t>
+            </a:r>
+            <a:r>
+              <a:rPr lang="de-DE" dirty="0" err="1"/>
+              <a:t>function</a:t>
+            </a:r>
+            <a:r>
+              <a:rPr lang="de-DE" dirty="0"/>
+              <a:t> </a:t>
+            </a:r>
+            <a:r>
+              <a:rPr lang="de-DE" dirty="0" err="1"/>
+              <a:t>approximators</a:t>
+            </a:r>
+            <a:r>
+              <a:rPr lang="de-DE" dirty="0"/>
+              <a:t>.</a:t>
+            </a:r>
+          </a:p>
+          <a:p>
+            <a:pPr marL="285750" marR="0" indent="-285750" algn="l" defTabSz="914400" rtl="0" eaLnBrk="0" fontAlgn="base" latinLnBrk="0" hangingPunct="0">
+              <a:lnSpc>
+                <a:spcPct val="100000"/>
+              </a:lnSpc>
+              <a:spcBef>
+                <a:spcPct val="30000"/>
+              </a:spcBef>
+              <a:spcAft>
+                <a:spcPct val="0"/>
+              </a:spcAft>
+              <a:buClr>
+                <a:srgbClr val="800000"/>
+              </a:buClr>
+              <a:buSzTx/>
+              <a:buFont typeface="Wingdings" charset="2"/>
+              <a:buChar char="§"/>
+              <a:tabLst/>
+              <a:defRPr/>
+            </a:pPr>
+            <a:r>
+              <a:rPr lang="de-DE" dirty="0"/>
+              <a:t>In Future </a:t>
+            </a:r>
+            <a:r>
+              <a:rPr lang="de-DE" dirty="0" err="1"/>
+              <a:t>works</a:t>
+            </a:r>
+            <a:r>
+              <a:rPr lang="de-DE" dirty="0"/>
+              <a:t> –</a:t>
+            </a:r>
+          </a:p>
+          <a:p>
+            <a:pPr marL="615950" marR="0" lvl="1" indent="-285750" algn="l" defTabSz="914400" rtl="0" eaLnBrk="0" fontAlgn="base" latinLnBrk="0" hangingPunct="0">
+              <a:lnSpc>
+                <a:spcPct val="100000"/>
+              </a:lnSpc>
+              <a:spcBef>
+                <a:spcPct val="30000"/>
+              </a:spcBef>
+              <a:spcAft>
+                <a:spcPct val="0"/>
+              </a:spcAft>
+              <a:buClr>
+                <a:srgbClr val="800000"/>
+              </a:buClr>
+              <a:buSzTx/>
+              <a:buFont typeface="Wingdings" charset="2"/>
+              <a:buChar char="§"/>
+              <a:tabLst/>
+              <a:defRPr/>
+            </a:pPr>
+            <a:r>
+              <a:rPr lang="de-DE" dirty="0"/>
+              <a:t>A </a:t>
+            </a:r>
+            <a:r>
+              <a:rPr lang="de-DE" dirty="0" err="1"/>
+              <a:t>more</a:t>
+            </a:r>
+            <a:r>
+              <a:rPr lang="de-DE" dirty="0"/>
+              <a:t> </a:t>
+            </a:r>
+            <a:r>
+              <a:rPr lang="de-DE" dirty="0" err="1"/>
+              <a:t>complex</a:t>
+            </a:r>
+            <a:r>
+              <a:rPr lang="de-DE" dirty="0"/>
+              <a:t> </a:t>
+            </a:r>
+            <a:r>
+              <a:rPr lang="de-DE" dirty="0" err="1"/>
+              <a:t>language</a:t>
+            </a:r>
+            <a:r>
+              <a:rPr lang="de-DE" dirty="0"/>
+              <a:t> </a:t>
+            </a:r>
+            <a:r>
+              <a:rPr lang="de-DE" dirty="0" err="1"/>
+              <a:t>could</a:t>
+            </a:r>
+            <a:r>
+              <a:rPr lang="de-DE" dirty="0"/>
+              <a:t> </a:t>
+            </a:r>
+            <a:r>
+              <a:rPr lang="de-DE" dirty="0" err="1"/>
+              <a:t>be</a:t>
+            </a:r>
+            <a:r>
+              <a:rPr lang="de-DE" dirty="0"/>
+              <a:t> </a:t>
+            </a:r>
+            <a:r>
+              <a:rPr lang="de-DE" dirty="0" err="1"/>
+              <a:t>introduced</a:t>
+            </a:r>
+            <a:r>
+              <a:rPr lang="de-DE" dirty="0"/>
+              <a:t>. </a:t>
+            </a:r>
+            <a:r>
+              <a:rPr lang="de-DE" dirty="0" err="1"/>
+              <a:t>E.g</a:t>
+            </a:r>
+            <a:r>
+              <a:rPr lang="de-DE" dirty="0"/>
+              <a:t> </a:t>
+            </a:r>
+            <a:r>
+              <a:rPr lang="de-DE" dirty="0" err="1"/>
+              <a:t>having</a:t>
+            </a:r>
+            <a:r>
+              <a:rPr lang="de-DE" dirty="0"/>
+              <a:t> relative </a:t>
+            </a:r>
+            <a:r>
+              <a:rPr lang="de-DE" dirty="0" err="1"/>
+              <a:t>positions</a:t>
+            </a:r>
+            <a:r>
+              <a:rPr lang="de-DE" dirty="0"/>
+              <a:t> in </a:t>
+            </a:r>
+            <a:r>
+              <a:rPr lang="de-DE" dirty="0" err="1"/>
+              <a:t>the</a:t>
+            </a:r>
+            <a:r>
+              <a:rPr lang="de-DE" dirty="0"/>
+              <a:t> </a:t>
+            </a:r>
+            <a:r>
+              <a:rPr lang="de-DE" dirty="0" err="1"/>
+              <a:t>grammar</a:t>
+            </a:r>
+            <a:r>
+              <a:rPr lang="de-DE" dirty="0"/>
+              <a:t>. </a:t>
+            </a:r>
+            <a:r>
+              <a:rPr lang="de-DE" dirty="0" err="1"/>
+              <a:t>E.g</a:t>
+            </a:r>
+            <a:r>
+              <a:rPr lang="de-DE" dirty="0"/>
+              <a:t> Move </a:t>
+            </a:r>
+            <a:r>
+              <a:rPr lang="de-DE" dirty="0" err="1"/>
+              <a:t>chair</a:t>
+            </a:r>
+            <a:r>
+              <a:rPr lang="de-DE" dirty="0"/>
+              <a:t> </a:t>
+            </a:r>
+            <a:r>
+              <a:rPr lang="de-DE" dirty="0" err="1"/>
+              <a:t>left</a:t>
+            </a:r>
+            <a:r>
+              <a:rPr lang="de-DE" dirty="0"/>
+              <a:t> </a:t>
+            </a:r>
+            <a:r>
+              <a:rPr lang="de-DE" dirty="0" err="1"/>
+              <a:t>of</a:t>
+            </a:r>
+            <a:r>
+              <a:rPr lang="de-DE" dirty="0"/>
+              <a:t> </a:t>
+            </a:r>
+            <a:r>
+              <a:rPr lang="de-DE" dirty="0" err="1"/>
+              <a:t>the</a:t>
+            </a:r>
+            <a:r>
+              <a:rPr lang="de-DE" dirty="0"/>
+              <a:t> </a:t>
+            </a:r>
+            <a:r>
+              <a:rPr lang="de-DE" dirty="0" err="1"/>
+              <a:t>table</a:t>
+            </a:r>
+            <a:r>
+              <a:rPr lang="de-DE" dirty="0"/>
+              <a:t>.</a:t>
+            </a:r>
+          </a:p>
+          <a:p>
+            <a:pPr marL="615950" marR="0" lvl="1" indent="-285750" algn="l" defTabSz="914400" rtl="0" eaLnBrk="0" fontAlgn="base" latinLnBrk="0" hangingPunct="0">
+              <a:lnSpc>
+                <a:spcPct val="100000"/>
+              </a:lnSpc>
+              <a:spcBef>
+                <a:spcPct val="30000"/>
+              </a:spcBef>
+              <a:spcAft>
+                <a:spcPct val="0"/>
+              </a:spcAft>
+              <a:buClr>
+                <a:srgbClr val="800000"/>
+              </a:buClr>
+              <a:buSzTx/>
+              <a:buFont typeface="Wingdings" charset="2"/>
+              <a:buChar char="§"/>
+              <a:tabLst/>
+              <a:defRPr/>
+            </a:pPr>
+            <a:r>
+              <a:rPr lang="de-DE" baseline="0" dirty="0" err="1"/>
+              <a:t>Scaling</a:t>
+            </a:r>
+            <a:r>
+              <a:rPr lang="de-DE" baseline="0" dirty="0"/>
+              <a:t> </a:t>
+            </a:r>
+            <a:r>
+              <a:rPr lang="de-DE" baseline="0" dirty="0" err="1"/>
+              <a:t>the</a:t>
+            </a:r>
+            <a:r>
+              <a:rPr lang="de-DE" baseline="0" dirty="0"/>
+              <a:t> </a:t>
+            </a:r>
+            <a:r>
+              <a:rPr lang="de-DE" baseline="0" dirty="0" err="1"/>
+              <a:t>construction</a:t>
+            </a:r>
+            <a:r>
+              <a:rPr lang="de-DE" baseline="0" dirty="0"/>
+              <a:t> </a:t>
+            </a:r>
+            <a:r>
+              <a:rPr lang="de-DE" baseline="0" dirty="0" err="1"/>
+              <a:t>grammar</a:t>
+            </a:r>
+            <a:r>
+              <a:rPr lang="de-DE" baseline="0" dirty="0"/>
+              <a:t> </a:t>
+            </a:r>
+            <a:r>
+              <a:rPr lang="de-DE" baseline="0" dirty="0" err="1"/>
+              <a:t>to</a:t>
+            </a:r>
+            <a:r>
+              <a:rPr lang="de-DE" baseline="0" dirty="0"/>
+              <a:t> real </a:t>
+            </a:r>
+            <a:r>
+              <a:rPr lang="de-DE" baseline="0" dirty="0" err="1"/>
+              <a:t>langauages</a:t>
+            </a:r>
+            <a:r>
+              <a:rPr lang="de-DE" baseline="0" dirty="0"/>
+              <a:t>.</a:t>
+            </a:r>
+          </a:p>
+          <a:p>
+            <a:pPr marL="615950" marR="0" lvl="1" indent="-285750" algn="l" defTabSz="914400" rtl="0" eaLnBrk="0" fontAlgn="base" latinLnBrk="0" hangingPunct="0">
+              <a:lnSpc>
+                <a:spcPct val="100000"/>
+              </a:lnSpc>
+              <a:spcBef>
+                <a:spcPct val="30000"/>
+              </a:spcBef>
+              <a:spcAft>
+                <a:spcPct val="0"/>
+              </a:spcAft>
+              <a:buClr>
+                <a:srgbClr val="800000"/>
+              </a:buClr>
+              <a:buSzTx/>
+              <a:buFont typeface="Wingdings" charset="2"/>
+              <a:buChar char="§"/>
+              <a:tabLst/>
+              <a:defRPr/>
+            </a:pPr>
+            <a:r>
+              <a:rPr lang="de-DE" baseline="0" dirty="0" err="1"/>
+              <a:t>They</a:t>
+            </a:r>
+            <a:r>
+              <a:rPr lang="de-DE" baseline="0" dirty="0"/>
+              <a:t> </a:t>
+            </a:r>
+            <a:r>
+              <a:rPr lang="de-DE" baseline="0" dirty="0" err="1"/>
+              <a:t>would</a:t>
+            </a:r>
+            <a:r>
+              <a:rPr lang="de-DE" baseline="0" dirty="0"/>
+              <a:t> like </a:t>
+            </a:r>
+            <a:r>
+              <a:rPr lang="de-DE" baseline="0" dirty="0" err="1"/>
+              <a:t>to</a:t>
+            </a:r>
+            <a:r>
+              <a:rPr lang="de-DE" baseline="0" dirty="0"/>
+              <a:t> </a:t>
+            </a:r>
+            <a:r>
+              <a:rPr lang="de-DE" baseline="0" dirty="0" err="1"/>
+              <a:t>further</a:t>
+            </a:r>
+            <a:r>
+              <a:rPr lang="de-DE" baseline="0" dirty="0"/>
+              <a:t> </a:t>
+            </a:r>
+            <a:r>
+              <a:rPr lang="de-DE" baseline="0" dirty="0" err="1"/>
+              <a:t>reduce</a:t>
+            </a:r>
+            <a:r>
+              <a:rPr lang="de-DE" baseline="0" dirty="0"/>
+              <a:t> </a:t>
+            </a:r>
+            <a:r>
+              <a:rPr lang="de-DE" baseline="0" dirty="0" err="1"/>
+              <a:t>the</a:t>
+            </a:r>
+            <a:r>
+              <a:rPr lang="de-DE" baseline="0" dirty="0"/>
+              <a:t> </a:t>
+            </a:r>
+            <a:r>
+              <a:rPr lang="de-DE" baseline="0" dirty="0" err="1"/>
+              <a:t>burden</a:t>
+            </a:r>
+            <a:r>
+              <a:rPr lang="de-DE" baseline="0" dirty="0"/>
+              <a:t> on </a:t>
+            </a:r>
+            <a:r>
+              <a:rPr lang="de-DE" baseline="0" dirty="0" err="1"/>
+              <a:t>the</a:t>
+            </a:r>
+            <a:r>
+              <a:rPr lang="de-DE" baseline="0" dirty="0"/>
+              <a:t> </a:t>
+            </a:r>
+            <a:r>
+              <a:rPr lang="de-DE" baseline="0" dirty="0" err="1"/>
+              <a:t>social</a:t>
+            </a:r>
+            <a:r>
+              <a:rPr lang="de-DE" baseline="0" dirty="0"/>
+              <a:t> </a:t>
+            </a:r>
+            <a:r>
+              <a:rPr lang="de-DE" baseline="0" dirty="0" err="1"/>
+              <a:t>partner</a:t>
+            </a:r>
+            <a:r>
+              <a:rPr lang="de-DE" baseline="0" dirty="0"/>
+              <a:t> – </a:t>
+            </a:r>
+            <a:r>
+              <a:rPr lang="de-DE" baseline="0" dirty="0" err="1"/>
+              <a:t>by</a:t>
+            </a:r>
+            <a:r>
+              <a:rPr lang="de-DE" baseline="0" dirty="0"/>
+              <a:t> </a:t>
+            </a:r>
+            <a:r>
+              <a:rPr lang="de-DE" baseline="0" dirty="0" err="1"/>
+              <a:t>reducing</a:t>
+            </a:r>
+            <a:r>
+              <a:rPr lang="de-DE" baseline="0" dirty="0"/>
+              <a:t> </a:t>
+            </a:r>
+            <a:r>
+              <a:rPr lang="de-DE" baseline="0" dirty="0" err="1"/>
+              <a:t>the</a:t>
+            </a:r>
+            <a:r>
+              <a:rPr lang="de-DE" baseline="0" dirty="0"/>
+              <a:t> </a:t>
+            </a:r>
+            <a:r>
+              <a:rPr lang="de-DE" baseline="0" dirty="0" err="1"/>
+              <a:t>requirement</a:t>
+            </a:r>
+            <a:r>
+              <a:rPr lang="de-DE" baseline="0" dirty="0"/>
+              <a:t> </a:t>
+            </a:r>
+            <a:r>
+              <a:rPr lang="de-DE" baseline="0" dirty="0" err="1"/>
+              <a:t>of</a:t>
+            </a:r>
+            <a:r>
+              <a:rPr lang="de-DE" baseline="0" dirty="0"/>
+              <a:t> </a:t>
+            </a:r>
+            <a:r>
+              <a:rPr lang="de-DE" baseline="0" dirty="0" err="1"/>
+              <a:t>presence</a:t>
+            </a:r>
+            <a:r>
+              <a:rPr lang="de-DE" baseline="0" dirty="0"/>
+              <a:t> </a:t>
+            </a:r>
+            <a:r>
+              <a:rPr lang="de-DE" baseline="0" dirty="0" err="1"/>
+              <a:t>and</a:t>
+            </a:r>
+            <a:r>
+              <a:rPr lang="de-DE" baseline="0" dirty="0"/>
+              <a:t> </a:t>
+            </a:r>
+            <a:r>
+              <a:rPr lang="de-DE" baseline="0" dirty="0" err="1"/>
+              <a:t>perfect</a:t>
+            </a:r>
+            <a:r>
+              <a:rPr lang="de-DE" baseline="0" dirty="0"/>
+              <a:t> </a:t>
+            </a:r>
+            <a:r>
+              <a:rPr lang="de-DE" baseline="0" dirty="0" err="1"/>
+              <a:t>description</a:t>
+            </a:r>
+            <a:r>
+              <a:rPr lang="de-DE" baseline="0" dirty="0"/>
+              <a:t> </a:t>
+            </a:r>
+            <a:r>
+              <a:rPr lang="de-DE" baseline="0" dirty="0" err="1"/>
+              <a:t>of</a:t>
+            </a:r>
+            <a:r>
+              <a:rPr lang="de-DE" baseline="0" dirty="0"/>
+              <a:t> </a:t>
+            </a:r>
+            <a:r>
+              <a:rPr lang="de-DE" baseline="0" dirty="0" err="1"/>
+              <a:t>the</a:t>
+            </a:r>
+            <a:r>
+              <a:rPr lang="de-DE" baseline="0" dirty="0"/>
+              <a:t> </a:t>
+            </a:r>
+            <a:r>
+              <a:rPr lang="de-DE" baseline="0" dirty="0" err="1"/>
+              <a:t>agent</a:t>
+            </a:r>
+            <a:r>
+              <a:rPr lang="de-DE" baseline="0" dirty="0"/>
+              <a:t>.</a:t>
+            </a:r>
+          </a:p>
+          <a:p>
+            <a:pPr marL="615950" marR="0" lvl="1" indent="-285750" algn="l" defTabSz="914400" rtl="0" eaLnBrk="0" fontAlgn="base" latinLnBrk="0" hangingPunct="0">
+              <a:lnSpc>
+                <a:spcPct val="100000"/>
+              </a:lnSpc>
+              <a:spcBef>
+                <a:spcPct val="30000"/>
+              </a:spcBef>
+              <a:spcAft>
+                <a:spcPct val="0"/>
+              </a:spcAft>
+              <a:buClr>
+                <a:srgbClr val="800000"/>
+              </a:buClr>
+              <a:buSzTx/>
+              <a:buFont typeface="Wingdings" charset="2"/>
+              <a:buChar char="§"/>
+              <a:tabLst/>
+              <a:defRPr/>
+            </a:pPr>
             <a:endParaRPr lang="en-US" baseline="0" dirty="0"/>
           </a:p>
         </p:txBody>
@@ -2091,12 +3829,7 @@
             <p:ph type="sldImg"/>
           </p:nvPr>
         </p:nvSpPr>
-        <p:spPr>
-          <a:xfrm>
-            <a:off x="2516188" y="409575"/>
-            <a:ext cx="5202237" cy="2927350"/>
-          </a:xfrm>
-        </p:spPr>
+        <p:spPr/>
       </p:sp>
       <p:sp>
         <p:nvSpPr>
@@ -2113,81 +3846,7 @@
           <a:bodyPr/>
           <a:lstStyle/>
           <a:p>
-            <a:pPr marL="285750" marR="0" indent="-285750" algn="l" defTabSz="914400" rtl="0" eaLnBrk="0" fontAlgn="base" latinLnBrk="0" hangingPunct="0">
-              <a:lnSpc>
-                <a:spcPct val="100000"/>
-              </a:lnSpc>
-              <a:spcBef>
-                <a:spcPct val="30000"/>
-              </a:spcBef>
-              <a:spcAft>
-                <a:spcPct val="0"/>
-              </a:spcAft>
-              <a:buClr>
-                <a:srgbClr val="800000"/>
-              </a:buClr>
-              <a:buSzTx/>
-              <a:buFont typeface="Wingdings" charset="2"/>
-              <a:buChar char="§"/>
-              <a:tabLst/>
-              <a:defRPr/>
-            </a:pPr>
-            <a:r>
-              <a:rPr lang="en-US"/>
-              <a:t>-One of the ways in which we might achieve a lot of</a:t>
-            </a:r>
-            <a:r>
-              <a:rPr lang="en-US" baseline="0"/>
-              <a:t> background knowledge about the world is</a:t>
-            </a:r>
-            <a:r>
-              <a:rPr lang="en-US"/>
-              <a:t> by self-supervised learning</a:t>
-            </a:r>
-            <a:r>
-              <a:rPr lang="en-US" baseline="0"/>
-              <a:t> through interaction or demonstrations</a:t>
-            </a:r>
-          </a:p>
-          <a:p>
-            <a:r>
-              <a:rPr lang="en-US"/>
-              <a:t>-Self-supervised learning</a:t>
-            </a:r>
-            <a:r>
-              <a:rPr lang="en-US" baseline="0"/>
-              <a:t> is a subset of unsupervised learning where the data itself provides the supervision</a:t>
-            </a:r>
-          </a:p>
-          <a:p>
-            <a:r>
-              <a:rPr lang="en-US" baseline="0"/>
-              <a:t>-As we want robots to learn to perform a wide range of tasks in diverse scenarios</a:t>
-            </a:r>
-          </a:p>
-          <a:p>
-            <a:r>
-              <a:rPr lang="en-US" b="1" baseline="0"/>
-              <a:t>-its not really practical to ask humans to label every aspect of every new scene and precisely label continuous dimensions either</a:t>
-            </a:r>
-          </a:p>
-          <a:p>
-            <a:r>
-              <a:rPr lang="en-US" b="1" baseline="0"/>
-              <a:t>-Instead, we want our models to discover and disentangle the abstract dimensions that matter without explicit supervision</a:t>
-            </a:r>
-          </a:p>
-          <a:p>
-            <a:r>
-              <a:rPr lang="en-US" baseline="0"/>
-              <a:t>-There are many signals in the world that we can exploit to self teach such as……</a:t>
-            </a:r>
-          </a:p>
-          <a:p>
-            <a:r>
-              <a:rPr lang="en-US" baseline="0"/>
-              <a:t>-And for continuous control, robots can learn a policy using a dynamics model or from reinforcing signals in a self-supervised manner by interacting with the environment</a:t>
-            </a:r>
+            <a:endParaRPr lang="en-US" dirty="0"/>
           </a:p>
         </p:txBody>
       </p:sp>
@@ -2198,7 +3857,7 @@
             <a:spLocks noGrp="1"/>
           </p:cNvSpPr>
           <p:nvPr>
-            <p:ph type="sldNum" sz="quarter" idx="10"/>
+            <p:ph type="sldNum" sz="quarter" idx="5"/>
           </p:nvPr>
         </p:nvSpPr>
         <p:spPr/>
@@ -2214,7 +3873,7 @@
               <a:pPr>
                 <a:defRPr/>
               </a:pPr>
-              <a:t>19</a:t>
+              <a:t>18</a:t>
             </a:fld>
             <a:endParaRPr lang="en-US"/>
           </a:p>
@@ -2223,7 +3882,7 @@
     </p:spTree>
     <p:extLst>
       <p:ext uri="{BB962C8B-B14F-4D97-AF65-F5344CB8AC3E}">
-        <p14:creationId xmlns:p14="http://schemas.microsoft.com/office/powerpoint/2010/main" val="704984662"/>
+        <p14:creationId xmlns:p14="http://schemas.microsoft.com/office/powerpoint/2010/main" val="3791365823"/>
       </p:ext>
     </p:extLst>
   </p:cSld>
@@ -2260,7 +3919,12 @@
             <p:ph type="sldImg"/>
           </p:nvPr>
         </p:nvSpPr>
-        <p:spPr/>
+        <p:spPr>
+          <a:xfrm>
+            <a:off x="2516188" y="409575"/>
+            <a:ext cx="5202237" cy="2927350"/>
+          </a:xfrm>
+        </p:spPr>
       </p:sp>
       <p:sp>
         <p:nvSpPr>
@@ -2277,59 +3941,30 @@
           <a:bodyPr/>
           <a:lstStyle/>
           <a:p>
-            <a:r>
-              <a:rPr lang="en-US" b="0" baseline="0" dirty="0"/>
-              <a:t>It starts by taking all the known goals (Compounds).</a:t>
-            </a:r>
-          </a:p>
-          <a:p>
-            <a:r>
-              <a:rPr lang="en-US" b="0" baseline="0" dirty="0"/>
-              <a:t>Find out any goal or compound templates</a:t>
-            </a:r>
-          </a:p>
-          <a:p>
-            <a:pPr lvl="1"/>
-            <a:r>
-              <a:rPr lang="en-US" b="0" baseline="0" dirty="0"/>
-              <a:t>All goal templates are having edit distance &gt; 2. They cannot be reached by simple substitution.</a:t>
-            </a:r>
-          </a:p>
-          <a:p>
-            <a:pPr lvl="0"/>
-            <a:r>
-              <a:rPr lang="en-US" b="0" baseline="0" dirty="0"/>
-              <a:t>Calculate the the atom </a:t>
-            </a:r>
-            <a:r>
-              <a:rPr lang="en-US" b="0" baseline="0" dirty="0" err="1"/>
-              <a:t>equivalance</a:t>
-            </a:r>
-            <a:r>
-              <a:rPr lang="en-US" b="0" baseline="0" dirty="0"/>
-              <a:t>.</a:t>
-            </a:r>
-          </a:p>
-          <a:p>
-            <a:pPr lvl="0"/>
-            <a:r>
-              <a:rPr lang="en-US" b="0" baseline="0" dirty="0"/>
-              <a:t>For all the goal template do all the substitutions of words one by one to generate the resulting compounds.</a:t>
-            </a:r>
-          </a:p>
-          <a:p>
-            <a:pPr lvl="0"/>
-            <a:r>
-              <a:rPr lang="en-US" b="0" baseline="0" dirty="0"/>
-              <a:t>Filter out the compounds from the known compounds.</a:t>
-            </a:r>
-          </a:p>
-          <a:p>
-            <a:pPr lvl="0"/>
-            <a:r>
-              <a:rPr lang="en-US" b="0" baseline="0" dirty="0"/>
-              <a:t>Return the imagined compounds.</a:t>
-            </a:r>
+            <a:pPr marL="285750" marR="0" indent="-285750" algn="l" defTabSz="914400" rtl="0" eaLnBrk="0" fontAlgn="base" latinLnBrk="0" hangingPunct="0">
+              <a:lnSpc>
+                <a:spcPct val="100000"/>
+              </a:lnSpc>
+              <a:spcBef>
+                <a:spcPct val="30000"/>
+              </a:spcBef>
+              <a:spcAft>
+                <a:spcPct val="0"/>
+              </a:spcAft>
+              <a:buClr>
+                <a:srgbClr val="800000"/>
+              </a:buClr>
+              <a:buSzTx/>
+              <a:buFont typeface="Wingdings" charset="2"/>
+              <a:buChar char="§"/>
+              <a:tabLst/>
+              <a:defRPr/>
+            </a:pPr>
+            <a:r>
+              <a:rPr lang="en-US" dirty="0"/>
+              <a:t>-</a:t>
+            </a:r>
+            <a:endParaRPr lang="en-US" baseline="0" dirty="0"/>
           </a:p>
         </p:txBody>
       </p:sp>
@@ -2356,7 +3991,7 @@
               <a:pPr>
                 <a:defRPr/>
               </a:pPr>
-              <a:t>20</a:t>
+              <a:t>19</a:t>
             </a:fld>
             <a:endParaRPr lang="en-US"/>
           </a:p>
@@ -2365,7 +4000,7 @@
     </p:spTree>
     <p:extLst>
       <p:ext uri="{BB962C8B-B14F-4D97-AF65-F5344CB8AC3E}">
-        <p14:creationId xmlns:p14="http://schemas.microsoft.com/office/powerpoint/2010/main" val="3929600154"/>
+        <p14:creationId xmlns:p14="http://schemas.microsoft.com/office/powerpoint/2010/main" val="704984662"/>
       </p:ext>
     </p:extLst>
   </p:cSld>
@@ -2440,7 +4075,32 @@
             </a:pPr>
             <a:r>
               <a:rPr lang="en-US" dirty="0"/>
-              <a:t>Normal Reinforcement Learning agents have their skills engineered by engineering reward function.</a:t>
+              <a:t>Normal Reinforcement Learning agents are specific skill learning agent.</a:t>
+            </a:r>
+          </a:p>
+          <a:p>
+            <a:pPr marL="342900" marR="0" lvl="0" indent="-342900" algn="l" defTabSz="914400" rtl="0" eaLnBrk="0" fontAlgn="base" latinLnBrk="0" hangingPunct="0">
+              <a:lnSpc>
+                <a:spcPct val="100000"/>
+              </a:lnSpc>
+              <a:spcBef>
+                <a:spcPct val="30000"/>
+              </a:spcBef>
+              <a:spcAft>
+                <a:spcPct val="0"/>
+              </a:spcAft>
+              <a:buClr>
+                <a:srgbClr val="800000"/>
+              </a:buClr>
+              <a:buSzTx/>
+              <a:buFont typeface="Arial" panose="020B0604020202020204" pitchFamily="34" charset="0"/>
+              <a:buChar char="•"/>
+              <a:tabLst/>
+              <a:defRPr/>
+            </a:pPr>
+            <a:r>
+              <a:rPr lang="en-US" dirty="0"/>
+              <a:t>The specific skill is learnt through a reward function.</a:t>
             </a:r>
           </a:p>
           <a:p>
@@ -2450,7 +4110,7 @@
             </a:pPr>
             <a:r>
               <a:rPr lang="en-US" dirty="0"/>
-              <a:t>The authors build an agent that can learn open ended skills.</a:t>
+              <a:t>The authors, on the contrary, want build an agent that can learn open ended skills.</a:t>
             </a:r>
           </a:p>
           <a:p>
@@ -2470,7 +4130,7 @@
             </a:pPr>
             <a:r>
               <a:rPr lang="en-US" dirty="0"/>
-              <a:t>After accomplishing a goal it is no longer interesting for the child to accomplish the same goal.</a:t>
+              <a:t>According to psychologist – Novelty is the key for the internal satisfaction of infants.</a:t>
             </a:r>
           </a:p>
           <a:p>
@@ -2480,13 +4140,69 @@
             </a:pPr>
             <a:r>
               <a:rPr lang="en-US" dirty="0"/>
+              <a:t>After accomplishing a goal it is no longer interesting for the child to accomplish the same goal.</a:t>
+            </a:r>
+          </a:p>
+          <a:p>
+            <a:pPr marL="673100" lvl="1" indent="-342900">
+              <a:buFont typeface="Arial" panose="020B0604020202020204" pitchFamily="34" charset="0"/>
+              <a:buChar char="•"/>
+            </a:pPr>
+            <a:r>
+              <a:rPr lang="en-US" dirty="0"/>
+              <a:t>Example after stacking blocks in the picture, it becomes less interesting for the child to stack books.</a:t>
+            </a:r>
+          </a:p>
+          <a:p>
+            <a:pPr marL="342900" indent="-342900">
+              <a:buFont typeface="Arial" panose="020B0604020202020204" pitchFamily="34" charset="0"/>
+              <a:buChar char="•"/>
+            </a:pPr>
+            <a:r>
+              <a:rPr lang="en-US" dirty="0"/>
               <a:t>They always try to do new tasks/goals </a:t>
             </a:r>
             <a:r>
               <a:rPr lang="en-US" dirty="0">
                 <a:sym typeface="Wingdings" pitchFamily="2" charset="2"/>
               </a:rPr>
-              <a:t> They are inherently curiosity.</a:t>
+              <a:t> </a:t>
+            </a:r>
+          </a:p>
+          <a:p>
+            <a:pPr marL="673100" lvl="1" indent="-342900">
+              <a:buFont typeface="Arial" panose="020B0604020202020204" pitchFamily="34" charset="0"/>
+              <a:buChar char="•"/>
+            </a:pPr>
+            <a:r>
+              <a:rPr lang="en-US" dirty="0">
+                <a:sym typeface="Wingdings" pitchFamily="2" charset="2"/>
+              </a:rPr>
+              <a:t>They are intrinsically motivated to learn new skills</a:t>
+            </a:r>
+          </a:p>
+          <a:p>
+            <a:pPr marL="673100" lvl="1" indent="-342900">
+              <a:buFont typeface="Arial" panose="020B0604020202020204" pitchFamily="34" charset="0"/>
+              <a:buChar char="•"/>
+            </a:pPr>
+            <a:r>
+              <a:rPr lang="en-US" dirty="0">
+                <a:sym typeface="Wingdings" pitchFamily="2" charset="2"/>
+              </a:rPr>
+              <a:t>They are inherently curiosity.</a:t>
+            </a:r>
+          </a:p>
+          <a:p>
+            <a:pPr marL="673100" lvl="1" indent="-342900">
+              <a:buFont typeface="Arial" panose="020B0604020202020204" pitchFamily="34" charset="0"/>
+              <a:buChar char="•"/>
+            </a:pPr>
+            <a:r>
+              <a:rPr lang="en-US" dirty="0">
+                <a:sym typeface="Wingdings" pitchFamily="2" charset="2"/>
+              </a:rPr>
+              <a:t>The authors try to mimic this aspect of child development in their agent.</a:t>
             </a:r>
             <a:endParaRPr lang="en-US" dirty="0"/>
           </a:p>
@@ -2580,6 +4296,148 @@
           <a:p>
             <a:r>
               <a:rPr lang="en-US" b="0" baseline="0" dirty="0"/>
+              <a:t>It starts by taking all the known goals (Compounds).</a:t>
+            </a:r>
+          </a:p>
+          <a:p>
+            <a:r>
+              <a:rPr lang="en-US" b="0" baseline="0" dirty="0"/>
+              <a:t>Find out any goal or compound templates</a:t>
+            </a:r>
+          </a:p>
+          <a:p>
+            <a:pPr lvl="1"/>
+            <a:r>
+              <a:rPr lang="en-US" b="0" baseline="0" dirty="0"/>
+              <a:t>All goal templates are having edit distance &gt; 2. They cannot be reached by simple substitution.</a:t>
+            </a:r>
+          </a:p>
+          <a:p>
+            <a:pPr lvl="0"/>
+            <a:r>
+              <a:rPr lang="en-US" b="0" baseline="0" dirty="0"/>
+              <a:t>Calculate the the atom </a:t>
+            </a:r>
+            <a:r>
+              <a:rPr lang="en-US" b="0" baseline="0" dirty="0" err="1"/>
+              <a:t>equivalance</a:t>
+            </a:r>
+            <a:r>
+              <a:rPr lang="en-US" b="0" baseline="0" dirty="0"/>
+              <a:t>.</a:t>
+            </a:r>
+          </a:p>
+          <a:p>
+            <a:pPr lvl="0"/>
+            <a:r>
+              <a:rPr lang="en-US" b="0" baseline="0" dirty="0"/>
+              <a:t>For all the goal template do all the substitutions of words one by one to generate the resulting compounds.</a:t>
+            </a:r>
+          </a:p>
+          <a:p>
+            <a:pPr lvl="0"/>
+            <a:r>
+              <a:rPr lang="en-US" b="0" baseline="0" dirty="0"/>
+              <a:t>Filter out the compounds from the known compounds.</a:t>
+            </a:r>
+          </a:p>
+          <a:p>
+            <a:pPr lvl="0"/>
+            <a:r>
+              <a:rPr lang="en-US" b="0" baseline="0" dirty="0"/>
+              <a:t>Return the imagined compounds.</a:t>
+            </a:r>
+          </a:p>
+        </p:txBody>
+      </p:sp>
+      <p:sp>
+        <p:nvSpPr>
+          <p:cNvPr id="4" name="Slide Number Placeholder 3"/>
+          <p:cNvSpPr>
+            <a:spLocks noGrp="1"/>
+          </p:cNvSpPr>
+          <p:nvPr>
+            <p:ph type="sldNum" sz="quarter" idx="10"/>
+          </p:nvPr>
+        </p:nvSpPr>
+        <p:spPr/>
+        <p:txBody>
+          <a:bodyPr/>
+          <a:lstStyle/>
+          <a:p>
+            <a:pPr>
+              <a:defRPr/>
+            </a:pPr>
+            <a:fld id="{2D72F1E3-2578-1242-A6A3-72B7E9BB2E1A}" type="slidenum">
+              <a:rPr lang="en-US" smtClean="0"/>
+              <a:pPr>
+                <a:defRPr/>
+              </a:pPr>
+              <a:t>20</a:t>
+            </a:fld>
+            <a:endParaRPr lang="en-US"/>
+          </a:p>
+        </p:txBody>
+      </p:sp>
+    </p:spTree>
+    <p:extLst>
+      <p:ext uri="{BB962C8B-B14F-4D97-AF65-F5344CB8AC3E}">
+        <p14:creationId xmlns:p14="http://schemas.microsoft.com/office/powerpoint/2010/main" val="3929600154"/>
+      </p:ext>
+    </p:extLst>
+  </p:cSld>
+  <p:clrMapOvr>
+    <a:masterClrMapping/>
+  </p:clrMapOvr>
+</p:notes>
+</file>
+
+<file path=ppt/notesSlides/notesSlide21.xml><?xml version="1.0" encoding="utf-8"?>
+<p:notes xmlns:a="http://schemas.openxmlformats.org/drawingml/2006/main" xmlns:r="http://schemas.openxmlformats.org/officeDocument/2006/relationships" xmlns:p="http://schemas.openxmlformats.org/presentationml/2006/main">
+  <p:cSld>
+    <p:spTree>
+      <p:nvGrpSpPr>
+        <p:cNvPr id="1" name=""/>
+        <p:cNvGrpSpPr/>
+        <p:nvPr/>
+      </p:nvGrpSpPr>
+      <p:grpSpPr>
+        <a:xfrm>
+          <a:off x="0" y="0"/>
+          <a:ext cx="0" cy="0"/>
+          <a:chOff x="0" y="0"/>
+          <a:chExt cx="0" cy="0"/>
+        </a:xfrm>
+      </p:grpSpPr>
+      <p:sp>
+        <p:nvSpPr>
+          <p:cNvPr id="2" name="Slide Image Placeholder 1"/>
+          <p:cNvSpPr>
+            <a:spLocks noGrp="1" noRot="1" noChangeAspect="1"/>
+          </p:cNvSpPr>
+          <p:nvPr>
+            <p:ph type="sldImg"/>
+          </p:nvPr>
+        </p:nvSpPr>
+        <p:spPr/>
+      </p:sp>
+      <p:sp>
+        <p:nvSpPr>
+          <p:cNvPr id="3" name="Notes Placeholder 2"/>
+          <p:cNvSpPr>
+            <a:spLocks noGrp="1"/>
+          </p:cNvSpPr>
+          <p:nvPr>
+            <p:ph type="body" idx="1"/>
+          </p:nvPr>
+        </p:nvSpPr>
+        <p:spPr/>
+        <p:txBody>
+          <a:bodyPr/>
+          <a:lstStyle/>
+          <a:p>
+            <a:r>
+              <a:rPr lang="en-US" b="0" baseline="0" dirty="0"/>
               <a:t>There is still a discussion about the type of function approximators used inside the whole architecture</a:t>
             </a:r>
           </a:p>
@@ -2729,7 +4587,7 @@
             </a:pPr>
             <a:r>
               <a:rPr lang="en-US" dirty="0"/>
-              <a:t>The next motivation comes from the work of psychologist Vygotsky</a:t>
+              <a:t>The next motivation comes from the work of psychologist Vygotsky.</a:t>
             </a:r>
           </a:p>
           <a:p>
@@ -2739,7 +4597,54 @@
             </a:pPr>
             <a:r>
               <a:rPr lang="en-US" dirty="0"/>
-              <a:t>According to Vygotsky, in his theory “Zone of proximal development”, a child requires some guidance to increase the zone of development.</a:t>
+              <a:t>Let us look at the picture on the right here.</a:t>
+            </a:r>
+          </a:p>
+          <a:p>
+            <a:pPr marL="673100" lvl="1" indent="-342900">
+              <a:buFont typeface="Arial" panose="020B0604020202020204" pitchFamily="34" charset="0"/>
+              <a:buChar char="•"/>
+            </a:pPr>
+            <a:r>
+              <a:rPr lang="en-US" dirty="0"/>
+              <a:t>There are 3 zones of skills for a child –</a:t>
+            </a:r>
+          </a:p>
+          <a:p>
+            <a:pPr marL="960438" lvl="2" indent="-342900">
+              <a:buFont typeface="Arial" panose="020B0604020202020204" pitchFamily="34" charset="0"/>
+              <a:buChar char="•"/>
+            </a:pPr>
+            <a:r>
+              <a:rPr lang="en-US" dirty="0"/>
+              <a:t>Inner skill zone. These are trivial zones. For example if a child know how to stack blocks, he will know how to stack books.</a:t>
+            </a:r>
+          </a:p>
+          <a:p>
+            <a:pPr marL="960438" lvl="2" indent="-342900">
+              <a:buFont typeface="Arial" panose="020B0604020202020204" pitchFamily="34" charset="0"/>
+              <a:buChar char="•"/>
+            </a:pPr>
+            <a:r>
+              <a:rPr lang="en-US" dirty="0"/>
+              <a:t>Middle skill zone. This is learnable using some guidance. Example, stacking a different shape instead of a tower</a:t>
+            </a:r>
+          </a:p>
+          <a:p>
+            <a:pPr marL="960438" lvl="2" indent="-342900">
+              <a:buFont typeface="Arial" panose="020B0604020202020204" pitchFamily="34" charset="0"/>
+              <a:buChar char="•"/>
+            </a:pPr>
+            <a:r>
+              <a:rPr lang="en-US" dirty="0"/>
+              <a:t>Outer skill zone. This are non-trivial accomplishable goals. For example for a child that has just learnt to stack blocks, it is almost impossible to </a:t>
+            </a:r>
+            <a:br>
+              <a:rPr lang="en-US" dirty="0"/>
+            </a:br>
+            <a:r>
+              <a:rPr lang="en-US" dirty="0"/>
+              <a:t>to create a complex Lego machine.</a:t>
             </a:r>
           </a:p>
           <a:p>
@@ -2749,7 +4654,7 @@
             </a:pPr>
             <a:r>
               <a:rPr lang="en-US" dirty="0"/>
-              <a:t>This is provided by scaffolding / guidance from some peer.</a:t>
+              <a:t>In summary, according to Vygotsky, in his theory “Zone of proximal development”, a child requires some guidance to increase the zone of development.</a:t>
             </a:r>
           </a:p>
           <a:p>
@@ -2759,7 +4664,7 @@
             </a:pPr>
             <a:r>
               <a:rPr lang="en-US" dirty="0"/>
-              <a:t>The medium of scaffolding is language when the parent is the social peer.</a:t>
+              <a:t>This is provided by guidance/scaffolding from some partner.</a:t>
             </a:r>
           </a:p>
           <a:p>
@@ -2769,7 +4674,7 @@
             </a:pPr>
             <a:r>
               <a:rPr lang="en-US" dirty="0"/>
-              <a:t>Hence the authors use language as a medium of aid.</a:t>
+              <a:t>Scaffolding can be thought of like this picture of a building construction. The framework is laid out first which guides the building that is constructed.</a:t>
             </a:r>
           </a:p>
           <a:p>
@@ -2779,6 +4684,26 @@
             </a:pPr>
             <a:r>
               <a:rPr lang="en-US" dirty="0"/>
+              <a:t>The medium of scaffolding is language in the parent-child scenario. The parent becomes the social partner giving guidance to the child.</a:t>
+            </a:r>
+          </a:p>
+          <a:p>
+            <a:pPr marL="342900" indent="-342900">
+              <a:buFont typeface="Arial" panose="020B0604020202020204" pitchFamily="34" charset="0"/>
+              <a:buChar char="•"/>
+            </a:pPr>
+            <a:r>
+              <a:rPr lang="en-US" dirty="0"/>
+              <a:t>Hence the authors use language as a medium of aid.</a:t>
+            </a:r>
+          </a:p>
+          <a:p>
+            <a:pPr marL="342900" indent="-342900">
+              <a:buFont typeface="Arial" panose="020B0604020202020204" pitchFamily="34" charset="0"/>
+              <a:buChar char="•"/>
+            </a:pPr>
+            <a:r>
+              <a:rPr lang="en-US" dirty="0"/>
               <a:t>Other reasons authors use language is </a:t>
             </a:r>
           </a:p>
@@ -2789,15 +4714,7 @@
             </a:pPr>
             <a:r>
               <a:rPr lang="en-US" dirty="0"/>
-              <a:t>Collective knowledge of 1000s of years is embedded in our </a:t>
-            </a:r>
-            <a:r>
-              <a:rPr lang="en-US" dirty="0" err="1"/>
-              <a:t>lanaguages</a:t>
-            </a:r>
-            <a:r>
-              <a:rPr lang="en-US" dirty="0"/>
-              <a:t>.</a:t>
+              <a:t>Collective knowledge of 1000s of years is embedded in our languages.</a:t>
             </a:r>
           </a:p>
           <a:p>
@@ -2809,209 +4726,6 @@
               <a:rPr lang="en-US" dirty="0"/>
               <a:t>Combinatorial compositionality of language makes it good for describing/formulating and imagining new goals.</a:t>
             </a:r>
-          </a:p>
-          <a:p>
-            <a:pPr marL="342900" lvl="0" indent="-342900">
-              <a:buFont typeface="Arial" panose="020B0604020202020204" pitchFamily="34" charset="0"/>
-              <a:buChar char="•"/>
-            </a:pPr>
-            <a:r>
-              <a:rPr lang="en-US" dirty="0"/>
-              <a:t>Another notable philosopher - </a:t>
-            </a:r>
-            <a:r>
-              <a:rPr lang="de-DE" sz="1400" b="1" i="0" kern="1200" dirty="0">
-                <a:solidFill>
-                  <a:schemeClr val="tx1"/>
-                </a:solidFill>
-                <a:effectLst/>
-                <a:latin typeface="Verdana"/>
-                <a:ea typeface="ＭＳ Ｐゴシック" charset="0"/>
-                <a:cs typeface="Verdana"/>
-              </a:rPr>
-              <a:t>Mortimer J. Adler.</a:t>
-            </a:r>
-            <a:r>
-              <a:rPr lang="de-DE" sz="1400" b="0" i="0" kern="1200" dirty="0">
-                <a:solidFill>
-                  <a:schemeClr val="tx1"/>
-                </a:solidFill>
-                <a:effectLst/>
-                <a:latin typeface="Verdana"/>
-                <a:ea typeface="ＭＳ Ｐゴシック" charset="0"/>
-                <a:cs typeface="Verdana"/>
-              </a:rPr>
-              <a:t> </a:t>
-            </a:r>
-            <a:r>
-              <a:rPr lang="de-DE" sz="1400" b="0" i="0" kern="1200" dirty="0" err="1">
-                <a:solidFill>
-                  <a:schemeClr val="tx1"/>
-                </a:solidFill>
-                <a:effectLst/>
-                <a:latin typeface="Verdana"/>
-                <a:ea typeface="ＭＳ Ｐゴシック" charset="0"/>
-                <a:cs typeface="Verdana"/>
-              </a:rPr>
-              <a:t>Considers</a:t>
-            </a:r>
-            <a:r>
-              <a:rPr lang="de-DE" sz="1400" b="0" i="0" kern="1200" dirty="0">
-                <a:solidFill>
-                  <a:schemeClr val="tx1"/>
-                </a:solidFill>
-                <a:effectLst/>
-                <a:latin typeface="Verdana"/>
-                <a:ea typeface="ＭＳ Ｐゴシック" charset="0"/>
-                <a:cs typeface="Verdana"/>
-              </a:rPr>
-              <a:t> </a:t>
-            </a:r>
-            <a:r>
-              <a:rPr lang="de-DE" sz="1400" b="0" i="0" kern="1200" dirty="0" err="1">
-                <a:solidFill>
-                  <a:schemeClr val="tx1"/>
-                </a:solidFill>
-                <a:effectLst/>
-                <a:latin typeface="Verdana"/>
-                <a:ea typeface="ＭＳ Ｐゴシック" charset="0"/>
-                <a:cs typeface="Verdana"/>
-              </a:rPr>
-              <a:t>learning</a:t>
-            </a:r>
-            <a:r>
-              <a:rPr lang="de-DE" sz="1400" b="0" i="0" kern="1200" dirty="0">
-                <a:solidFill>
-                  <a:schemeClr val="tx1"/>
-                </a:solidFill>
-                <a:effectLst/>
-                <a:latin typeface="Verdana"/>
-                <a:ea typeface="ＭＳ Ｐゴシック" charset="0"/>
-                <a:cs typeface="Verdana"/>
-              </a:rPr>
-              <a:t> </a:t>
-            </a:r>
-            <a:r>
-              <a:rPr lang="de-DE" sz="1400" b="0" i="0" kern="1200" dirty="0" err="1">
-                <a:solidFill>
-                  <a:schemeClr val="tx1"/>
-                </a:solidFill>
-                <a:effectLst/>
-                <a:latin typeface="Verdana"/>
-                <a:ea typeface="ＭＳ Ｐゴシック" charset="0"/>
-                <a:cs typeface="Verdana"/>
-              </a:rPr>
-              <a:t>by</a:t>
-            </a:r>
-            <a:r>
-              <a:rPr lang="de-DE" sz="1400" b="0" i="0" kern="1200" dirty="0">
-                <a:solidFill>
-                  <a:schemeClr val="tx1"/>
-                </a:solidFill>
-                <a:effectLst/>
-                <a:latin typeface="Verdana"/>
-                <a:ea typeface="ＭＳ Ｐゴシック" charset="0"/>
-                <a:cs typeface="Verdana"/>
-              </a:rPr>
-              <a:t> </a:t>
-            </a:r>
-            <a:r>
-              <a:rPr lang="de-DE" sz="1400" b="0" i="0" kern="1200" dirty="0" err="1">
-                <a:solidFill>
-                  <a:schemeClr val="tx1"/>
-                </a:solidFill>
-                <a:effectLst/>
-                <a:latin typeface="Verdana"/>
-                <a:ea typeface="ＭＳ Ｐゴシック" charset="0"/>
-                <a:cs typeface="Verdana"/>
-              </a:rPr>
-              <a:t>aided</a:t>
-            </a:r>
-            <a:r>
-              <a:rPr lang="de-DE" sz="1400" b="0" i="0" kern="1200" dirty="0">
-                <a:solidFill>
-                  <a:schemeClr val="tx1"/>
-                </a:solidFill>
-                <a:effectLst/>
-                <a:latin typeface="Verdana"/>
-                <a:ea typeface="ＭＳ Ｐゴシック" charset="0"/>
-                <a:cs typeface="Verdana"/>
-              </a:rPr>
-              <a:t> </a:t>
-            </a:r>
-            <a:r>
-              <a:rPr lang="de-DE" sz="1400" b="0" i="0" kern="1200" dirty="0" err="1">
-                <a:solidFill>
-                  <a:schemeClr val="tx1"/>
-                </a:solidFill>
-                <a:effectLst/>
-                <a:latin typeface="Verdana"/>
-                <a:ea typeface="ＭＳ Ｐゴシック" charset="0"/>
-                <a:cs typeface="Verdana"/>
-              </a:rPr>
-              <a:t>discovery</a:t>
-            </a:r>
-            <a:r>
-              <a:rPr lang="de-DE" sz="1400" b="0" i="0" kern="1200" dirty="0">
-                <a:solidFill>
-                  <a:schemeClr val="tx1"/>
-                </a:solidFill>
-                <a:effectLst/>
-                <a:latin typeface="Verdana"/>
-                <a:ea typeface="ＭＳ Ｐゴシック" charset="0"/>
-                <a:cs typeface="Verdana"/>
-              </a:rPr>
-              <a:t> </a:t>
-            </a:r>
-            <a:r>
-              <a:rPr lang="de-DE" sz="1400" b="0" i="0" kern="1200" dirty="0" err="1">
-                <a:solidFill>
-                  <a:schemeClr val="tx1"/>
-                </a:solidFill>
-                <a:effectLst/>
-                <a:latin typeface="Verdana"/>
-                <a:ea typeface="ＭＳ Ｐゴシック" charset="0"/>
-                <a:cs typeface="Verdana"/>
-              </a:rPr>
-              <a:t>through</a:t>
-            </a:r>
-            <a:r>
-              <a:rPr lang="de-DE" sz="1400" b="0" i="0" kern="1200" dirty="0">
-                <a:solidFill>
-                  <a:schemeClr val="tx1"/>
-                </a:solidFill>
-                <a:effectLst/>
-                <a:latin typeface="Verdana"/>
-                <a:ea typeface="ＭＳ Ｐゴシック" charset="0"/>
-                <a:cs typeface="Verdana"/>
-              </a:rPr>
-              <a:t> </a:t>
-            </a:r>
-            <a:r>
-              <a:rPr lang="de-DE" sz="1400" b="0" i="0" kern="1200" dirty="0" err="1">
-                <a:solidFill>
-                  <a:schemeClr val="tx1"/>
-                </a:solidFill>
-                <a:effectLst/>
-                <a:latin typeface="Verdana"/>
-                <a:ea typeface="ＭＳ Ｐゴシック" charset="0"/>
-                <a:cs typeface="Verdana"/>
-              </a:rPr>
-              <a:t>reading</a:t>
-            </a:r>
-            <a:r>
-              <a:rPr lang="de-DE" sz="1400" b="0" i="0" kern="1200" dirty="0">
-                <a:solidFill>
-                  <a:schemeClr val="tx1"/>
-                </a:solidFill>
-                <a:effectLst/>
-                <a:latin typeface="Verdana"/>
-                <a:ea typeface="ＭＳ Ｐゴシック" charset="0"/>
-                <a:cs typeface="Verdana"/>
-              </a:rPr>
-              <a:t>.</a:t>
-            </a:r>
-            <a:endParaRPr lang="en-US" dirty="0"/>
           </a:p>
           <a:p>
             <a:pPr marL="342900" indent="-342900">
@@ -3116,13 +4830,13 @@
           <a:p>
             <a:r>
               <a:rPr lang="en-US" baseline="0" dirty="0"/>
-              <a:t>Because of these 2 stages we have 2 stages/levels of generalization.</a:t>
+              <a:t>So lets move forward to define our problem. What exactly is being solved here?</a:t>
             </a:r>
           </a:p>
           <a:p>
             <a:r>
               <a:rPr lang="en-US" baseline="0" dirty="0"/>
-              <a:t>Traditionally in RL we give the goal by using the reward function.</a:t>
+              <a:t>Accomplishing a task can be divided into 2 stages. – Understand the Task. Complete the task.</a:t>
             </a:r>
           </a:p>
           <a:p>
@@ -3132,9 +4846,34 @@
             </a:r>
           </a:p>
           <a:p>
+            <a:pPr marL="285750" marR="0" lvl="0" indent="-285750" algn="l" defTabSz="914400" rtl="0" eaLnBrk="0" fontAlgn="base" latinLnBrk="0" hangingPunct="0">
+              <a:lnSpc>
+                <a:spcPct val="100000"/>
+              </a:lnSpc>
+              <a:spcBef>
+                <a:spcPct val="30000"/>
+              </a:spcBef>
+              <a:spcAft>
+                <a:spcPct val="0"/>
+              </a:spcAft>
+              <a:buClr>
+                <a:srgbClr val="800000"/>
+              </a:buClr>
+              <a:buSzTx/>
+              <a:buFont typeface="Wingdings" charset="2"/>
+              <a:buChar char="§"/>
+              <a:tabLst/>
+              <a:defRPr/>
+            </a:pPr>
             <a:r>
               <a:rPr lang="en-US" baseline="0" dirty="0"/>
-              <a:t>One concept that is essential to understand is –</a:t>
+              <a:t>Because of these 2 stages we have 2 stages/levels of generalization.</a:t>
+            </a:r>
+          </a:p>
+          <a:p>
+            <a:r>
+              <a:rPr lang="en-US" baseline="0" dirty="0"/>
+              <a:t>This concept is essential to understand –</a:t>
             </a:r>
           </a:p>
           <a:p>
@@ -3155,13 +4894,13 @@
             <a:pPr lvl="1"/>
             <a:r>
               <a:rPr lang="en-US" baseline="0" dirty="0"/>
-              <a:t>Goal space generalization. </a:t>
+              <a:t>Goal generalization. </a:t>
             </a:r>
             <a:r>
               <a:rPr lang="en-US" baseline="0" dirty="0">
                 <a:sym typeface="Wingdings" pitchFamily="2" charset="2"/>
               </a:rPr>
-              <a:t> This is a higher generalization.</a:t>
+              <a:t> This is a generalization at a higher abstraction.</a:t>
             </a:r>
           </a:p>
           <a:p>
@@ -3181,13 +4920,118 @@
               </a:rPr>
               <a:t>The second is policy generalization across a goals.</a:t>
             </a:r>
+          </a:p>
+          <a:p>
+            <a:pPr marL="285750" marR="0" lvl="0" indent="-285750" algn="l" defTabSz="914400" rtl="0" eaLnBrk="0" fontAlgn="base" latinLnBrk="0" hangingPunct="0">
+              <a:lnSpc>
+                <a:spcPct val="100000"/>
+              </a:lnSpc>
+              <a:spcBef>
+                <a:spcPct val="30000"/>
+              </a:spcBef>
+              <a:spcAft>
+                <a:spcPct val="0"/>
+              </a:spcAft>
+              <a:buClr>
+                <a:srgbClr val="800000"/>
+              </a:buClr>
+              <a:buSzTx/>
+              <a:buFont typeface="Wingdings" charset="2"/>
+              <a:buChar char="§"/>
+              <a:tabLst/>
+              <a:defRPr/>
+            </a:pPr>
+            <a:r>
+              <a:rPr lang="en-US" sz="2000" baseline="0" dirty="0">
+                <a:sym typeface="Wingdings" pitchFamily="2" charset="2"/>
+              </a:rPr>
+              <a:t>Take for example moving objects in the x-y plane.</a:t>
+            </a:r>
+          </a:p>
+          <a:p>
+            <a:pPr marL="615950" marR="0" lvl="1" indent="-285750" algn="l" defTabSz="914400" rtl="0" eaLnBrk="0" fontAlgn="base" latinLnBrk="0" hangingPunct="0">
+              <a:lnSpc>
+                <a:spcPct val="100000"/>
+              </a:lnSpc>
+              <a:spcBef>
+                <a:spcPct val="30000"/>
+              </a:spcBef>
+              <a:spcAft>
+                <a:spcPct val="0"/>
+              </a:spcAft>
+              <a:buClr>
+                <a:srgbClr val="800000"/>
+              </a:buClr>
+              <a:buSzTx/>
+              <a:buFont typeface="Wingdings" charset="2"/>
+              <a:buChar char="§"/>
+              <a:tabLst/>
+              <a:defRPr/>
+            </a:pPr>
+            <a:r>
+              <a:rPr lang="en-US" sz="2000" baseline="0" dirty="0">
+                <a:sym typeface="Wingdings" pitchFamily="2" charset="2"/>
+              </a:rPr>
+              <a:t>If an agent after learning to move an object from (1,0) to (3,3) does the same job moving object from (4,5) to (0,0) This is called state space generalization.</a:t>
+            </a:r>
+          </a:p>
+          <a:p>
+            <a:pPr marL="615950" marR="0" lvl="1" indent="-285750" algn="l" defTabSz="914400" rtl="0" eaLnBrk="0" fontAlgn="base" latinLnBrk="0" hangingPunct="0">
+              <a:lnSpc>
+                <a:spcPct val="100000"/>
+              </a:lnSpc>
+              <a:spcBef>
+                <a:spcPct val="30000"/>
+              </a:spcBef>
+              <a:spcAft>
+                <a:spcPct val="0"/>
+              </a:spcAft>
+              <a:buClr>
+                <a:srgbClr val="800000"/>
+              </a:buClr>
+              <a:buSzTx/>
+              <a:buFont typeface="Wingdings" charset="2"/>
+              <a:buChar char="§"/>
+              <a:tabLst/>
+              <a:defRPr/>
+            </a:pPr>
+            <a:r>
+              <a:rPr lang="en-US" sz="2000" baseline="0" dirty="0">
+                <a:sym typeface="Wingdings" pitchFamily="2" charset="2"/>
+              </a:rPr>
+              <a:t>If on the other hand it can also move a table from (1,0) to (3,3) this is goal generalization.</a:t>
+            </a:r>
+          </a:p>
+          <a:p>
+            <a:pPr marL="285750" marR="0" lvl="0" indent="-285750" algn="l" defTabSz="914400" rtl="0" eaLnBrk="0" fontAlgn="base" latinLnBrk="0" hangingPunct="0">
+              <a:lnSpc>
+                <a:spcPct val="100000"/>
+              </a:lnSpc>
+              <a:spcBef>
+                <a:spcPct val="30000"/>
+              </a:spcBef>
+              <a:spcAft>
+                <a:spcPct val="0"/>
+              </a:spcAft>
+              <a:buClr>
+                <a:srgbClr val="800000"/>
+              </a:buClr>
+              <a:buSzTx/>
+              <a:buFont typeface="Wingdings" charset="2"/>
+              <a:buChar char="§"/>
+              <a:tabLst/>
+              <a:defRPr/>
+            </a:pPr>
+            <a:r>
+              <a:rPr lang="en-US" sz="2000" baseline="0" dirty="0">
+                <a:sym typeface="Wingdings" pitchFamily="2" charset="2"/>
+              </a:rPr>
+              <a:t>To generalize we need to explore in both cases.</a:t>
+            </a:r>
+          </a:p>
+          <a:p>
+            <a:pPr lvl="0"/>
             <a:endParaRPr lang="de-DE" sz="2000" dirty="0"/>
-          </a:p>
-          <a:p>
-            <a:pPr lvl="0"/>
-            <a:endParaRPr lang="en-US" baseline="0" dirty="0">
-              <a:sym typeface="Wingdings" pitchFamily="2" charset="2"/>
-            </a:endParaRPr>
           </a:p>
         </p:txBody>
       </p:sp>
@@ -3277,18 +5121,6 @@
           <a:bodyPr/>
           <a:lstStyle/>
           <a:p>
-            <a:r>
-              <a:rPr lang="en-US" b="0" baseline="0" dirty="0"/>
-              <a:t>Traditional RL does not have this problem because the goals are given in terms of reward functions.</a:t>
-            </a:r>
-          </a:p>
-          <a:p>
-            <a:r>
-              <a:rPr lang="en-US" b="0" baseline="0" dirty="0"/>
-              <a:t>What I would like you to observe is that the problem of generalization and exploration remain the same.</a:t>
-            </a:r>
-          </a:p>
-          <a:p>
             <a:pPr marL="285750" marR="0" lvl="0" indent="-285750" algn="l" defTabSz="914400" rtl="0" eaLnBrk="0" fontAlgn="base" latinLnBrk="0" hangingPunct="0">
               <a:lnSpc>
                 <a:spcPct val="100000"/>
@@ -3309,55 +5141,40 @@
               <a:defRPr/>
             </a:pPr>
             <a:r>
-              <a:rPr lang="de-DE" sz="1400" dirty="0" err="1"/>
-              <a:t>Some</a:t>
-            </a:r>
-            <a:r>
-              <a:rPr lang="de-DE" sz="1400" dirty="0"/>
-              <a:t> </a:t>
-            </a:r>
-            <a:r>
-              <a:rPr lang="de-DE" sz="1400" dirty="0" err="1"/>
-              <a:t>of</a:t>
-            </a:r>
-            <a:r>
-              <a:rPr lang="de-DE" sz="1400" dirty="0"/>
-              <a:t> </a:t>
-            </a:r>
-            <a:r>
-              <a:rPr lang="de-DE" sz="1400" dirty="0" err="1"/>
-              <a:t>then</a:t>
-            </a:r>
-            <a:r>
-              <a:rPr lang="de-DE" sz="1400" dirty="0"/>
-              <a:t> </a:t>
-            </a:r>
-            <a:r>
-              <a:rPr lang="de-DE" sz="1400" dirty="0" err="1"/>
-              <a:t>hardcoded</a:t>
-            </a:r>
-            <a:r>
-              <a:rPr lang="de-DE" sz="1400" dirty="0"/>
-              <a:t> </a:t>
-            </a:r>
-            <a:r>
-              <a:rPr lang="de-DE" sz="1400" dirty="0" err="1"/>
-              <a:t>the</a:t>
-            </a:r>
-            <a:r>
-              <a:rPr lang="de-DE" sz="1400" dirty="0"/>
-              <a:t> </a:t>
-            </a:r>
-            <a:r>
-              <a:rPr lang="de-DE" sz="1400" dirty="0" err="1"/>
-              <a:t>representations</a:t>
-            </a:r>
-            <a:endParaRPr lang="en-US" b="0" baseline="0" dirty="0"/>
-          </a:p>
-          <a:p>
-            <a:r>
               <a:rPr lang="en-US" b="0" baseline="0" dirty="0"/>
-              <a:t>Only the abstraction of our application changes.</a:t>
+              <a:t>As state space generalization is trivial, we talk about goal generalization.</a:t>
+            </a:r>
+          </a:p>
+          <a:p>
+            <a:r>
+              <a:rPr lang="en-US" b="0" baseline="0" dirty="0"/>
+              <a:t>Traditional RL does not have this problem because the goals are given in terms of reward functions.</a:t>
+            </a:r>
+          </a:p>
+          <a:p>
+            <a:r>
+              <a:rPr lang="en-US" b="0" baseline="0" dirty="0"/>
+              <a:t>What I would like you to observe is that the problem of generalization and exploration essentially is the same -- it only differs in the level of abstraction.</a:t>
+            </a:r>
+          </a:p>
+          <a:p>
+            <a:r>
+              <a:rPr lang="en-US" b="0" baseline="0" dirty="0"/>
+              <a:t>What are the previous works that have tried goal generalization?</a:t>
+            </a:r>
+          </a:p>
+          <a:p>
+            <a:pPr lvl="1"/>
+            <a:r>
+              <a:rPr lang="en-US" b="0" baseline="0" dirty="0"/>
+              <a:t>Firstly they represented the goals as a Euclidean vector.</a:t>
+            </a:r>
+          </a:p>
+          <a:p>
+            <a:pPr lvl="1"/>
+            <a:r>
+              <a:rPr lang="en-US" b="0" baseline="0" dirty="0"/>
+              <a:t>They used generation mechanisms like Generative Adversarial Networks or Variational auto encoder to generate the goals.</a:t>
             </a:r>
           </a:p>
           <a:p>
@@ -3456,6 +5273,12 @@
           <a:p>
             <a:r>
               <a:rPr lang="en-US" b="0" baseline="0" dirty="0"/>
+              <a:t>Comment - Consider showing the left half.</a:t>
+            </a:r>
+          </a:p>
+          <a:p>
+            <a:r>
+              <a:rPr lang="en-US" b="0" baseline="0" dirty="0"/>
               <a:t>This is the proposed agent by the authors. They call it IMAGINE.</a:t>
             </a:r>
           </a:p>
@@ -3468,7 +5291,39 @@
           <a:p>
             <a:r>
               <a:rPr lang="en-US" b="0" baseline="0" dirty="0"/>
-              <a:t>But let me explain some things we do understand.</a:t>
+              <a:t>But let us break things one by one to understand the components</a:t>
+            </a:r>
+          </a:p>
+          <a:p>
+            <a:pPr lvl="1"/>
+            <a:r>
+              <a:rPr lang="en-US" b="0" baseline="0" dirty="0"/>
+              <a:t>Social Partner - We have a social partner as discussed previously.</a:t>
+            </a:r>
+          </a:p>
+          <a:p>
+            <a:pPr marL="615950" marR="0" lvl="1" indent="-285750" algn="l" defTabSz="914400" rtl="0" eaLnBrk="0" fontAlgn="base" latinLnBrk="0" hangingPunct="0">
+              <a:lnSpc>
+                <a:spcPct val="100000"/>
+              </a:lnSpc>
+              <a:spcBef>
+                <a:spcPct val="30000"/>
+              </a:spcBef>
+              <a:spcAft>
+                <a:spcPct val="0"/>
+              </a:spcAft>
+              <a:buClr>
+                <a:srgbClr val="800000"/>
+              </a:buClr>
+              <a:buSzTx/>
+              <a:buFont typeface="Wingdings" charset="2"/>
+              <a:buChar char="§"/>
+              <a:tabLst/>
+              <a:defRPr/>
+            </a:pPr>
+            <a:r>
+              <a:rPr lang="en-US" b="0" baseline="0" dirty="0"/>
+              <a:t>There is a Goal Generation (Which we will talk in a little while)</a:t>
             </a:r>
           </a:p>
           <a:p>
@@ -3617,6 +5472,86 @@
           <a:bodyPr/>
           <a:lstStyle/>
           <a:p>
+            <a:r>
+              <a:rPr lang="en-US" b="0" baseline="0" dirty="0"/>
+              <a:t>A 2 dimensional limited space containing different objects.</a:t>
+            </a:r>
+          </a:p>
+          <a:p>
+            <a:pPr lvl="1"/>
+            <a:r>
+              <a:rPr lang="en-US" b="0" baseline="0" dirty="0"/>
+              <a:t>List of objects are listed on the right bottom.</a:t>
+            </a:r>
+          </a:p>
+          <a:p>
+            <a:pPr lvl="0"/>
+            <a:r>
+              <a:rPr lang="en-US" b="0" baseline="0" dirty="0"/>
+              <a:t>Each object is represented as a circle. With a radius.</a:t>
+            </a:r>
+          </a:p>
+          <a:p>
+            <a:pPr lvl="0"/>
+            <a:r>
+              <a:rPr lang="en-US" b="0" baseline="0" dirty="0"/>
+              <a:t>Even the agent is represented by a circle with an agent. (For showing the authors show the different objects)</a:t>
+            </a:r>
+          </a:p>
+          <a:p>
+            <a:r>
+              <a:rPr lang="en-US" b="0" baseline="0" dirty="0"/>
+              <a:t>There is predicate hierarchy which is not told to our agent</a:t>
+            </a:r>
+          </a:p>
+          <a:p>
+            <a:pPr lvl="1"/>
+            <a:r>
+              <a:rPr lang="en-US" b="0" baseline="0" dirty="0"/>
+              <a:t>This helps for testing the generalization, the agent has to generalize based on predicates.</a:t>
+            </a:r>
+          </a:p>
+          <a:p>
+            <a:pPr lvl="1"/>
+            <a:r>
+              <a:rPr lang="en-US" b="0" baseline="0" dirty="0"/>
+              <a:t>Observe the main categories – Living things, furniture and food/water supply.</a:t>
+            </a:r>
+          </a:p>
+          <a:p>
+            <a:pPr lvl="1"/>
+            <a:r>
+              <a:rPr lang="en-US" b="0" baseline="0" dirty="0"/>
+              <a:t>This can be viewed as a farm.</a:t>
+            </a:r>
+          </a:p>
+          <a:p>
+            <a:pPr marL="285750" marR="0" lvl="0" indent="-285750" algn="l" defTabSz="914400" rtl="0" eaLnBrk="0" fontAlgn="base" latinLnBrk="0" hangingPunct="0">
+              <a:lnSpc>
+                <a:spcPct val="100000"/>
+              </a:lnSpc>
+              <a:spcBef>
+                <a:spcPct val="30000"/>
+              </a:spcBef>
+              <a:spcAft>
+                <a:spcPct val="0"/>
+              </a:spcAft>
+              <a:buClr>
+                <a:srgbClr val="800000"/>
+              </a:buClr>
+              <a:buSzTx/>
+              <a:buFont typeface="Wingdings" charset="2"/>
+              <a:buChar char="§"/>
+              <a:tabLst/>
+              <a:defRPr/>
+            </a:pPr>
+            <a:r>
+              <a:rPr lang="en-US" b="0" baseline="0" dirty="0"/>
+              <a:t>There are 3 basic commands that can be executed by the agent – Go Grasp Grow.</a:t>
+            </a:r>
+          </a:p>
+          <a:p>
+            <a:pPr lvl="0"/>
             <a:endParaRPr lang="en-US" b="0" baseline="0" dirty="0"/>
           </a:p>
         </p:txBody>
@@ -3707,7 +5642,29 @@
           <a:bodyPr/>
           <a:lstStyle/>
           <a:p>
-            <a:endParaRPr lang="en-US" b="0" baseline="0" dirty="0"/>
+            <a:r>
+              <a:rPr lang="en-US" b="0" baseline="0" dirty="0"/>
+              <a:t>To Give you an idea of how the environment is quantified, I have put this slide here.</a:t>
+            </a:r>
+          </a:p>
+          <a:p>
+            <a:r>
+              <a:rPr lang="en-US" b="0" baseline="0" dirty="0"/>
+              <a:t>Explain object, agent action and observation</a:t>
+            </a:r>
+          </a:p>
+          <a:p>
+            <a:r>
+              <a:rPr lang="en-US" b="0" baseline="0" dirty="0"/>
+              <a:t>The state is a combination of observation and delta observation.</a:t>
+            </a:r>
+          </a:p>
+          <a:p>
+            <a:pPr lvl="1"/>
+            <a:r>
+              <a:rPr lang="en-US" b="0" baseline="0" dirty="0"/>
+              <a:t>This helps us quantify and account for the growth of an object in the environment</a:t>
+            </a:r>
           </a:p>
         </p:txBody>
       </p:sp>
@@ -3797,7 +5754,78 @@
           <a:bodyPr/>
           <a:lstStyle/>
           <a:p>
-            <a:endParaRPr lang="en-US" b="0" baseline="0" dirty="0"/>
+            <a:r>
+              <a:rPr lang="en-US" b="0" baseline="0" dirty="0"/>
+              <a:t>Fundamental Idea – Use language compositionality to generate new goals.</a:t>
+            </a:r>
+          </a:p>
+          <a:p>
+            <a:r>
+              <a:rPr lang="en-US" b="0" baseline="0" dirty="0"/>
+              <a:t>How is language compositionality actually utilized.</a:t>
+            </a:r>
+          </a:p>
+          <a:p>
+            <a:r>
+              <a:rPr lang="en-US" b="0" baseline="0" dirty="0"/>
+              <a:t>Lets first talk about the jargon.</a:t>
+            </a:r>
+          </a:p>
+          <a:p>
+            <a:pPr lvl="1"/>
+            <a:r>
+              <a:rPr lang="en-US" b="0" baseline="0" dirty="0"/>
+              <a:t>An atom is a word (Which makes sense because it is semantically unbreakable)</a:t>
+            </a:r>
+          </a:p>
+          <a:p>
+            <a:pPr lvl="1"/>
+            <a:r>
+              <a:rPr lang="en-US" b="0" baseline="0" dirty="0"/>
+              <a:t>A Compound is a obtained using the composition of atoms.</a:t>
+            </a:r>
+          </a:p>
+          <a:p>
+            <a:pPr lvl="1"/>
+            <a:r>
+              <a:rPr lang="en-US" b="0" baseline="0" dirty="0"/>
+              <a:t>This is also called a goal.</a:t>
+            </a:r>
+          </a:p>
+          <a:p>
+            <a:pPr lvl="0"/>
+            <a:r>
+              <a:rPr lang="en-US" b="0" baseline="0" dirty="0"/>
+              <a:t>I have listed the grammar at the bottom.</a:t>
+            </a:r>
+          </a:p>
+          <a:p>
+            <a:pPr lvl="0"/>
+            <a:r>
+              <a:rPr lang="en-US" b="0" baseline="0" dirty="0"/>
+              <a:t>Observer the main actions that an agent can do –</a:t>
+            </a:r>
+          </a:p>
+          <a:p>
+            <a:pPr lvl="1"/>
+            <a:r>
+              <a:rPr lang="en-US" b="0" baseline="0" dirty="0"/>
+              <a:t>Go</a:t>
+            </a:r>
+          </a:p>
+          <a:p>
+            <a:pPr lvl="1"/>
+            <a:r>
+              <a:rPr lang="en-US" b="0" baseline="0" dirty="0"/>
+              <a:t>Grasp</a:t>
+            </a:r>
+          </a:p>
+          <a:p>
+            <a:pPr lvl="1"/>
+            <a:r>
+              <a:rPr lang="en-US" b="0" baseline="0" dirty="0"/>
+              <a:t>Grow</a:t>
+            </a:r>
           </a:p>
         </p:txBody>
       </p:sp>
@@ -5944,7 +7972,7 @@
               </a14:hiddenEffects>
             </a:ext>
             <a:ext uri="{FAA26D3D-D897-4be2-8F04-BA451C77F1D7}">
-              <ma14:placeholderFlag xmlns:ma14="http://schemas.microsoft.com/office/mac/drawingml/2011/main" xmlns="" val="1"/>
+              <ma14:placeholderFlag xmlns="" xmlns:ma14="http://schemas.microsoft.com/office/mac/drawingml/2011/main" val="1"/>
             </a:ext>
           </a:extLst>
         </p:spPr>
@@ -6018,7 +8046,7 @@
               </a14:hiddenEffects>
             </a:ext>
             <a:ext uri="{FAA26D3D-D897-4be2-8F04-BA451C77F1D7}">
-              <ma14:placeholderFlag xmlns:ma14="http://schemas.microsoft.com/office/mac/drawingml/2011/main" xmlns="" val="1"/>
+              <ma14:placeholderFlag xmlns="" xmlns:ma14="http://schemas.microsoft.com/office/mac/drawingml/2011/main" val="1"/>
             </a:ext>
           </a:extLst>
         </p:spPr>
@@ -6618,7 +8646,7 @@
               </a14:hiddenEffects>
             </a:ext>
             <a:ext uri="{FAA26D3D-D897-4be2-8F04-BA451C77F1D7}">
-              <ma14:placeholderFlag xmlns:ma14="http://schemas.microsoft.com/office/mac/drawingml/2011/main" xmlns="" val="1"/>
+              <ma14:placeholderFlag xmlns="" xmlns:ma14="http://schemas.microsoft.com/office/mac/drawingml/2011/main" val="1"/>
             </a:ext>
           </a:extLst>
         </p:spPr>
@@ -6982,7 +9010,15 @@
           <a:p>
             <a:r>
               <a:rPr lang="en-US" dirty="0"/>
-              <a:t>Essence of the algorithm:</a:t>
+              <a:t>Essence of the </a:t>
+            </a:r>
+            <a:r>
+              <a:rPr lang="en-US" b="1" dirty="0"/>
+              <a:t>IMAGINE</a:t>
+            </a:r>
+            <a:r>
+              <a:rPr lang="en-US" dirty="0"/>
+              <a:t> algorithm:</a:t>
             </a:r>
           </a:p>
           <a:p>
@@ -6992,14 +9028,7 @@
             </a:pPr>
             <a:r>
               <a:rPr lang="en-US" dirty="0"/>
-              <a:t>Compute sets of equivalent</a:t>
-            </a:r>
-            <a:br>
-              <a:rPr lang="en-US" dirty="0"/>
-            </a:br>
-            <a:r>
-              <a:rPr lang="en-US" dirty="0"/>
-              <a:t>atoms</a:t>
+              <a:t>Compute sets of equivalent atoms.</a:t>
             </a:r>
           </a:p>
           <a:p>
@@ -7009,15 +9038,25 @@
             </a:pPr>
             <a:r>
               <a:rPr lang="en-US" dirty="0"/>
-              <a:t>Atoms are equivalent if the edit</a:t>
-            </a:r>
-            <a:br>
+              <a:t>Atoms are equivalent if the edit distance between the compounds is 1</a:t>
+            </a:r>
+          </a:p>
+          <a:p>
+            <a:pPr marL="1085850" lvl="2">
+              <a:buFont typeface="Arial" panose="020B0604020202020204" pitchFamily="34" charset="0"/>
+              <a:buChar char="•"/>
+            </a:pPr>
+            <a:r>
               <a:rPr lang="en-US" dirty="0"/>
-            </a:br>
-            <a:r>
-              <a:rPr lang="en-US" dirty="0"/>
-              <a:t>distance between them is 1</a:t>
-            </a:r>
+              <a:t>E.g. “Move Red Table” and “Move Red Chair” </a:t>
+            </a:r>
+            <a:r>
+              <a:rPr lang="en-US" dirty="0">
+                <a:sym typeface="Wingdings" pitchFamily="2" charset="2"/>
+              </a:rPr>
+              <a:t> Table and Chair are equivalent.</a:t>
+            </a:r>
+            <a:endParaRPr lang="en-US" dirty="0"/>
           </a:p>
           <a:p>
             <a:pPr marL="685800" lvl="1">
@@ -7026,38 +9065,17 @@
             </a:pPr>
             <a:r>
               <a:rPr lang="en-US" dirty="0"/>
-              <a:t>By substituting the equivalent</a:t>
-            </a:r>
-            <a:br>
-              <a:rPr lang="en-US" dirty="0"/>
-            </a:br>
-            <a:r>
-              <a:rPr lang="en-US" dirty="0"/>
-              <a:t>words, compute all possible</a:t>
-            </a:r>
-            <a:br>
-              <a:rPr lang="en-US" dirty="0"/>
-            </a:br>
-            <a:r>
-              <a:rPr lang="en-US" dirty="0"/>
-              <a:t>new goals (Compounds).</a:t>
-            </a:r>
-          </a:p>
-          <a:p>
-            <a:pPr marL="685800" lvl="1">
+              <a:t>Use substitution to generate new goals.</a:t>
+            </a:r>
+          </a:p>
+          <a:p>
+            <a:pPr marL="1085850" lvl="2">
               <a:buFont typeface="Arial" panose="020B0604020202020204" pitchFamily="34" charset="0"/>
               <a:buChar char="•"/>
             </a:pPr>
             <a:r>
               <a:rPr lang="en-US" dirty="0"/>
-              <a:t>Filter out Compounds that are</a:t>
-            </a:r>
-            <a:br>
-              <a:rPr lang="en-US" dirty="0"/>
-            </a:br>
-            <a:r>
-              <a:rPr lang="en-US" dirty="0"/>
-              <a:t>known</a:t>
+              <a:t>E.g. If known goal = “Break Red Chair”, new goal = “Break Red Table.”</a:t>
             </a:r>
           </a:p>
           <a:p>
@@ -7114,6 +9132,260 @@
         </p:nvSpPr>
         <p:spPr>
           <a:xfrm>
+            <a:off x="369728" y="391180"/>
+            <a:ext cx="8545672" cy="523220"/>
+          </a:xfrm>
+        </p:spPr>
+        <p:txBody>
+          <a:bodyPr/>
+          <a:lstStyle/>
+          <a:p>
+            <a:r>
+              <a:rPr lang="en-US" dirty="0"/>
+              <a:t>Language Encoder, Reward and Policy</a:t>
+            </a:r>
+          </a:p>
+        </p:txBody>
+      </p:sp>
+      <p:sp>
+        <p:nvSpPr>
+          <p:cNvPr id="3" name="Slide Number Placeholder 2"/>
+          <p:cNvSpPr>
+            <a:spLocks noGrp="1"/>
+          </p:cNvSpPr>
+          <p:nvPr>
+            <p:ph type="sldNum" sz="quarter" idx="10"/>
+          </p:nvPr>
+        </p:nvSpPr>
+        <p:spPr/>
+        <p:txBody>
+          <a:bodyPr/>
+          <a:lstStyle/>
+          <a:p>
+            <a:fld id="{6BC48003-D90B-4677-A057-B663AA3C6CCD}" type="slidenum">
+              <a:rPr lang="en-US" smtClean="0"/>
+              <a:pPr/>
+              <a:t>11</a:t>
+            </a:fld>
+            <a:endParaRPr lang="en-US" dirty="0"/>
+          </a:p>
+        </p:txBody>
+      </p:sp>
+      <mc:AlternateContent xmlns:mc="http://schemas.openxmlformats.org/markup-compatibility/2006">
+        <mc:Choice xmlns:a14="http://schemas.microsoft.com/office/drawing/2010/main" Requires="a14">
+          <p:sp>
+            <p:nvSpPr>
+              <p:cNvPr id="5" name="Content Placeholder 4">
+                <a:extLst>
+                  <a:ext uri="{FF2B5EF4-FFF2-40B4-BE49-F238E27FC236}">
+                    <a16:creationId xmlns:a16="http://schemas.microsoft.com/office/drawing/2014/main" id="{935F62F9-B12E-8C40-BF8E-29E7EF68B51E}"/>
+                  </a:ext>
+                </a:extLst>
+              </p:cNvPr>
+              <p:cNvSpPr>
+                <a:spLocks noGrp="1"/>
+              </p:cNvSpPr>
+              <p:nvPr>
+                <p:ph idx="1"/>
+              </p:nvPr>
+            </p:nvSpPr>
+            <p:spPr>
+              <a:xfrm>
+                <a:off x="369728" y="884238"/>
+                <a:ext cx="8534400" cy="3943350"/>
+              </a:xfrm>
+            </p:spPr>
+            <p:txBody>
+              <a:bodyPr/>
+              <a:lstStyle/>
+              <a:p>
+                <a:r>
+                  <a:rPr lang="en-US" dirty="0"/>
+                  <a:t>Function approximators (Goal conditioned) used </a:t>
+                </a:r>
+              </a:p>
+              <a:p>
+                <a:pPr lvl="1"/>
+                <a:r>
+                  <a:rPr lang="en-US" dirty="0"/>
+                  <a:t>LSTM : goal </a:t>
+                </a:r>
+                <a:r>
+                  <a:rPr lang="en-US" dirty="0">
+                    <a:sym typeface="Wingdings" pitchFamily="2" charset="2"/>
+                  </a:rPr>
+                  <a:t> </a:t>
+                </a:r>
+                <a14:m>
+                  <m:oMath xmlns:m="http://schemas.openxmlformats.org/officeDocument/2006/math">
+                    <m:sSup>
+                      <m:sSupPr>
+                        <m:ctrlPr>
+                          <a:rPr lang="en-US" sz="2400" i="1">
+                            <a:latin typeface="Cambria Math" panose="02040503050406030204" pitchFamily="18" charset="0"/>
+                          </a:rPr>
+                        </m:ctrlPr>
+                      </m:sSupPr>
+                      <m:e>
+                        <m:r>
+                          <a:rPr lang="en-US" sz="2400" i="1">
+                            <a:latin typeface="Cambria Math" panose="02040503050406030204" pitchFamily="18" charset="0"/>
+                          </a:rPr>
+                          <m:t>𝑅</m:t>
+                        </m:r>
+                      </m:e>
+                      <m:sup>
+                        <m:r>
+                          <a:rPr lang="en-US" sz="2400" b="0" i="1" smtClean="0">
+                            <a:latin typeface="Cambria Math" panose="02040503050406030204" pitchFamily="18" charset="0"/>
+                          </a:rPr>
+                          <m:t>100</m:t>
+                        </m:r>
+                      </m:sup>
+                    </m:sSup>
+                    <m:r>
+                      <a:rPr lang="en-US" sz="2400" i="1">
+                        <a:latin typeface="Cambria Math" panose="02040503050406030204" pitchFamily="18" charset="0"/>
+                      </a:rPr>
+                      <m:t> </m:t>
+                    </m:r>
+                  </m:oMath>
+                </a14:m>
+                <a:endParaRPr lang="en-US" sz="2400" dirty="0"/>
+              </a:p>
+              <a:p>
+                <a:pPr lvl="1"/>
+                <a:r>
+                  <a:rPr lang="en-US" sz="2400" dirty="0"/>
+                  <a:t>Reward function – Artificial Neural Network</a:t>
+                </a:r>
+              </a:p>
+              <a:p>
+                <a:pPr lvl="1"/>
+                <a:r>
+                  <a:rPr lang="en-US" sz="2400" dirty="0"/>
+                  <a:t>Policy function – Artificial Neural Network</a:t>
+                </a:r>
+              </a:p>
+              <a:p>
+                <a:r>
+                  <a:rPr lang="en-US" dirty="0"/>
+                  <a:t>All the above are trained when we run the agent.</a:t>
+                </a:r>
+              </a:p>
+              <a:p>
+                <a:pPr lvl="1"/>
+                <a:r>
+                  <a:rPr lang="en-US" dirty="0"/>
+                  <a:t>Basic principle – Save anything that is interesting</a:t>
+                </a:r>
+              </a:p>
+              <a:p>
+                <a:pPr lvl="1"/>
+                <a:r>
+                  <a:rPr lang="en-US" dirty="0"/>
+                  <a:t>Use the saved memory to train our function approximators</a:t>
+                </a:r>
+              </a:p>
+              <a:p>
+                <a:r>
+                  <a:rPr lang="en-US" dirty="0"/>
+                  <a:t>Lets go back to the architecture!!! </a:t>
+                </a:r>
+              </a:p>
+              <a:p>
+                <a:pPr lvl="1"/>
+                <a:endParaRPr lang="en-US" dirty="0"/>
+              </a:p>
+            </p:txBody>
+          </p:sp>
+        </mc:Choice>
+        <mc:Fallback>
+          <p:sp>
+            <p:nvSpPr>
+              <p:cNvPr id="5" name="Content Placeholder 4">
+                <a:extLst>
+                  <a:ext uri="{FF2B5EF4-FFF2-40B4-BE49-F238E27FC236}">
+                    <a16:creationId xmlns:a16="http://schemas.microsoft.com/office/drawing/2014/main" id="{935F62F9-B12E-8C40-BF8E-29E7EF68B51E}"/>
+                  </a:ext>
+                </a:extLst>
+              </p:cNvPr>
+              <p:cNvSpPr>
+                <a:spLocks noGrp="1" noRot="1" noChangeAspect="1" noMove="1" noResize="1" noEditPoints="1" noAdjustHandles="1" noChangeArrowheads="1" noChangeShapeType="1" noTextEdit="1"/>
+              </p:cNvSpPr>
+              <p:nvPr>
+                <p:ph idx="1"/>
+              </p:nvPr>
+            </p:nvSpPr>
+            <p:spPr>
+              <a:xfrm>
+                <a:off x="369728" y="884238"/>
+                <a:ext cx="8534400" cy="3943350"/>
+              </a:xfrm>
+              <a:blipFill>
+                <a:blip r:embed="rId3"/>
+                <a:stretch>
+                  <a:fillRect l="-892" t="-1286"/>
+                </a:stretch>
+              </a:blipFill>
+            </p:spPr>
+            <p:txBody>
+              <a:bodyPr/>
+              <a:lstStyle/>
+              <a:p>
+                <a:r>
+                  <a:rPr lang="en-US">
+                    <a:noFill/>
+                  </a:rPr>
+                  <a:t> </a:t>
+                </a:r>
+              </a:p>
+            </p:txBody>
+          </p:sp>
+        </mc:Fallback>
+      </mc:AlternateContent>
+    </p:spTree>
+    <p:extLst>
+      <p:ext uri="{BB962C8B-B14F-4D97-AF65-F5344CB8AC3E}">
+        <p14:creationId xmlns:p14="http://schemas.microsoft.com/office/powerpoint/2010/main" val="954986444"/>
+      </p:ext>
+    </p:extLst>
+  </p:cSld>
+  <p:clrMapOvr>
+    <a:masterClrMapping/>
+  </p:clrMapOvr>
+</p:sld>
+</file>
+
+<file path=ppt/slides/slide12.xml><?xml version="1.0" encoding="utf-8"?>
+<p:sld xmlns:a="http://schemas.openxmlformats.org/drawingml/2006/main" xmlns:r="http://schemas.openxmlformats.org/officeDocument/2006/relationships" xmlns:p="http://schemas.openxmlformats.org/presentationml/2006/main">
+  <p:cSld>
+    <p:spTree>
+      <p:nvGrpSpPr>
+        <p:cNvPr id="1" name=""/>
+        <p:cNvGrpSpPr/>
+        <p:nvPr/>
+      </p:nvGrpSpPr>
+      <p:grpSpPr>
+        <a:xfrm>
+          <a:off x="0" y="0"/>
+          <a:ext cx="0" cy="0"/>
+          <a:chOff x="0" y="0"/>
+          <a:chExt cx="0" cy="0"/>
+        </a:xfrm>
+      </p:grpSpPr>
+      <p:sp>
+        <p:nvSpPr>
+          <p:cNvPr id="2" name="Title 1"/>
+          <p:cNvSpPr>
+            <a:spLocks noGrp="1"/>
+          </p:cNvSpPr>
+          <p:nvPr>
+            <p:ph type="title"/>
+          </p:nvPr>
+        </p:nvSpPr>
+        <p:spPr>
+          <a:xfrm>
             <a:off x="367553" y="149880"/>
             <a:ext cx="8545672" cy="523220"/>
           </a:xfrm>
@@ -7270,7 +9542,7 @@
             <a:fld id="{6BC48003-D90B-4677-A057-B663AA3C6CCD}" type="slidenum">
               <a:rPr lang="en-US" smtClean="0"/>
               <a:pPr/>
-              <a:t>11</a:t>
+              <a:t>12</a:t>
             </a:fld>
             <a:endParaRPr lang="en-US"/>
           </a:p>
@@ -7818,7 +10090,7 @@
 </p:sld>
 </file>
 
-<file path=ppt/slides/slide12.xml><?xml version="1.0" encoding="utf-8"?>
+<file path=ppt/slides/slide13.xml><?xml version="1.0" encoding="utf-8"?>
 <p:sld xmlns:a="http://schemas.openxmlformats.org/drawingml/2006/main" xmlns:r="http://schemas.openxmlformats.org/officeDocument/2006/relationships" xmlns:p="http://schemas.openxmlformats.org/presentationml/2006/main">
   <p:cSld>
     <p:spTree>
@@ -7905,157 +10177,6 @@
 </p:sld>
 </file>
 
-<file path=ppt/slides/slide13.xml><?xml version="1.0" encoding="utf-8"?>
-<p:sld xmlns:a="http://schemas.openxmlformats.org/drawingml/2006/main" xmlns:r="http://schemas.openxmlformats.org/officeDocument/2006/relationships" xmlns:p="http://schemas.openxmlformats.org/presentationml/2006/main">
-  <p:cSld>
-    <p:spTree>
-      <p:nvGrpSpPr>
-        <p:cNvPr id="1" name=""/>
-        <p:cNvGrpSpPr/>
-        <p:nvPr/>
-      </p:nvGrpSpPr>
-      <p:grpSpPr>
-        <a:xfrm>
-          <a:off x="0" y="0"/>
-          <a:ext cx="0" cy="0"/>
-          <a:chOff x="0" y="0"/>
-          <a:chExt cx="0" cy="0"/>
-        </a:xfrm>
-      </p:grpSpPr>
-      <p:sp>
-        <p:nvSpPr>
-          <p:cNvPr id="2" name="Title 1"/>
-          <p:cNvSpPr>
-            <a:spLocks noGrp="1"/>
-          </p:cNvSpPr>
-          <p:nvPr>
-            <p:ph type="title"/>
-          </p:nvPr>
-        </p:nvSpPr>
-        <p:spPr/>
-        <p:txBody>
-          <a:bodyPr/>
-          <a:lstStyle/>
-          <a:p>
-            <a:r>
-              <a:rPr lang="en-US" dirty="0"/>
-              <a:t>Goal Generation &amp; Environment</a:t>
-            </a:r>
-          </a:p>
-        </p:txBody>
-      </p:sp>
-      <p:sp>
-        <p:nvSpPr>
-          <p:cNvPr id="19" name="Content Placeholder 2"/>
-          <p:cNvSpPr>
-            <a:spLocks noGrp="1"/>
-          </p:cNvSpPr>
-          <p:nvPr>
-            <p:ph idx="1"/>
-          </p:nvPr>
-        </p:nvSpPr>
-        <p:spPr>
-          <a:xfrm>
-            <a:off x="381000" y="895350"/>
-            <a:ext cx="8534400" cy="361890"/>
-          </a:xfrm>
-        </p:spPr>
-        <p:txBody>
-          <a:bodyPr/>
-          <a:lstStyle/>
-          <a:p>
-            <a:r>
-              <a:rPr lang="en-US" sz="2000" dirty="0"/>
-              <a:t>Goal exploration strategy</a:t>
-            </a:r>
-          </a:p>
-          <a:p>
-            <a:pPr lvl="1"/>
-            <a:r>
-              <a:rPr lang="en-US" sz="1700" dirty="0"/>
-              <a:t>Based on Language (Construction Grammar).</a:t>
-            </a:r>
-          </a:p>
-          <a:p>
-            <a:pPr lvl="1"/>
-            <a:r>
-              <a:rPr lang="en-US" sz="1700" dirty="0"/>
-              <a:t>Language’s combinatorial compositionality is used to their advantage.</a:t>
-            </a:r>
-          </a:p>
-          <a:p>
-            <a:pPr lvl="1"/>
-            <a:r>
-              <a:rPr lang="en-US" sz="1700" dirty="0"/>
-              <a:t>They can generalize to Goals that are out of the known-distribution.</a:t>
-            </a:r>
-          </a:p>
-          <a:p>
-            <a:r>
-              <a:rPr lang="en-US" sz="2000" dirty="0"/>
-              <a:t>The work in this paper is orthogonal to previous research.</a:t>
-            </a:r>
-          </a:p>
-          <a:p>
-            <a:pPr lvl="1"/>
-            <a:r>
-              <a:rPr lang="en-US" sz="1700" dirty="0"/>
-              <a:t>Representation of Goals is learnt</a:t>
-            </a:r>
-          </a:p>
-          <a:p>
-            <a:pPr lvl="1"/>
-            <a:r>
-              <a:rPr lang="en-US" sz="1700" dirty="0"/>
-              <a:t>Reward function is learnt</a:t>
-            </a:r>
-          </a:p>
-          <a:p>
-            <a:pPr lvl="1"/>
-            <a:r>
-              <a:rPr lang="en-US" sz="1700" dirty="0"/>
-              <a:t>Policy, Q-function approximation is also learnt.</a:t>
-            </a:r>
-          </a:p>
-        </p:txBody>
-      </p:sp>
-      <p:sp>
-        <p:nvSpPr>
-          <p:cNvPr id="3" name="Slide Number Placeholder 2"/>
-          <p:cNvSpPr>
-            <a:spLocks noGrp="1"/>
-          </p:cNvSpPr>
-          <p:nvPr>
-            <p:ph type="sldNum" sz="quarter" idx="10"/>
-          </p:nvPr>
-        </p:nvSpPr>
-        <p:spPr/>
-        <p:txBody>
-          <a:bodyPr/>
-          <a:lstStyle/>
-          <a:p>
-            <a:fld id="{6BC48003-D90B-4677-A057-B663AA3C6CCD}" type="slidenum">
-              <a:rPr lang="en-US" smtClean="0"/>
-              <a:pPr/>
-              <a:t>13</a:t>
-            </a:fld>
-            <a:endParaRPr lang="en-US" dirty="0"/>
-          </a:p>
-        </p:txBody>
-      </p:sp>
-    </p:spTree>
-    <p:extLst>
-      <p:ext uri="{BB962C8B-B14F-4D97-AF65-F5344CB8AC3E}">
-        <p14:creationId xmlns:p14="http://schemas.microsoft.com/office/powerpoint/2010/main" val="3115038902"/>
-      </p:ext>
-    </p:extLst>
-  </p:cSld>
-  <p:clrMapOvr>
-    <a:masterClrMapping/>
-  </p:clrMapOvr>
-</p:sld>
-</file>
-
 <file path=ppt/slides/slide14.xml><?xml version="1.0" encoding="utf-8"?>
 <p:sld xmlns:a="http://schemas.openxmlformats.org/drawingml/2006/main" xmlns:r="http://schemas.openxmlformats.org/officeDocument/2006/relationships" xmlns:p="http://schemas.openxmlformats.org/presentationml/2006/main">
   <p:cSld>
@@ -8090,36 +10211,8 @@
           <a:p>
             <a:r>
               <a:rPr lang="en-US" dirty="0"/>
-              <a:t>Generalization</a:t>
-            </a:r>
-          </a:p>
-        </p:txBody>
-      </p:sp>
-      <p:sp>
-        <p:nvSpPr>
-          <p:cNvPr id="4" name="Content Placeholder 3"/>
-          <p:cNvSpPr>
-            <a:spLocks noGrp="1"/>
-          </p:cNvSpPr>
-          <p:nvPr>
-            <p:ph idx="1"/>
-          </p:nvPr>
-        </p:nvSpPr>
-        <p:spPr>
-          <a:xfrm>
-            <a:off x="381000" y="914400"/>
-            <a:ext cx="8610600" cy="3943350"/>
-          </a:xfrm>
-        </p:spPr>
-        <p:txBody>
-          <a:bodyPr/>
-          <a:lstStyle/>
-          <a:p>
-            <a:endParaRPr lang="en-US" sz="2000" dirty="0">
-              <a:solidFill>
-                <a:srgbClr val="9A0000"/>
-              </a:solidFill>
-            </a:endParaRPr>
+              <a:t>Generalization (Goal generalization)</a:t>
+            </a:r>
           </a:p>
         </p:txBody>
       </p:sp>
@@ -8147,6 +10240,117 @@
           </a:p>
         </p:txBody>
       </p:sp>
+      <p:sp>
+        <p:nvSpPr>
+          <p:cNvPr id="5" name="Content Placeholder 4">
+            <a:extLst>
+              <a:ext uri="{FF2B5EF4-FFF2-40B4-BE49-F238E27FC236}">
+                <a16:creationId xmlns:a16="http://schemas.microsoft.com/office/drawing/2014/main" id="{6A970114-FE11-F841-90E3-36A4C4CA4758}"/>
+              </a:ext>
+            </a:extLst>
+          </p:cNvPr>
+          <p:cNvSpPr>
+            <a:spLocks noGrp="1"/>
+          </p:cNvSpPr>
+          <p:nvPr>
+            <p:ph idx="1"/>
+          </p:nvPr>
+        </p:nvSpPr>
+        <p:spPr>
+          <a:xfrm>
+            <a:off x="369728" y="884238"/>
+            <a:ext cx="8534400" cy="3943350"/>
+          </a:xfrm>
+        </p:spPr>
+        <p:txBody>
+          <a:bodyPr/>
+          <a:lstStyle/>
+          <a:p>
+            <a:r>
+              <a:rPr lang="en-US" dirty="0"/>
+              <a:t>Through imagination, 2 Types of “Interesting” generalizations were found</a:t>
+            </a:r>
+          </a:p>
+          <a:p>
+            <a:pPr lvl="1"/>
+            <a:r>
+              <a:rPr lang="en-US" dirty="0"/>
+              <a:t>“Grow” generalization to non-living things</a:t>
+            </a:r>
+          </a:p>
+          <a:p>
+            <a:pPr lvl="1"/>
+            <a:r>
+              <a:rPr lang="en-US" dirty="0"/>
+              <a:t>Behaviors adaptation to growing plants [5]</a:t>
+            </a:r>
+          </a:p>
+          <a:p>
+            <a:pPr lvl="1"/>
+            <a:endParaRPr lang="en-US" dirty="0"/>
+          </a:p>
+        </p:txBody>
+      </p:sp>
+      <p:pic>
+        <p:nvPicPr>
+          <p:cNvPr id="7" name="Picture 6">
+            <a:extLst>
+              <a:ext uri="{FF2B5EF4-FFF2-40B4-BE49-F238E27FC236}">
+                <a16:creationId xmlns:a16="http://schemas.microsoft.com/office/drawing/2014/main" id="{571C88F9-0B40-5140-9A91-E991CAEBF850}"/>
+              </a:ext>
+            </a:extLst>
+          </p:cNvPr>
+          <p:cNvPicPr>
+            <a:picLocks noChangeAspect="1"/>
+          </p:cNvPicPr>
+          <p:nvPr/>
+        </p:nvPicPr>
+        <p:blipFill>
+          <a:blip r:embed="rId3"/>
+          <a:stretch>
+            <a:fillRect/>
+          </a:stretch>
+        </p:blipFill>
+        <p:spPr>
+          <a:xfrm>
+            <a:off x="0" y="2776489"/>
+            <a:ext cx="4428174" cy="2346102"/>
+          </a:xfrm>
+          <a:prstGeom prst="rect">
+            <a:avLst/>
+          </a:prstGeom>
+        </p:spPr>
+      </p:pic>
+      <p:pic>
+        <p:nvPicPr>
+          <p:cNvPr id="9" name="Picture 8">
+            <a:extLst>
+              <a:ext uri="{FF2B5EF4-FFF2-40B4-BE49-F238E27FC236}">
+                <a16:creationId xmlns:a16="http://schemas.microsoft.com/office/drawing/2014/main" id="{F889A111-77E5-514D-885B-D02C9FAC3561}"/>
+              </a:ext>
+            </a:extLst>
+          </p:cNvPr>
+          <p:cNvPicPr>
+            <a:picLocks noChangeAspect="1"/>
+          </p:cNvPicPr>
+          <p:nvPr/>
+        </p:nvPicPr>
+        <p:blipFill>
+          <a:blip r:embed="rId4"/>
+          <a:stretch>
+            <a:fillRect/>
+          </a:stretch>
+        </p:blipFill>
+        <p:spPr>
+          <a:xfrm>
+            <a:off x="4428174" y="2862706"/>
+            <a:ext cx="4715826" cy="2140977"/>
+          </a:xfrm>
+          <a:prstGeom prst="rect">
+            <a:avLst/>
+          </a:prstGeom>
+        </p:spPr>
+      </p:pic>
     </p:spTree>
     <p:extLst>
       <p:ext uri="{BB962C8B-B14F-4D97-AF65-F5344CB8AC3E}">
@@ -8305,34 +10509,6 @@
       </p:sp>
       <p:sp>
         <p:nvSpPr>
-          <p:cNvPr id="4" name="Content Placeholder 3"/>
-          <p:cNvSpPr>
-            <a:spLocks noGrp="1"/>
-          </p:cNvSpPr>
-          <p:nvPr>
-            <p:ph idx="1"/>
-          </p:nvPr>
-        </p:nvSpPr>
-        <p:spPr>
-          <a:xfrm>
-            <a:off x="381000" y="914400"/>
-            <a:ext cx="8610600" cy="3943350"/>
-          </a:xfrm>
-        </p:spPr>
-        <p:txBody>
-          <a:bodyPr/>
-          <a:lstStyle/>
-          <a:p>
-            <a:endParaRPr lang="en-US" sz="2000" dirty="0">
-              <a:solidFill>
-                <a:srgbClr val="9A0000"/>
-              </a:solidFill>
-            </a:endParaRPr>
-          </a:p>
-        </p:txBody>
-      </p:sp>
-      <p:sp>
-        <p:nvSpPr>
           <p:cNvPr id="3" name="Slide Number Placeholder 2"/>
           <p:cNvSpPr>
             <a:spLocks noGrp="1"/>
@@ -8352,6 +10528,36 @@
               <a:t>16</a:t>
             </a:fld>
             <a:endParaRPr lang="en-US"/>
+          </a:p>
+        </p:txBody>
+      </p:sp>
+      <p:sp>
+        <p:nvSpPr>
+          <p:cNvPr id="5" name="Content Placeholder 4">
+            <a:extLst>
+              <a:ext uri="{FF2B5EF4-FFF2-40B4-BE49-F238E27FC236}">
+                <a16:creationId xmlns:a16="http://schemas.microsoft.com/office/drawing/2014/main" id="{AF9DEE8C-FD8B-B340-AFBF-EE80D4FB0FB8}"/>
+              </a:ext>
+            </a:extLst>
+          </p:cNvPr>
+          <p:cNvSpPr>
+            <a:spLocks noGrp="1"/>
+          </p:cNvSpPr>
+          <p:nvPr>
+            <p:ph idx="1"/>
+          </p:nvPr>
+        </p:nvSpPr>
+        <p:spPr>
+          <a:xfrm>
+            <a:off x="369728" y="884238"/>
+            <a:ext cx="8534400" cy="3943350"/>
+          </a:xfrm>
+        </p:spPr>
+        <p:txBody>
+          <a:bodyPr/>
+          <a:lstStyle/>
+          <a:p>
+            <a:endParaRPr lang="en-US" dirty="0"/>
           </a:p>
         </p:txBody>
       </p:sp>
@@ -8402,7 +10608,7 @@
           <a:p>
             <a:r>
               <a:rPr lang="en-US" dirty="0"/>
-              <a:t>Future works</a:t>
+              <a:t>Limitations and Future works</a:t>
             </a:r>
           </a:p>
         </p:txBody>
@@ -8427,7 +10633,53 @@
           <a:bodyPr/>
           <a:lstStyle/>
           <a:p>
-            <a:endParaRPr lang="en-US" sz="2000" dirty="0">
+            <a:r>
+              <a:rPr lang="en-US" sz="2000" dirty="0"/>
+              <a:t>The work is done on synthetic environment.</a:t>
+            </a:r>
+          </a:p>
+          <a:p>
+            <a:r>
+              <a:rPr lang="en-US" sz="2000" dirty="0"/>
+              <a:t>Language grammar used is very primitive.</a:t>
+            </a:r>
+          </a:p>
+          <a:p>
+            <a:r>
+              <a:rPr lang="en-US" sz="2000" dirty="0"/>
+              <a:t>Very high computational cost i.e. ~2.5 CPU years for training.</a:t>
+            </a:r>
+          </a:p>
+          <a:p>
+            <a:r>
+              <a:rPr lang="en-US" sz="2000" dirty="0"/>
+              <a:t>Future work proposed by the authors</a:t>
+            </a:r>
+          </a:p>
+          <a:p>
+            <a:pPr lvl="1"/>
+            <a:r>
+              <a:rPr lang="en-US" sz="1700" dirty="0"/>
+              <a:t>More complex grammar can be utilized for scaffolding of the agent</a:t>
+            </a:r>
+          </a:p>
+          <a:p>
+            <a:pPr lvl="1"/>
+            <a:r>
+              <a:rPr lang="en-US" sz="1700" dirty="0"/>
+              <a:t>Reduce the assumption on the agent (Reducing presence and reducing precision of description)</a:t>
+            </a:r>
+          </a:p>
+          <a:p>
+            <a:pPr lvl="1"/>
+            <a:r>
+              <a:rPr lang="en-US" sz="1700" dirty="0"/>
+              <a:t>Guiding the agent by showing how to accomplish a goal.</a:t>
+            </a:r>
+          </a:p>
+          <a:p>
+            <a:pPr lvl="1"/>
+            <a:endParaRPr lang="en-US" sz="1700" dirty="0">
               <a:solidFill>
                 <a:srgbClr val="9A0000"/>
               </a:solidFill>
@@ -8737,7 +10989,7 @@
             </a:r>
             <a:r>
               <a:rPr lang="en-US" sz="1400" dirty="0">
-                <a:hlinkClick r:id="rId2"/>
+                <a:hlinkClick r:id="rId3"/>
               </a:rPr>
               <a:t>https://unsplash.com/s/photos/children-playing</a:t>
             </a:r>
@@ -8761,7 +11013,7 @@
             </a:r>
             <a:r>
               <a:rPr lang="en-US" sz="1400" dirty="0">
-                <a:hlinkClick r:id="rId3"/>
+                <a:hlinkClick r:id="rId4"/>
               </a:rPr>
               <a:t>https://commons.wikimedia.org/w/index.php?curid=20903046</a:t>
             </a:r>
@@ -8785,7 +11037,7 @@
             </a:r>
             <a:r>
               <a:rPr lang="en-US" sz="1400" kern="0" dirty="0">
-                <a:hlinkClick r:id="rId4"/>
+                <a:hlinkClick r:id="rId5"/>
               </a:rPr>
               <a:t>https://commons.wikimedia.org/w/index.php?curid=304059</a:t>
             </a:r>
@@ -8799,6 +11051,28 @@
               <a:rPr lang="en-US" sz="1400" kern="0" dirty="0"/>
               <a:t>[4] – The research paper</a:t>
             </a:r>
+          </a:p>
+          <a:p>
+            <a:pPr marL="0" indent="0">
+              <a:buNone/>
+            </a:pPr>
+            <a:r>
+              <a:rPr lang="en-US" sz="1400" kern="0" dirty="0"/>
+              <a:t>[5] - </a:t>
+            </a:r>
+            <a:r>
+              <a:rPr lang="en-US" sz="1400" kern="0" dirty="0">
+                <a:hlinkClick r:id="rId6"/>
+              </a:rPr>
+              <a:t>https://sites.google.com/view/imagine-drl</a:t>
+            </a:r>
+            <a:endParaRPr lang="en-US" sz="1400" kern="0" dirty="0"/>
+          </a:p>
+          <a:p>
+            <a:pPr marL="0" indent="0">
+              <a:buNone/>
+            </a:pPr>
+            <a:endParaRPr lang="en-US" sz="1400" kern="0" dirty="0"/>
           </a:p>
         </p:txBody>
       </p:sp>
@@ -8875,11 +11149,14 @@
           <a:bodyPr/>
           <a:lstStyle/>
           <a:p>
-            <a:endParaRPr lang="en-US" sz="2000" dirty="0">
-              <a:solidFill>
-                <a:srgbClr val="9A0000"/>
-              </a:solidFill>
-            </a:endParaRPr>
+            <a:r>
+              <a:rPr lang="en-US" sz="2000" dirty="0">
+                <a:solidFill>
+                  <a:srgbClr val="9A0000"/>
+                </a:solidFill>
+              </a:rPr>
+              <a:t>In Further slides – Extra details about the research paper.</a:t>
+            </a:r>
           </a:p>
         </p:txBody>
       </p:sp>
@@ -10209,7 +12486,7 @@
           <a:p>
             <a:r>
               <a:rPr lang="en-US" sz="1400" dirty="0"/>
-              <a:t>[3 – A building scaffolded for construction or repair]</a:t>
+              <a:t>[3] – A building scaffolded for construction or repair</a:t>
             </a:r>
           </a:p>
         </p:txBody>
@@ -10449,7 +12726,7 @@
             <a:pPr lvl="1"/>
             <a:r>
               <a:rPr lang="de-DE" sz="1400" dirty="0"/>
-              <a:t>Goal-Space </a:t>
+              <a:t>Goal </a:t>
             </a:r>
             <a:r>
               <a:rPr lang="de-DE" sz="1400" dirty="0" err="1"/>
@@ -10457,7 +12734,7 @@
             </a:r>
             <a:r>
               <a:rPr lang="de-DE" sz="1400" dirty="0"/>
-              <a:t>. (GS-G)</a:t>
+              <a:t>. (G-G)</a:t>
             </a:r>
           </a:p>
           <a:p>
@@ -11238,7 +13515,7 @@
           <a:p>
             <a:r>
               <a:rPr lang="en-US" sz="1100" dirty="0"/>
-              <a:t>GS - G</a:t>
+              <a:t>G - G</a:t>
             </a:r>
           </a:p>
         </p:txBody>
@@ -11354,8 +13631,8 @@
           </a:p>
         </p:txBody>
       </p:sp>
-      <mc:AlternateContent xmlns:mc="http://schemas.openxmlformats.org/markup-compatibility/2006" xmlns:a14="http://schemas.microsoft.com/office/drawing/2010/main">
-        <mc:Choice Requires="a14">
+      <mc:AlternateContent xmlns:mc="http://schemas.openxmlformats.org/markup-compatibility/2006">
+        <mc:Choice xmlns:a14="http://schemas.microsoft.com/office/drawing/2010/main" Requires="a14">
           <p:sp>
             <p:nvSpPr>
               <p:cNvPr id="19" name="Content Placeholder 2"/>
@@ -11814,7 +14091,7 @@
                 </a:r>
                 <a:r>
                   <a:rPr lang="de-DE" sz="1700" dirty="0"/>
-                  <a:t> Goal Space - </a:t>
+                  <a:t> Goals - </a:t>
                 </a:r>
                 <a:r>
                   <a:rPr lang="de-DE" sz="1700" dirty="0" err="1"/>
@@ -11966,7 +14243,7 @@
             </p:txBody>
           </p:sp>
         </mc:Choice>
-        <mc:Fallback xmlns="">
+        <mc:Fallback>
           <p:sp>
             <p:nvSpPr>
               <p:cNvPr id="19" name="Content Placeholder 2"/>
@@ -14329,7 +16606,7 @@
           <a:p>
             <a:r>
               <a:rPr lang="en-US" dirty="0"/>
-              <a:t>Goal Generation</a:t>
+              <a:t>Goal Generation Mechanism</a:t>
             </a:r>
           </a:p>
         </p:txBody>
@@ -14356,34 +16633,13 @@
           <a:p>
             <a:r>
               <a:rPr lang="en-US" sz="2000" dirty="0"/>
-              <a:t>Goals are generated using Construction Grammar</a:t>
-            </a:r>
-          </a:p>
-          <a:p>
-            <a:pPr lvl="1"/>
+              <a:t>Goals are generated using Construction Grammar.</a:t>
+            </a:r>
+          </a:p>
+          <a:p>
             <a:r>
               <a:rPr lang="en-US" sz="2000" dirty="0"/>
-              <a:t>Each word is called an atom</a:t>
-            </a:r>
-          </a:p>
-          <a:p>
-            <a:pPr lvl="1"/>
-            <a:r>
-              <a:rPr lang="en-US" sz="2000" dirty="0"/>
-              <a:t>Each sentence is called a compound</a:t>
-            </a:r>
-          </a:p>
-          <a:p>
-            <a:pPr lvl="1"/>
-            <a:r>
-              <a:rPr lang="en-US" sz="2000" dirty="0"/>
-              <a:t>Each compound created is a goal.</a:t>
-            </a:r>
-          </a:p>
-          <a:p>
-            <a:r>
-              <a:rPr lang="en-US" sz="2000" dirty="0"/>
-              <a:t>The Agent uses an LSTM called a language encoder to encode the compound to a goal.</a:t>
+              <a:t>Out of the known-distribution goals are generated using the compositionality.</a:t>
             </a:r>
           </a:p>
         </p:txBody>
@@ -14434,7 +16690,7 @@
         </p:blipFill>
         <p:spPr>
           <a:xfrm>
-            <a:off x="381000" y="3130610"/>
+            <a:off x="0" y="3300456"/>
             <a:ext cx="8173993" cy="1902124"/>
           </a:xfrm>
           <a:prstGeom prst="rect">
@@ -14473,6 +16729,338 @@
             <a:r>
               <a:rPr lang="en-US" sz="1000" dirty="0"/>
               <a:t>[4]</a:t>
+            </a:r>
+          </a:p>
+        </p:txBody>
+      </p:sp>
+      <p:sp>
+        <p:nvSpPr>
+          <p:cNvPr id="8" name="Oval 7">
+            <a:extLst>
+              <a:ext uri="{FF2B5EF4-FFF2-40B4-BE49-F238E27FC236}">
+                <a16:creationId xmlns:a16="http://schemas.microsoft.com/office/drawing/2014/main" id="{FCDDEC69-8DFB-DF45-8BBD-FBA23170386E}"/>
+              </a:ext>
+            </a:extLst>
+          </p:cNvPr>
+          <p:cNvSpPr/>
+          <p:nvPr/>
+        </p:nvSpPr>
+        <p:spPr bwMode="auto">
+          <a:xfrm>
+            <a:off x="1219200" y="1915473"/>
+            <a:ext cx="1371600" cy="562630"/>
+          </a:xfrm>
+          <a:prstGeom prst="ellipse">
+            <a:avLst/>
+          </a:prstGeom>
+          <a:solidFill>
+            <a:srgbClr val="92D050"/>
+          </a:solidFill>
+          <a:ln w="25400">
+            <a:solidFill>
+              <a:schemeClr val="tx1"/>
+            </a:solidFill>
+            <a:round/>
+            <a:headEnd/>
+            <a:tailEnd/>
+          </a:ln>
+          <a:effectLst/>
+          <a:extLst/>
+        </p:spPr>
+        <p:txBody>
+          <a:bodyPr wrap="square" rtlCol="0" anchor="ctr">
+            <a:spAutoFit/>
+          </a:bodyPr>
+          <a:lstStyle/>
+          <a:p>
+            <a:pPr algn="ctr"/>
+            <a:r>
+              <a:rPr lang="en-US" sz="2000" dirty="0"/>
+              <a:t>Grasp</a:t>
+            </a:r>
+          </a:p>
+        </p:txBody>
+      </p:sp>
+      <p:sp>
+        <p:nvSpPr>
+          <p:cNvPr id="9" name="Oval 8">
+            <a:extLst>
+              <a:ext uri="{FF2B5EF4-FFF2-40B4-BE49-F238E27FC236}">
+                <a16:creationId xmlns:a16="http://schemas.microsoft.com/office/drawing/2014/main" id="{0138A414-D980-DA49-BF3C-1F32D58DB91F}"/>
+              </a:ext>
+            </a:extLst>
+          </p:cNvPr>
+          <p:cNvSpPr/>
+          <p:nvPr/>
+        </p:nvSpPr>
+        <p:spPr bwMode="auto">
+          <a:xfrm>
+            <a:off x="3962400" y="1876725"/>
+            <a:ext cx="1371600" cy="562630"/>
+          </a:xfrm>
+          <a:prstGeom prst="ellipse">
+            <a:avLst/>
+          </a:prstGeom>
+          <a:solidFill>
+            <a:srgbClr val="92D050"/>
+          </a:solidFill>
+          <a:ln w="25400">
+            <a:solidFill>
+              <a:schemeClr val="tx1"/>
+            </a:solidFill>
+            <a:round/>
+            <a:headEnd/>
+            <a:tailEnd/>
+          </a:ln>
+          <a:effectLst/>
+          <a:extLst/>
+        </p:spPr>
+        <p:txBody>
+          <a:bodyPr wrap="square" rtlCol="0" anchor="ctr">
+            <a:spAutoFit/>
+          </a:bodyPr>
+          <a:lstStyle/>
+          <a:p>
+            <a:pPr algn="ctr"/>
+            <a:r>
+              <a:rPr lang="en-US" sz="2000" dirty="0"/>
+              <a:t>Red</a:t>
+            </a:r>
+          </a:p>
+        </p:txBody>
+      </p:sp>
+      <p:sp>
+        <p:nvSpPr>
+          <p:cNvPr id="10" name="Oval 9">
+            <a:extLst>
+              <a:ext uri="{FF2B5EF4-FFF2-40B4-BE49-F238E27FC236}">
+                <a16:creationId xmlns:a16="http://schemas.microsoft.com/office/drawing/2014/main" id="{098B9110-DF08-3243-AF1A-A783D67BED1B}"/>
+              </a:ext>
+            </a:extLst>
+          </p:cNvPr>
+          <p:cNvSpPr/>
+          <p:nvPr/>
+        </p:nvSpPr>
+        <p:spPr bwMode="auto">
+          <a:xfrm>
+            <a:off x="6629400" y="1884988"/>
+            <a:ext cx="1371600" cy="562630"/>
+          </a:xfrm>
+          <a:prstGeom prst="ellipse">
+            <a:avLst/>
+          </a:prstGeom>
+          <a:solidFill>
+            <a:srgbClr val="92D050"/>
+          </a:solidFill>
+          <a:ln w="25400">
+            <a:solidFill>
+              <a:schemeClr val="tx1"/>
+            </a:solidFill>
+            <a:round/>
+            <a:headEnd/>
+            <a:tailEnd/>
+          </a:ln>
+          <a:effectLst/>
+          <a:extLst/>
+        </p:spPr>
+        <p:txBody>
+          <a:bodyPr wrap="square" rtlCol="0" anchor="ctr">
+            <a:spAutoFit/>
+          </a:bodyPr>
+          <a:lstStyle/>
+          <a:p>
+            <a:pPr algn="ctr"/>
+            <a:r>
+              <a:rPr lang="en-US" sz="2000" dirty="0"/>
+              <a:t>Cat</a:t>
+            </a:r>
+          </a:p>
+        </p:txBody>
+      </p:sp>
+      <p:sp>
+        <p:nvSpPr>
+          <p:cNvPr id="7" name="TextBox 6">
+            <a:extLst>
+              <a:ext uri="{FF2B5EF4-FFF2-40B4-BE49-F238E27FC236}">
+                <a16:creationId xmlns:a16="http://schemas.microsoft.com/office/drawing/2014/main" id="{B8361412-5940-3548-A5F5-D546DED13899}"/>
+              </a:ext>
+            </a:extLst>
+          </p:cNvPr>
+          <p:cNvSpPr txBox="1"/>
+          <p:nvPr/>
+        </p:nvSpPr>
+        <p:spPr>
+          <a:xfrm>
+            <a:off x="381000" y="2038350"/>
+            <a:ext cx="838200" cy="307777"/>
+          </a:xfrm>
+          <a:prstGeom prst="rect">
+            <a:avLst/>
+          </a:prstGeom>
+          <a:noFill/>
+        </p:spPr>
+        <p:txBody>
+          <a:bodyPr wrap="square" rtlCol="0">
+            <a:spAutoFit/>
+          </a:bodyPr>
+          <a:lstStyle/>
+          <a:p>
+            <a:r>
+              <a:rPr lang="en-US" sz="1400" dirty="0"/>
+              <a:t>Atom 1</a:t>
+            </a:r>
+          </a:p>
+        </p:txBody>
+      </p:sp>
+      <p:sp>
+        <p:nvSpPr>
+          <p:cNvPr id="12" name="TextBox 11">
+            <a:extLst>
+              <a:ext uri="{FF2B5EF4-FFF2-40B4-BE49-F238E27FC236}">
+                <a16:creationId xmlns:a16="http://schemas.microsoft.com/office/drawing/2014/main" id="{FEF8E6C6-26E2-2942-8DAC-4ED6272900D2}"/>
+              </a:ext>
+            </a:extLst>
+          </p:cNvPr>
+          <p:cNvSpPr txBox="1"/>
+          <p:nvPr/>
+        </p:nvSpPr>
+        <p:spPr>
+          <a:xfrm>
+            <a:off x="3126059" y="2038349"/>
+            <a:ext cx="838200" cy="307777"/>
+          </a:xfrm>
+          <a:prstGeom prst="rect">
+            <a:avLst/>
+          </a:prstGeom>
+          <a:noFill/>
+        </p:spPr>
+        <p:txBody>
+          <a:bodyPr wrap="square" rtlCol="0">
+            <a:spAutoFit/>
+          </a:bodyPr>
+          <a:lstStyle/>
+          <a:p>
+            <a:r>
+              <a:rPr lang="en-US" sz="1400" dirty="0"/>
+              <a:t>Atom 2</a:t>
+            </a:r>
+          </a:p>
+        </p:txBody>
+      </p:sp>
+      <p:sp>
+        <p:nvSpPr>
+          <p:cNvPr id="13" name="TextBox 12">
+            <a:extLst>
+              <a:ext uri="{FF2B5EF4-FFF2-40B4-BE49-F238E27FC236}">
+                <a16:creationId xmlns:a16="http://schemas.microsoft.com/office/drawing/2014/main" id="{8EA6514B-5240-F640-82D3-ED39DC3D1145}"/>
+              </a:ext>
+            </a:extLst>
+          </p:cNvPr>
+          <p:cNvSpPr txBox="1"/>
+          <p:nvPr/>
+        </p:nvSpPr>
+        <p:spPr>
+          <a:xfrm>
+            <a:off x="5562600" y="2004151"/>
+            <a:ext cx="838200" cy="307777"/>
+          </a:xfrm>
+          <a:prstGeom prst="rect">
+            <a:avLst/>
+          </a:prstGeom>
+          <a:noFill/>
+        </p:spPr>
+        <p:txBody>
+          <a:bodyPr wrap="square" rtlCol="0">
+            <a:spAutoFit/>
+          </a:bodyPr>
+          <a:lstStyle/>
+          <a:p>
+            <a:r>
+              <a:rPr lang="en-US" sz="1400" dirty="0"/>
+              <a:t>Atom 3</a:t>
+            </a:r>
+          </a:p>
+        </p:txBody>
+      </p:sp>
+      <p:sp>
+        <p:nvSpPr>
+          <p:cNvPr id="15" name="Rectangle 14">
+            <a:extLst>
+              <a:ext uri="{FF2B5EF4-FFF2-40B4-BE49-F238E27FC236}">
+                <a16:creationId xmlns:a16="http://schemas.microsoft.com/office/drawing/2014/main" id="{356B8A48-AA26-764B-A256-252177B74DBA}"/>
+              </a:ext>
+            </a:extLst>
+          </p:cNvPr>
+          <p:cNvSpPr/>
+          <p:nvPr/>
+        </p:nvSpPr>
+        <p:spPr bwMode="auto">
+          <a:xfrm>
+            <a:off x="2448696" y="2675803"/>
+            <a:ext cx="3276600" cy="461665"/>
+          </a:xfrm>
+          <a:prstGeom prst="rect">
+            <a:avLst/>
+          </a:prstGeom>
+          <a:solidFill>
+            <a:srgbClr val="92D050"/>
+          </a:solidFill>
+          <a:ln w="25400">
+            <a:solidFill>
+              <a:schemeClr val="tx1"/>
+            </a:solidFill>
+            <a:round/>
+            <a:headEnd/>
+            <a:tailEnd/>
+          </a:ln>
+          <a:effectLst/>
+          <a:extLst/>
+        </p:spPr>
+        <p:txBody>
+          <a:bodyPr rtlCol="0" anchor="ctr">
+            <a:spAutoFit/>
+          </a:bodyPr>
+          <a:lstStyle/>
+          <a:p>
+            <a:pPr algn="ctr"/>
+            <a:r>
+              <a:rPr lang="en-US" dirty="0"/>
+              <a:t>Grasp Red Cat</a:t>
+            </a:r>
+          </a:p>
+        </p:txBody>
+      </p:sp>
+      <p:sp>
+        <p:nvSpPr>
+          <p:cNvPr id="17" name="TextBox 16">
+            <a:extLst>
+              <a:ext uri="{FF2B5EF4-FFF2-40B4-BE49-F238E27FC236}">
+                <a16:creationId xmlns:a16="http://schemas.microsoft.com/office/drawing/2014/main" id="{5BE623E1-AE9E-6D4F-B62E-D235865E55A5}"/>
+              </a:ext>
+            </a:extLst>
+          </p:cNvPr>
+          <p:cNvSpPr txBox="1"/>
+          <p:nvPr/>
+        </p:nvSpPr>
+        <p:spPr>
+          <a:xfrm>
+            <a:off x="5928314" y="2716017"/>
+            <a:ext cx="2323171" cy="307777"/>
+          </a:xfrm>
+          <a:prstGeom prst="rect">
+            <a:avLst/>
+          </a:prstGeom>
+          <a:noFill/>
+        </p:spPr>
+        <p:txBody>
+          <a:bodyPr wrap="square" rtlCol="0">
+            <a:spAutoFit/>
+          </a:bodyPr>
+          <a:lstStyle/>
+          <a:p>
+            <a:r>
+              <a:rPr lang="en-US" sz="1400" dirty="0"/>
+              <a:t>Compound / Goal</a:t>
             </a:r>
           </a:p>
         </p:txBody>

</xml_diff>

<commit_message>
Completing SP assumption relaxing slide
</commit_message>
<xml_diff>
--- a/presentation.pptx
+++ b/presentation.pptx
@@ -2624,7 +2624,243 @@
               <a:tabLst/>
               <a:defRPr/>
             </a:pPr>
-            <a:endParaRPr lang="en-US" baseline="0" dirty="0"/>
+            <a:r>
+              <a:rPr lang="en-US" baseline="0" dirty="0"/>
+              <a:t>The authors had made the following assumptions about the social partner</a:t>
+            </a:r>
+          </a:p>
+          <a:p>
+            <a:pPr marL="615950" marR="0" lvl="1" indent="-285750" algn="l" defTabSz="914400" rtl="0" eaLnBrk="0" fontAlgn="base" latinLnBrk="0" hangingPunct="0">
+              <a:lnSpc>
+                <a:spcPct val="100000"/>
+              </a:lnSpc>
+              <a:spcBef>
+                <a:spcPct val="30000"/>
+              </a:spcBef>
+              <a:spcAft>
+                <a:spcPct val="0"/>
+              </a:spcAft>
+              <a:buClr>
+                <a:srgbClr val="800000"/>
+              </a:buClr>
+              <a:buSzTx/>
+              <a:buFont typeface="Wingdings" charset="2"/>
+              <a:buChar char="§"/>
+              <a:tabLst/>
+              <a:defRPr/>
+            </a:pPr>
+            <a:r>
+              <a:rPr lang="en-US" baseline="0" dirty="0"/>
+              <a:t>The social partner is always available – perfect presence</a:t>
+            </a:r>
+          </a:p>
+          <a:p>
+            <a:pPr marL="615950" marR="0" lvl="1" indent="-285750" algn="l" defTabSz="914400" rtl="0" eaLnBrk="0" fontAlgn="base" latinLnBrk="0" hangingPunct="0">
+              <a:lnSpc>
+                <a:spcPct val="100000"/>
+              </a:lnSpc>
+              <a:spcBef>
+                <a:spcPct val="30000"/>
+              </a:spcBef>
+              <a:spcAft>
+                <a:spcPct val="0"/>
+              </a:spcAft>
+              <a:buClr>
+                <a:srgbClr val="800000"/>
+              </a:buClr>
+              <a:buSzTx/>
+              <a:buFont typeface="Wingdings" charset="2"/>
+              <a:buChar char="§"/>
+              <a:tabLst/>
+              <a:defRPr/>
+            </a:pPr>
+            <a:r>
+              <a:rPr lang="en-US" baseline="0" dirty="0"/>
+              <a:t>The social partner gives perfect description about the the goal description. - Exhaustiveness (Ex in images)</a:t>
+            </a:r>
+          </a:p>
+          <a:p>
+            <a:pPr marL="285750" marR="0" lvl="0" indent="-285750" algn="l" defTabSz="914400" rtl="0" eaLnBrk="0" fontAlgn="base" latinLnBrk="0" hangingPunct="0">
+              <a:lnSpc>
+                <a:spcPct val="100000"/>
+              </a:lnSpc>
+              <a:spcBef>
+                <a:spcPct val="30000"/>
+              </a:spcBef>
+              <a:spcAft>
+                <a:spcPct val="0"/>
+              </a:spcAft>
+              <a:buClr>
+                <a:srgbClr val="800000"/>
+              </a:buClr>
+              <a:buSzTx/>
+              <a:buFont typeface="Wingdings" charset="2"/>
+              <a:buChar char="§"/>
+              <a:tabLst/>
+              <a:defRPr/>
+            </a:pPr>
+            <a:r>
+              <a:rPr lang="en-US" baseline="0" dirty="0"/>
+              <a:t>From the study of this the authors have concluded the following things –</a:t>
+            </a:r>
+          </a:p>
+          <a:p>
+            <a:pPr marL="615950" marR="0" lvl="1" indent="-285750" algn="l" defTabSz="914400" rtl="0" eaLnBrk="0" fontAlgn="base" latinLnBrk="0" hangingPunct="0">
+              <a:lnSpc>
+                <a:spcPct val="100000"/>
+              </a:lnSpc>
+              <a:spcBef>
+                <a:spcPct val="30000"/>
+              </a:spcBef>
+              <a:spcAft>
+                <a:spcPct val="0"/>
+              </a:spcAft>
+              <a:buClr>
+                <a:srgbClr val="800000"/>
+              </a:buClr>
+              <a:buSzTx/>
+              <a:buFont typeface="Wingdings" charset="2"/>
+              <a:buChar char="§"/>
+              <a:tabLst/>
+              <a:defRPr/>
+            </a:pPr>
+            <a:r>
+              <a:rPr lang="en-US" baseline="0" dirty="0"/>
+              <a:t>Relaxing the exhaustiveness degraded the performance to an agent that does not imagine.</a:t>
+            </a:r>
+          </a:p>
+          <a:p>
+            <a:pPr marL="615950" marR="0" lvl="1" indent="-285750" algn="l" defTabSz="914400" rtl="0" eaLnBrk="0" fontAlgn="base" latinLnBrk="0" hangingPunct="0">
+              <a:lnSpc>
+                <a:spcPct val="100000"/>
+              </a:lnSpc>
+              <a:spcBef>
+                <a:spcPct val="30000"/>
+              </a:spcBef>
+              <a:spcAft>
+                <a:spcPct val="0"/>
+              </a:spcAft>
+              <a:buClr>
+                <a:srgbClr val="800000"/>
+              </a:buClr>
+              <a:buSzTx/>
+              <a:buFont typeface="Wingdings" charset="2"/>
+              <a:buChar char="§"/>
+              <a:tabLst/>
+              <a:defRPr/>
+            </a:pPr>
+            <a:r>
+              <a:rPr lang="en-US" baseline="0" dirty="0"/>
+              <a:t>See the red line (</a:t>
+            </a:r>
+            <a:r>
+              <a:rPr lang="en-US" baseline="0"/>
+              <a:t>no exhaustiveness) </a:t>
+            </a:r>
+            <a:r>
+              <a:rPr lang="en-US" baseline="0" dirty="0"/>
+              <a:t>below the green line here (exhaustiveness but no imagination)</a:t>
+            </a:r>
+          </a:p>
+          <a:p>
+            <a:pPr marL="285750" marR="0" lvl="0" indent="-285750" algn="l" defTabSz="914400" rtl="0" eaLnBrk="0" fontAlgn="base" latinLnBrk="0" hangingPunct="0">
+              <a:lnSpc>
+                <a:spcPct val="100000"/>
+              </a:lnSpc>
+              <a:spcBef>
+                <a:spcPct val="30000"/>
+              </a:spcBef>
+              <a:spcAft>
+                <a:spcPct val="0"/>
+              </a:spcAft>
+              <a:buClr>
+                <a:srgbClr val="800000"/>
+              </a:buClr>
+              <a:buSzTx/>
+              <a:buFont typeface="Wingdings" charset="2"/>
+              <a:buChar char="§"/>
+              <a:tabLst/>
+              <a:defRPr/>
+            </a:pPr>
+            <a:r>
+              <a:rPr lang="en-US" baseline="0" dirty="0"/>
+              <a:t>What is interesting is if you reduce the full presence of SP strategically, we get similar results to a normal agent</a:t>
+            </a:r>
+          </a:p>
+          <a:p>
+            <a:pPr marL="615950" marR="0" lvl="1" indent="-285750" algn="l" defTabSz="914400" rtl="0" eaLnBrk="0" fontAlgn="base" latinLnBrk="0" hangingPunct="0">
+              <a:lnSpc>
+                <a:spcPct val="100000"/>
+              </a:lnSpc>
+              <a:spcBef>
+                <a:spcPct val="30000"/>
+              </a:spcBef>
+              <a:spcAft>
+                <a:spcPct val="0"/>
+              </a:spcAft>
+              <a:buClr>
+                <a:srgbClr val="800000"/>
+              </a:buClr>
+              <a:buSzTx/>
+              <a:buFont typeface="Wingdings" charset="2"/>
+              <a:buChar char="§"/>
+              <a:tabLst/>
+              <a:defRPr/>
+            </a:pPr>
+            <a:r>
+              <a:rPr lang="en-US" baseline="0" dirty="0"/>
+              <a:t>Blue line is normal agent with imagination and with exhaustive presence</a:t>
+            </a:r>
+          </a:p>
+          <a:p>
+            <a:pPr marL="615950" marR="0" lvl="1" indent="-285750" algn="l" defTabSz="914400" rtl="0" eaLnBrk="0" fontAlgn="base" latinLnBrk="0" hangingPunct="0">
+              <a:lnSpc>
+                <a:spcPct val="100000"/>
+              </a:lnSpc>
+              <a:spcBef>
+                <a:spcPct val="30000"/>
+              </a:spcBef>
+              <a:spcAft>
+                <a:spcPct val="0"/>
+              </a:spcAft>
+              <a:buClr>
+                <a:srgbClr val="800000"/>
+              </a:buClr>
+              <a:buSzTx/>
+              <a:buFont typeface="Wingdings" charset="2"/>
+              <a:buChar char="§"/>
+              <a:tabLst/>
+              <a:defRPr/>
+            </a:pPr>
+            <a:r>
+              <a:rPr lang="en-US" baseline="0" dirty="0"/>
+              <a:t>If you see purple line – first 10% of the time the SP is present and then not present, performance is unchanged</a:t>
+            </a:r>
+          </a:p>
+          <a:p>
+            <a:pPr marL="615950" marR="0" lvl="1" indent="-285750" algn="l" defTabSz="914400" rtl="0" eaLnBrk="0" fontAlgn="base" latinLnBrk="0" hangingPunct="0">
+              <a:lnSpc>
+                <a:spcPct val="100000"/>
+              </a:lnSpc>
+              <a:spcBef>
+                <a:spcPct val="30000"/>
+              </a:spcBef>
+              <a:spcAft>
+                <a:spcPct val="0"/>
+              </a:spcAft>
+              <a:buClr>
+                <a:srgbClr val="800000"/>
+              </a:buClr>
+              <a:buSzTx/>
+              <a:buFont typeface="Wingdings" charset="2"/>
+              <a:buChar char="§"/>
+              <a:tabLst/>
+              <a:defRPr/>
+            </a:pPr>
+            <a:r>
+              <a:rPr lang="en-US" baseline="0" dirty="0"/>
+              <a:t>Parallels to children development where a baby requires extensive guidance in initial years and lesser and lesser guidance in the later years.</a:t>
+            </a:r>
           </a:p>
         </p:txBody>
       </p:sp>
@@ -10498,13 +10734,18 @@
             <p:ph type="title"/>
           </p:nvPr>
         </p:nvSpPr>
-        <p:spPr/>
+        <p:spPr>
+          <a:xfrm>
+            <a:off x="381000" y="243543"/>
+            <a:ext cx="8545672" cy="461665"/>
+          </a:xfrm>
+        </p:spPr>
         <p:txBody>
           <a:bodyPr/>
           <a:lstStyle/>
           <a:p>
             <a:r>
-              <a:rPr lang="en-US" dirty="0"/>
+              <a:rPr lang="en-US" sz="2400" dirty="0"/>
               <a:t>Ablation studies</a:t>
             </a:r>
           </a:p>
@@ -10530,11 +10771,7 @@
           <a:bodyPr/>
           <a:lstStyle/>
           <a:p>
-            <a:endParaRPr lang="en-US" sz="2000" dirty="0">
-              <a:solidFill>
-                <a:srgbClr val="9A0000"/>
-              </a:solidFill>
-            </a:endParaRPr>
+            <a:endParaRPr lang="en-US" sz="2000" dirty="0"/>
           </a:p>
         </p:txBody>
       </p:sp>
@@ -10614,7 +10851,7 @@
           <a:p>
             <a:r>
               <a:rPr lang="en-US" sz="2400" dirty="0"/>
-              <a:t>Model improvement</a:t>
+              <a:t>Model improvement (Social Partner)</a:t>
             </a:r>
           </a:p>
         </p:txBody>
@@ -10669,7 +10906,156 @@
           <a:bodyPr/>
           <a:lstStyle/>
           <a:p>
-            <a:endParaRPr lang="en-US" dirty="0"/>
+            <a:r>
+              <a:rPr lang="en-US" sz="1800" dirty="0"/>
+              <a:t>Assumptions of Social Partner made by authors –</a:t>
+            </a:r>
+          </a:p>
+          <a:p>
+            <a:pPr lvl="1"/>
+            <a:r>
+              <a:rPr lang="en-US" sz="1800" dirty="0"/>
+              <a:t>Full presence of SP and exhaustiveness (Perfect description)</a:t>
+            </a:r>
+          </a:p>
+          <a:p>
+            <a:r>
+              <a:rPr lang="en-US" sz="1800" dirty="0"/>
+              <a:t>Relaxing Exhaustiveness degraded the performance to an agent that does not imagine.</a:t>
+            </a:r>
+          </a:p>
+          <a:p>
+            <a:r>
+              <a:rPr lang="en-US" sz="1800" dirty="0"/>
+              <a:t>Strategic reduction of Full presence –</a:t>
+            </a:r>
+          </a:p>
+          <a:p>
+            <a:pPr lvl="1"/>
+            <a:r>
+              <a:rPr lang="en-US" sz="1500" dirty="0"/>
+              <a:t>Keeping the SP in the first 10% of time only leads to similar performance as a normal agent.</a:t>
+            </a:r>
+          </a:p>
+          <a:p>
+            <a:pPr lvl="1"/>
+            <a:r>
+              <a:rPr lang="en-US" sz="1500" dirty="0"/>
+              <a:t>Here ex = exhaustive</a:t>
+            </a:r>
+          </a:p>
+        </p:txBody>
+      </p:sp>
+      <p:pic>
+        <p:nvPicPr>
+          <p:cNvPr id="7" name="Picture 6">
+            <a:extLst>
+              <a:ext uri="{FF2B5EF4-FFF2-40B4-BE49-F238E27FC236}">
+                <a16:creationId xmlns:a16="http://schemas.microsoft.com/office/drawing/2014/main" id="{D302424F-3F34-284F-B4EB-DA4645154549}"/>
+              </a:ext>
+            </a:extLst>
+          </p:cNvPr>
+          <p:cNvPicPr>
+            <a:picLocks noChangeAspect="1"/>
+          </p:cNvPicPr>
+          <p:nvPr/>
+        </p:nvPicPr>
+        <p:blipFill>
+          <a:blip r:embed="rId3"/>
+          <a:stretch>
+            <a:fillRect/>
+          </a:stretch>
+        </p:blipFill>
+        <p:spPr>
+          <a:xfrm>
+            <a:off x="4343400" y="2876550"/>
+            <a:ext cx="2142000" cy="2286000"/>
+          </a:xfrm>
+          <a:prstGeom prst="rect">
+            <a:avLst/>
+          </a:prstGeom>
+        </p:spPr>
+      </p:pic>
+      <p:sp>
+        <p:nvSpPr>
+          <p:cNvPr id="8" name="Rectangle 7">
+            <a:extLst>
+              <a:ext uri="{FF2B5EF4-FFF2-40B4-BE49-F238E27FC236}">
+                <a16:creationId xmlns:a16="http://schemas.microsoft.com/office/drawing/2014/main" id="{DC275F54-08B9-FE49-85EA-94A4521DCD8C}"/>
+              </a:ext>
+            </a:extLst>
+          </p:cNvPr>
+          <p:cNvSpPr/>
+          <p:nvPr/>
+        </p:nvSpPr>
+        <p:spPr bwMode="auto">
+          <a:xfrm>
+            <a:off x="603964" y="3547706"/>
+            <a:ext cx="3505200" cy="523220"/>
+          </a:xfrm>
+          <a:prstGeom prst="rect">
+            <a:avLst/>
+          </a:prstGeom>
+          <a:solidFill>
+            <a:srgbClr val="FFF40F"/>
+          </a:solidFill>
+          <a:ln w="25400">
+            <a:solidFill>
+              <a:schemeClr val="tx1"/>
+            </a:solidFill>
+            <a:round/>
+            <a:headEnd/>
+            <a:tailEnd/>
+          </a:ln>
+          <a:effectLst/>
+          <a:extLst/>
+        </p:spPr>
+        <p:txBody>
+          <a:bodyPr rtlCol="0" anchor="ctr">
+            <a:spAutoFit/>
+          </a:bodyPr>
+          <a:lstStyle/>
+          <a:p>
+            <a:pPr algn="ctr"/>
+            <a:r>
+              <a:rPr lang="en-US" sz="1400" dirty="0"/>
+              <a:t>Similarly - A baby requires extensive guidance in the initial years</a:t>
+            </a:r>
+          </a:p>
+        </p:txBody>
+      </p:sp>
+      <p:sp>
+        <p:nvSpPr>
+          <p:cNvPr id="10" name="TextBox 9">
+            <a:extLst>
+              <a:ext uri="{FF2B5EF4-FFF2-40B4-BE49-F238E27FC236}">
+                <a16:creationId xmlns:a16="http://schemas.microsoft.com/office/drawing/2014/main" id="{3B7D82B3-6686-D347-A84B-0651FAD4C082}"/>
+              </a:ext>
+            </a:extLst>
+          </p:cNvPr>
+          <p:cNvSpPr txBox="1"/>
+          <p:nvPr/>
+        </p:nvSpPr>
+        <p:spPr>
+          <a:xfrm>
+            <a:off x="6472214" y="4698841"/>
+            <a:ext cx="461986" cy="307777"/>
+          </a:xfrm>
+          <a:prstGeom prst="rect">
+            <a:avLst/>
+          </a:prstGeom>
+          <a:noFill/>
+        </p:spPr>
+        <p:txBody>
+          <a:bodyPr wrap="none" rtlCol="0">
+            <a:spAutoFit/>
+          </a:bodyPr>
+          <a:lstStyle/>
+          <a:p>
+            <a:r>
+              <a:rPr lang="en-US" sz="1400" dirty="0"/>
+              <a:t>[4]</a:t>
+            </a:r>
           </a:p>
         </p:txBody>
       </p:sp>
@@ -10870,8 +11256,8 @@
         </p:nvSpPr>
         <p:spPr>
           <a:xfrm>
-            <a:off x="228600" y="361950"/>
-            <a:ext cx="8534400" cy="523220"/>
+            <a:off x="228600" y="423505"/>
+            <a:ext cx="8534400" cy="461665"/>
           </a:xfrm>
         </p:spPr>
         <p:txBody>
@@ -10879,7 +11265,7 @@
           <a:lstStyle/>
           <a:p>
             <a:r>
-              <a:rPr lang="en-US" dirty="0"/>
+              <a:rPr lang="en-US" sz="2400" dirty="0"/>
               <a:t>Thank you for your attention!</a:t>
             </a:r>
           </a:p>
@@ -11092,104 +11478,89 @@
               <a:buNone/>
             </a:pPr>
             <a:r>
-              <a:rPr lang="en-US" sz="1400" kern="0" dirty="0"/>
+              <a:rPr lang="en-US" sz="1800" b="1" kern="0" dirty="0"/>
               <a:t>References:</a:t>
             </a:r>
+          </a:p>
+          <a:p>
+            <a:r>
+              <a:rPr lang="en-US" sz="1800" dirty="0"/>
+              <a:t>[1] - </a:t>
+            </a:r>
+            <a:r>
+              <a:rPr lang="en-US" sz="1800" dirty="0">
+                <a:hlinkClick r:id="rId3"/>
+              </a:rPr>
+              <a:t>https://unsplash.com/s/photos/children-playing</a:t>
+            </a:r>
+            <a:endParaRPr lang="en-US" sz="1800" dirty="0"/>
+          </a:p>
+          <a:p>
+            <a:r>
+              <a:rPr lang="en-US" sz="1800" dirty="0"/>
+              <a:t>[2] - By </a:t>
+            </a:r>
+            <a:r>
+              <a:rPr lang="en-US" sz="1800" dirty="0" err="1"/>
+              <a:t>Dcoetzee</a:t>
+            </a:r>
+            <a:r>
+              <a:rPr lang="en-US" sz="1800" dirty="0"/>
+              <a:t> - Own work, CC0, </a:t>
+            </a:r>
+            <a:r>
+              <a:rPr lang="en-US" sz="1800" dirty="0">
+                <a:hlinkClick r:id="rId4"/>
+              </a:rPr>
+              <a:t>https://commons.wikimedia.org/w/index.php?curid=20903046</a:t>
+            </a:r>
+            <a:endParaRPr lang="en-US" sz="1800" dirty="0"/>
+          </a:p>
+          <a:p>
+            <a:r>
+              <a:rPr lang="en-US" sz="1800" kern="0" dirty="0"/>
+              <a:t>[3] - By </a:t>
+            </a:r>
+            <a:r>
+              <a:rPr lang="en-US" sz="1800" kern="0" dirty="0" err="1"/>
+              <a:t>Tysto</a:t>
+            </a:r>
+            <a:r>
+              <a:rPr lang="en-US" sz="1800" kern="0" dirty="0"/>
+              <a:t> - Own work, Public Domain, </a:t>
+            </a:r>
+            <a:r>
+              <a:rPr lang="en-US" sz="1800" kern="0" dirty="0">
+                <a:hlinkClick r:id="rId5"/>
+              </a:rPr>
+              <a:t>https://commons.wikimedia.org/w/index.php?curid=304059</a:t>
+            </a:r>
+            <a:endParaRPr lang="en-US" sz="1800" kern="0" dirty="0"/>
+          </a:p>
+          <a:p>
+            <a:r>
+              <a:rPr lang="en-US" sz="1800" kern="0" dirty="0"/>
+              <a:t>[4] – The research paper</a:t>
+            </a:r>
+          </a:p>
+          <a:p>
+            <a:r>
+              <a:rPr lang="en-US" sz="1800" kern="0" dirty="0"/>
+              <a:t>[5] - </a:t>
+            </a:r>
+            <a:r>
+              <a:rPr lang="en-US" sz="1800" kern="0" dirty="0">
+                <a:hlinkClick r:id="rId6"/>
+              </a:rPr>
+              <a:t>https://sites.google.com/view/imagine-drl</a:t>
+            </a:r>
+            <a:endParaRPr lang="en-US" sz="1800" kern="0" dirty="0"/>
           </a:p>
           <a:p>
             <a:pPr marL="0" indent="0">
               <a:buNone/>
             </a:pPr>
-            <a:r>
-              <a:rPr lang="en-US" sz="1400" dirty="0"/>
-              <a:t>[1] - </a:t>
-            </a:r>
-            <a:r>
-              <a:rPr lang="en-US" sz="1400" dirty="0">
-                <a:hlinkClick r:id="rId3"/>
-              </a:rPr>
-              <a:t>https://unsplash.com/s/photos/children-playing</a:t>
-            </a:r>
-            <a:endParaRPr lang="en-US" sz="1400" dirty="0"/>
-          </a:p>
-          <a:p>
-            <a:pPr marL="0" indent="0">
-              <a:buNone/>
-            </a:pPr>
-            <a:r>
-              <a:rPr lang="en-US" sz="1400" dirty="0"/>
-              <a:t>[2] - By </a:t>
-            </a:r>
-            <a:r>
-              <a:rPr lang="en-US" sz="1400" dirty="0" err="1"/>
-              <a:t>Dcoetzee</a:t>
-            </a:r>
-            <a:r>
-              <a:rPr lang="en-US" sz="1400" dirty="0"/>
-              <a:t> - Own work, CC0, </a:t>
-            </a:r>
-            <a:r>
-              <a:rPr lang="en-US" sz="1400" dirty="0">
-                <a:hlinkClick r:id="rId4"/>
-              </a:rPr>
-              <a:t>https://commons.wikimedia.org/w/index.php?curid=20903046</a:t>
-            </a:r>
-            <a:endParaRPr lang="en-US" sz="1400" dirty="0"/>
-          </a:p>
-          <a:p>
-            <a:pPr marL="0" indent="0">
-              <a:buNone/>
-            </a:pPr>
-            <a:r>
-              <a:rPr lang="en-US" sz="1400" kern="0" dirty="0"/>
-              <a:t>[3] - By </a:t>
-            </a:r>
-            <a:r>
-              <a:rPr lang="en-US" sz="1400" kern="0" dirty="0" err="1"/>
-              <a:t>Tysto</a:t>
-            </a:r>
-            <a:r>
-              <a:rPr lang="en-US" sz="1400" kern="0" dirty="0"/>
-              <a:t> - Own work, Public Domain, </a:t>
-            </a:r>
-            <a:r>
-              <a:rPr lang="en-US" sz="1400" kern="0" dirty="0">
-                <a:hlinkClick r:id="rId5"/>
-              </a:rPr>
-              <a:t>https://commons.wikimedia.org/w/index.php?curid=304059</a:t>
-            </a:r>
-            <a:endParaRPr lang="en-US" sz="1400" kern="0" dirty="0"/>
-          </a:p>
-          <a:p>
-            <a:pPr marL="0" indent="0">
-              <a:buNone/>
-            </a:pPr>
-            <a:r>
-              <a:rPr lang="en-US" sz="1400" kern="0" dirty="0"/>
-              <a:t>[4] – The research paper</a:t>
-            </a:r>
-          </a:p>
-          <a:p>
-            <a:pPr marL="0" indent="0">
-              <a:buNone/>
-            </a:pPr>
-            <a:r>
-              <a:rPr lang="en-US" sz="1400" kern="0" dirty="0"/>
-              <a:t>[5] - </a:t>
-            </a:r>
-            <a:r>
-              <a:rPr lang="en-US" sz="1400" kern="0" dirty="0">
-                <a:hlinkClick r:id="rId6"/>
-              </a:rPr>
-              <a:t>https://sites.google.com/view/imagine-drl</a:t>
-            </a:r>
-            <a:endParaRPr lang="en-US" sz="1400" kern="0" dirty="0"/>
-          </a:p>
-          <a:p>
-            <a:pPr marL="0" indent="0">
-              <a:buNone/>
-            </a:pPr>
-            <a:endParaRPr lang="en-US" sz="1400" kern="0" dirty="0"/>
+            <a:endParaRPr lang="en-US" sz="1800" kern="0" dirty="0"/>
           </a:p>
         </p:txBody>
       </p:sp>

</xml_diff>